<commit_message>
Name and justify the partial fine-tuning strategy in paper and slides
- Paper: "Estrategia de fine-tuning" paragraph (last block + new head from
  ImageNet, rest frozen; between linear probing and full fine-tuning) with
  four reasons (layer transferability, overfitting risk with 8,400 images,
  compute budget, common protocol), the fraction of parameters tuned per
  model in Table II (31/75/8/30%), BatchNorm statistics adaptation, and the
  link to ResNet18 overfitting and MaxViT-T underfitting in the Discussion.
  Adds Yosinski et al. 2014.
- Slides: method step renamed to partial fine-tuning, % tuned per model,
  and speaker notes with the rationale.

Co-Authored-By: Claude Opus 5.5 <noreply@anthropic.com>
</commit_message>
<xml_diff>
--- a/slides/presentacion_final.pptx
+++ b/slides/presentacion_final.pptx
@@ -115,18 +115,18 @@
   <p:extLst>
     <p:ext uri="{521415D9-36F7-43E2-AB2F-B90AF26B5E84}">
       <p14:sectionLst xmlns:p14="http://schemas.microsoft.com/office/powerpoint/2010/main">
-        <p14:section name="Introducción" id="{1366cc85-5b96-bbff-8ddb-99d43215e03e}">
+        <p14:section name="Introducción" id="{5a4d8ada-6ccf-2f1e-5900-841f444acfea}">
           <p14:sldIdLst>
             <p14:sldId id="256"/>
             <p14:sldId id="257"/>
           </p14:sldIdLst>
         </p14:section>
-        <p14:section name="Método" id="{031233cf-87ce-6fd7-cd92-d5332f14dea6}">
+        <p14:section name="Método" id="{1359adee-85ec-a54e-7ec4-4f5a33c5a773}">
           <p14:sldIdLst>
             <p14:sldId id="258"/>
           </p14:sldIdLst>
         </p14:section>
-        <p14:section name="Resultados" id="{ed88d144-56d8-dab7-a9ea-6bbd94a93b93}">
+        <p14:section name="Resultados" id="{effbddeb-36bb-1c03-0e12-5f903d295306}">
           <p14:sldIdLst>
             <p14:sldId id="259"/>
             <p14:sldId id="260"/>
@@ -135,7 +135,7 @@
             <p14:sldId id="263"/>
           </p14:sldIdLst>
         </p14:section>
-        <p14:section name="Cierre" id="{9243abe5-4015-3a8a-8d5d-40ab8e0403a7}">
+        <p14:section name="Cierre" id="{c7667a80-389e-80ee-5579-bfabebf60ed2}">
           <p14:sldIdLst>
             <p14:sldId id="264"/>
           </p14:sldIdLst>
@@ -1644,7 +1644,7 @@
           <a:p>
             <a:r>
               <a:rPr lang="en-US" dirty="0"/>
-              <a:t>Los cuatro modelos se entrenan exactamente igual. La partición es por paciente, para que el modelo nunca se evalúe sobre un paciente que ya vio. El desbalance se trata en la evaluación: AUROC, que no depende de la prevalencia, y un umbral por clase elegido en validación. En el híbrido descongelé solo su última capa para que su capacidad entrenable sea comparable a la de los demás. Y el ensemble es simplemente el promedio de las probabilidades de los cuatro.</a:t>
+              <a:t>Los cuatro modelos se entrenan exactamente igual. La partición es por paciente, para que el modelo nunca se evalúe sobre un paciente que ya vio. El desbalance se trata en la evaluación: AUROC, que no depende de la prevalencia, y un umbral por clase elegido en validación. Hice fine-tuning parcial: parto de los pesos de ImageNet y ajusto solo el último bloque y la capa de salida. Por cuatro razones: las primeras capas aprenden rasgos genéricos como bordes y texturas que sirven igual en radiografías; con 8,400 imágenes, ajustar los 86 millones de parámetros del ViT sobreajustaría; el presupuesto de cómputo no daba para fine-tuning completo de cuatro modelos; y aplicar la misma regla a todos mantiene la comparación justa. En el híbrido descongelé solo su última capa para que su capacidad entrenable sea comparable. Y el ensemble es simplemente el promedio de las probabilidades de los cuatro.</a:t>
             </a:r>
             <a:endParaRPr lang="en-US" dirty="0"/>
           </a:p>
@@ -4095,7 +4095,7 @@
                   <a:schemeClr val="tx1"/>
                 </a:solidFill>
               </a:rPr>
-              <a:t>Entrenamiento</a:t>
+              <a:t>Fine-tuning parcial</a:t>
             </a:r>
             <a:endParaRPr lang="en-US" sz="1800" dirty="0"/>
           </a:p>
@@ -4109,7 +4109,7 @@
                   <a:schemeClr val="tx2"/>
                 </a:solidFill>
               </a:rPr>
-              <a:t>Pesos de ImageNet; solo el último bloque + capa de 14 salidas. Adam 1e-4, 5 épocas, mejor época en validación</a:t>
+              <a:t>Desde ImageNet se ajustan el último bloque + capa de 14 salidas; el resto, congelado. Adam 1e-4, 5 épocas, mejor época en validación</a:t>
             </a:r>
             <a:endParaRPr lang="en-US" sz="1800" dirty="0"/>
           </a:p>
@@ -4347,7 +4347,7 @@
                   <a:schemeClr val="tx2"/>
                 </a:solidFill>
               </a:rPr>
-              <a:t>CNN · conexiones densas (base de CheXNet) · 7.0M parám. (2.2M entrenables)</a:t>
+              <a:t>CNN · conexiones densas (base de CheXNet) · 7.0M parám., se ajusta el 31% (2.2M)</a:t>
             </a:r>
             <a:endParaRPr lang="en-US" sz="1300" dirty="0"/>
           </a:p>
@@ -4474,7 +4474,7 @@
                   <a:schemeClr val="tx2"/>
                 </a:solidFill>
               </a:rPr>
-              <a:t>CNN · conexiones residuales · 11.2M parám. (8.4M entrenables)</a:t>
+              <a:t>CNN · conexiones residuales · 11.2M parám., se ajusta el 75% (8.4M)</a:t>
             </a:r>
             <a:endParaRPr lang="en-US" sz="1300" dirty="0"/>
           </a:p>
@@ -4601,7 +4601,7 @@
                   <a:schemeClr val="tx2"/>
                 </a:solidFill>
               </a:rPr>
-              <a:t>Transformer · 12 bloques de auto-atención · 85.8M parám. (7.1M entrenables)</a:t>
+              <a:t>Transformer · 12 bloques de auto-atención · 85.8M parám., se ajusta el 8% (7.1M)</a:t>
             </a:r>
             <a:endParaRPr lang="en-US" sz="1300" dirty="0"/>
           </a:p>
@@ -4728,7 +4728,7 @@
                   <a:schemeClr val="tx2"/>
                 </a:solidFill>
               </a:rPr>
-              <a:t>Híbrido · convoluciones + atención local y global · 30.4M parám. (9.2M entrenables)</a:t>
+              <a:t>Híbrido · convoluciones + atención local y global · 30.4M parám., se ajusta el 30% (9.2M)</a:t>
             </a:r>
             <a:endParaRPr lang="en-US" sz="1300" dirty="0"/>
           </a:p>
@@ -9223,7 +9223,7 @@
                   <a:schemeClr val="accent6"/>
                 </a:solidFill>
               </a:rPr>
-              <a:t>Limitaciones: subconjunto de 12k imágenes (11%), etiquetas ruidosas, 5 épocas con backbone casi congelado, una semilla por corrida, 224 px. Trabajo futuro: las 112k imágenes y fine-tuning completo, aprendizaje auto-supervisado sobre radiografías sin etiquetar, y multimodalidad (edad, sexo, proyección y texto del reporte).</a:t>
+              <a:t>Limitaciones: subconjunto de 12k imágenes (11%), etiquetas ruidosas, 5 épocas con fine-tuning parcial, una semilla por corrida, 224 px. Trabajo futuro: las 112k imágenes y fine-tuning completo, aprendizaje auto-supervisado sobre radiografías sin etiquetar, y multimodalidad (edad, sexo, proyección y texto del reporte).</a:t>
             </a:r>
             <a:endParaRPr lang="en-US" sz="1300" dirty="0"/>
           </a:p>

</xml_diff>

<commit_message>
Integrate the full-dataset (112k) run as a complementary experiment
- Paper: new subsection "Efecto del tamaño del conjunto de datos" with a
  12k vs 112k table; abstract, contributions, data/preprocessing/training
  (256px cache, low-power mode), discussion (hybrid gains most and
  converges, ensemble robust, ResNet18 best individual by <0.01 with 112k),
  limitations, conclusions and future work updated. 9 pages.
- Slides: new slide 6 comparing 12k vs 112k; conclusions updated (10 slides).
- Guide: slide 6 script, timings within 6 min, updated answers, two new
  questions with code evidence, glossary entries; paper/HISTORIAL line
  references recomputed and verified.
- README and HISTORIAL updated (run 5, results, files, lessons).

Co-Authored-By: Claude Opus 5.5 <noreply@anthropic.com>
</commit_message>
<xml_diff>
--- a/slides/presentacion_final.pptx
+++ b/slides/presentacion_final.pptx
@@ -14,9 +14,10 @@
     <p:sldId id="262" r:id="rId8"/>
     <p:sldId id="263" r:id="rId9"/>
     <p:sldId id="264" r:id="rId10"/>
+    <p:sldId id="265" r:id="rId11"/>
   </p:sldIdLst>
   <p:notesMasterIdLst>
-    <p:notesMasterId r:id="rId11"/>
+    <p:notesMasterId r:id="rId12"/>
   </p:notesMasterIdLst>
   <p:sldSz cx="12192000" cy="6858000"/>
   <p:notesSz cx="6858000" cy="12192000"/>
@@ -115,29 +116,30 @@
   <p:extLst>
     <p:ext uri="{521415D9-36F7-43E2-AB2F-B90AF26B5E84}">
       <p14:sectionLst xmlns:p14="http://schemas.microsoft.com/office/powerpoint/2010/main">
-        <p14:section name="Introducción" id="{5a4d8ada-6ccf-2f1e-5900-841f444acfea}">
+        <p14:section name="Introducción" id="{1d38ae1e-6d0c-9004-d72c-d6b9ba5d589c}">
           <p14:sldIdLst>
             <p14:sldId id="256"/>
             <p14:sldId id="257"/>
           </p14:sldIdLst>
         </p14:section>
-        <p14:section name="Método" id="{1359adee-85ec-a54e-7ec4-4f5a33c5a773}">
+        <p14:section name="Método" id="{edef95be-7fd6-2944-bf4c-1bb662dfbf17}">
           <p14:sldIdLst>
             <p14:sldId id="258"/>
           </p14:sldIdLst>
         </p14:section>
-        <p14:section name="Resultados" id="{effbddeb-36bb-1c03-0e12-5f903d295306}">
+        <p14:section name="Resultados" id="{4c340ee9-6335-885d-2379-f9fafde95c1e}">
           <p14:sldIdLst>
             <p14:sldId id="259"/>
             <p14:sldId id="260"/>
             <p14:sldId id="261"/>
             <p14:sldId id="262"/>
             <p14:sldId id="263"/>
+            <p14:sldId id="264"/>
           </p14:sldIdLst>
         </p14:section>
-        <p14:section name="Cierre" id="{c7667a80-389e-80ee-5579-bfabebf60ed2}">
+        <p14:section name="Cierre" id="{b7c12d51-d2c9-6b79-10cc-d7726bd3bfe1}">
           <p14:sldIdLst>
-            <p14:sldId id="264"/>
+            <p14:sldId id="265"/>
           </p14:sldIdLst>
         </p14:section>
       </p14:sectionLst>
@@ -1510,6 +1512,94 @@
 </p:notes>
 </file>
 
+<file path=ppt/notesSlides/notesSlide10.xml><?xml version="1.0" encoding="utf-8"?>
+<p:notes xmlns:a="http://schemas.openxmlformats.org/drawingml/2006/main" xmlns:r="http://schemas.openxmlformats.org/officeDocument/2006/relationships" xmlns:p="http://schemas.openxmlformats.org/presentationml/2006/main">
+  <p:cSld>
+    <p:spTree>
+      <p:nvGrpSpPr>
+        <p:cNvPr id="1" name=""/>
+        <p:cNvGrpSpPr/>
+        <p:nvPr/>
+      </p:nvGrpSpPr>
+      <p:grpSpPr>
+        <a:xfrm>
+          <a:off x="0" y="0"/>
+          <a:ext cx="0" cy="0"/>
+          <a:chOff x="0" y="0"/>
+          <a:chExt cx="0" cy="0"/>
+        </a:xfrm>
+      </p:grpSpPr>
+      <p:sp>
+        <p:nvSpPr>
+          <p:cNvPr id="2" name="Slide Image Placeholder 1"/>
+          <p:cNvSpPr>
+            <a:spLocks noGrp="1" noRot="1" noChangeAspect="1"/>
+          </p:cNvSpPr>
+          <p:nvPr>
+            <p:ph type="sldImg"/>
+          </p:nvPr>
+        </p:nvSpPr>
+        <p:spPr/>
+      </p:sp>
+      <p:sp>
+        <p:nvSpPr>
+          <p:cNvPr id="3" name="Notes Placeholder 2"/>
+          <p:cNvSpPr>
+            <a:spLocks noGrp="1"/>
+          </p:cNvSpPr>
+          <p:nvPr>
+            <p:ph type="body" idx="1"/>
+          </p:nvPr>
+        </p:nvSpPr>
+        <p:spPr/>
+        <p:txBody>
+          <a:bodyPr/>
+          <a:lstStyle/>
+          <a:p>
+            <a:r>
+              <a:rPr lang="en-US" dirty="0"/>
+              <a:t>En resumen: con el mismo presupuesto, ninguna arquitectura domina; la diferencia real está en el costo, donde ResNet18 es el más eficiente. Lo que sí mejora el desempeño es combinar los modelos. Con el dataset completo todo mejora unos 0.05 y las conclusiones se sostienen; el híbrido es el que más se beneficia de tener más datos. Y metodológicamente, evaluar bien —por paciente, con umbrales en validación, intervalos de confianza y repitiendo el experimento— fue lo que evitó conclusiones engañosas. Como siguientes pasos: entrenar con todo el dataset, preentrenamiento auto-supervisado y multimodalidad. Gracias.</a:t>
+            </a:r>
+            <a:endParaRPr lang="en-US" dirty="0"/>
+          </a:p>
+        </p:txBody>
+      </p:sp>
+      <p:sp>
+        <p:nvSpPr>
+          <p:cNvPr id="4" name="Slide Number Placeholder 3"/>
+          <p:cNvSpPr>
+            <a:spLocks noGrp="1"/>
+          </p:cNvSpPr>
+          <p:nvPr>
+            <p:ph type="sldNum" sz="quarter" idx="10"/>
+          </p:nvPr>
+        </p:nvSpPr>
+        <p:spPr/>
+        <p:txBody>
+          <a:bodyPr/>
+          <a:lstStyle/>
+          <a:p>
+            <a:fld id="{F7021451-1387-4CA6-816F-3879F97B5CBC}" type="slidenum">
+              <a:rPr lang="en-US"/>
+              <a:t>10</a:t>
+            </a:fld>
+            <a:endParaRPr lang="en-US"/>
+          </a:p>
+        </p:txBody>
+      </p:sp>
+    </p:spTree>
+    <p:extLst>
+      <p:ext uri="{BB962C8B-B14F-4D97-AF65-F5344CB8AC3E}">
+        <p14:creationId xmlns:p14="http://schemas.microsoft.com/office/powerpoint/2010/main" val="1024086991"/>
+      </p:ext>
+    </p:extLst>
+  </p:cSld>
+  <p:clrMapOvr>
+    <a:masterClrMapping/>
+  </p:clrMapOvr>
+</p:notes>
+</file>
+
 <file path=ppt/notesSlides/notesSlide2.xml><?xml version="1.0" encoding="utf-8"?>
 <p:notes xmlns:a="http://schemas.openxmlformats.org/drawingml/2006/main" xmlns:r="http://schemas.openxmlformats.org/officeDocument/2006/relationships" xmlns:p="http://schemas.openxmlformats.org/presentationml/2006/main">
   <p:cSld>
@@ -1908,7 +1998,7 @@
           <a:p>
             <a:r>
               <a:rPr lang="en-US" dirty="0"/>
-              <a:t>Las diferencias entre hallazgos son mucho mayores que entre modelos. Los más fáciles son Emphysema, Edema, Effusion; los más difíciles, Pneumonia, Nodule, Infiltration: lesiones pequeñas como los nódulos o con etiquetas ambiguas como neumonía e infiltración. Todos los modelos siguen el mismo patrón, lo que sugiere que el límite está en los datos y la resolución más que en la arquitectura.</a:t>
+              <a:t>También repetí todo con el dataset completo, 112 mil imágenes. Para que la computadora no se apagara, lo corrí en modo de bajo consumo: la GPU descansa la mitad del tiempo, sin cambiar el entrenamiento. Resultado: todos mejoran unos 0.05 de AUROC, y el híbrido es el que más gana, 0.057, y ahora sí converge; le faltaban datos. El ensemble sigue siendo el mejor, con 0.813, cerca de CheXNet. Y con un conjunto de prueba nueve veces mayor, ResNet18 ya es significativamente el mejor modelo individual, aunque por menos de 0.01. Las conclusiones se sostienen.</a:t>
             </a:r>
             <a:endParaRPr lang="en-US" dirty="0"/>
           </a:p>
@@ -1996,7 +2086,7 @@
           <a:p>
             <a:r>
               <a:rPr lang="en-US" dirty="0"/>
-              <a:t>El costo es donde los modelos sí se separan. ViT-B/16 tiene 12 veces los parámetros de DenseNet121, y tanto el ViT como el híbrido son unas 13 veces más lentos que ResNet18 en inferencia, sin rendir más. Con desempeño equivalente, ResNet18 es el mejor compromiso individual; si se busca el máximo desempeño, el ensemble, pagando el costo de correr los cuatro. Nota: en ROCm no hay atención eficiente en memoria, así que los modelos con atención salen algo pesimistas.</a:t>
+              <a:t>Las diferencias entre hallazgos son mucho mayores que entre modelos. Los más fáciles son Emphysema, Edema, Effusion; los más difíciles, Pneumonia, Nodule, Infiltration: lesiones pequeñas como los nódulos o con etiquetas ambiguas como neumonía e infiltración. Todos los modelos siguen el mismo patrón, lo que sugiere que el límite está en los datos y la resolución más que en la arquitectura.</a:t>
             </a:r>
             <a:endParaRPr lang="en-US" dirty="0"/>
           </a:p>
@@ -2084,7 +2174,7 @@
           <a:p>
             <a:r>
               <a:rPr lang="en-US" dirty="0"/>
-              <a:t>En el derrame pleural, con probabilidades altas, las CNN miran la región torácica correcta. En la infiltración, con probabilidades bajas, los mapas se van a los bordes de la imagen, a la marca de texto 'PORTABLE' o fuera de los pulmones: señal de posibles atajos, un problema conocido en este dataset. Para el ViT, la atención del último bloque sí recorre los campos pulmonares, mientras que el rollout se concentra en las esquinas, un artefacto conocido. Son ejemplos cualitativos, no una medida de localización.</a:t>
+              <a:t>El costo es donde los modelos sí se separan. ViT-B/16 tiene 12 veces los parámetros de DenseNet121, y tanto el ViT como el híbrido son unas 13 veces más lentos que ResNet18 en inferencia, sin rendir más. Con desempeño equivalente, ResNet18 es el mejor compromiso individual; si se busca el máximo desempeño, el ensemble, pagando el costo de correr los cuatro. Nota: en ROCm no hay atención eficiente en memoria, así que los modelos con atención salen algo pesimistas.</a:t>
             </a:r>
             <a:endParaRPr lang="en-US" dirty="0"/>
           </a:p>
@@ -2172,7 +2262,7 @@
           <a:p>
             <a:r>
               <a:rPr lang="en-US" dirty="0"/>
-              <a:t>En resumen: con el mismo presupuesto, ninguna arquitectura domina; la diferencia real está en el costo, donde ResNet18 es el más eficiente. Lo que sí mejora el desempeño es combinar los modelos. El híbrido promete, pero necesita más entrenamiento. Y metodológicamente, evaluar bien —por paciente, con umbrales en validación, intervalos de confianza y repitiendo el experimento— fue lo que evitó conclusiones engañosas. Como siguientes pasos: entrenar con todo el dataset, preentrenamiento auto-supervisado y multimodalidad. Gracias.</a:t>
+              <a:t>En el derrame pleural, con probabilidades altas, las CNN miran la región torácica correcta. En la infiltración, con probabilidades bajas, los mapas se van a los bordes de la imagen, a la marca de texto 'PORTABLE' o fuera de los pulmones: señal de posibles atajos, un problema conocido en este dataset. Para el ViT, la atención del último bloque sí recorre los campos pulmonares, mientras que el rollout se concentra en las esquinas, un artefacto conocido. Son ejemplos cualitativos, no una medida de localización.</a:t>
             </a:r>
             <a:endParaRPr lang="en-US" dirty="0"/>
           </a:p>
@@ -3187,6 +3277,450 @@
 </p:sld>
 </file>
 
+<file path=ppt/slides/slide10.xml><?xml version="1.0" encoding="utf-8"?>
+<p:sld xmlns:a="http://schemas.openxmlformats.org/drawingml/2006/main" xmlns:r="http://schemas.openxmlformats.org/officeDocument/2006/relationships" xmlns:p="http://schemas.openxmlformats.org/presentationml/2006/main">
+  <p:cSld name="Slide 10">
+    <p:spTree>
+      <p:nvGrpSpPr>
+        <p:cNvPr id="1" name=""/>
+        <p:cNvGrpSpPr/>
+        <p:nvPr/>
+      </p:nvGrpSpPr>
+      <p:grpSpPr>
+        <a:xfrm>
+          <a:off x="0" y="0"/>
+          <a:ext cx="0" cy="0"/>
+          <a:chOff x="0" y="0"/>
+          <a:chExt cx="0" cy="0"/>
+        </a:xfrm>
+      </p:grpSpPr>
+      <p:sp>
+        <p:nvSpPr>
+          <p:cNvPr id="2" name="Text 0"/>
+          <p:cNvSpPr/>
+          <p:nvPr>
+            <p:ph idx="100" type="title" hasCustomPrompt="1"/>
+          </p:nvPr>
+        </p:nvSpPr>
+        <p:spPr>
+          <a:xfrm>
+            <a:off x="548640" y="320040"/>
+            <a:ext cx="11064240" cy="868680"/>
+          </a:xfrm>
+          <a:prstGeom prst="rect">
+            <a:avLst/>
+          </a:prstGeom>
+          <a:noFill/>
+          <a:ln/>
+        </p:spPr>
+        <p:txBody>
+          <a:bodyPr wrap="square" rtlCol="0" anchor="ctr"/>
+          <a:lstStyle/>
+          <a:p>
+            <a:pPr indent="0" marL="0">
+              <a:buNone/>
+            </a:pPr>
+            <a:r>
+              <a:rPr lang="en-US" sz="2800" b="1" dirty="0">
+                <a:solidFill>
+                  <a:schemeClr val="bg1"/>
+                </a:solidFill>
+              </a:rPr>
+              <a:t>Conclusiones</a:t>
+            </a:r>
+            <a:endParaRPr lang="en-US" sz="2800" dirty="0"/>
+          </a:p>
+        </p:txBody>
+      </p:sp>
+      <p:sp>
+        <p:nvSpPr>
+          <p:cNvPr id="3" name="Shape 1"/>
+          <p:cNvSpPr/>
+          <p:nvPr/>
+        </p:nvSpPr>
+        <p:spPr>
+          <a:xfrm>
+            <a:off x="548640" y="1399032"/>
+            <a:ext cx="274320" cy="274320"/>
+          </a:xfrm>
+          <a:prstGeom prst="ellipse">
+            <a:avLst/>
+          </a:prstGeom>
+          <a:solidFill>
+            <a:srgbClr val="2A78D6"/>
+          </a:solidFill>
+          <a:ln w="12700">
+            <a:solidFill>
+              <a:srgbClr val="2A78D6"/>
+            </a:solidFill>
+            <a:prstDash val="solid"/>
+          </a:ln>
+        </p:spPr>
+      </p:sp>
+      <p:sp>
+        <p:nvSpPr>
+          <p:cNvPr id="4" name="Text 2"/>
+          <p:cNvSpPr txBox="1"/>
+          <p:nvPr/>
+        </p:nvSpPr>
+        <p:spPr>
+          <a:xfrm>
+            <a:off x="1051560" y="1325880"/>
+            <a:ext cx="10515600" cy="914400"/>
+          </a:xfrm>
+          <a:prstGeom prst="rect">
+            <a:avLst/>
+          </a:prstGeom>
+          <a:noFill/>
+          <a:ln/>
+        </p:spPr>
+        <p:txBody>
+          <a:bodyPr wrap="square" lIns="0" tIns="0" rIns="0" bIns="0" rtlCol="0" anchor="t"/>
+          <a:lstStyle/>
+          <a:p>
+            <a:pPr indent="0" marL="0">
+              <a:buNone/>
+            </a:pPr>
+            <a:r>
+              <a:rPr lang="en-US" sz="1800" b="1" dirty="0">
+                <a:solidFill>
+                  <a:schemeClr val="bg1"/>
+                </a:solidFill>
+              </a:rPr>
+              <a:t>Desempeño</a:t>
+            </a:r>
+            <a:endParaRPr lang="en-US" sz="1800" dirty="0"/>
+          </a:p>
+          <a:p>
+            <a:pPr indent="0" marL="0">
+              <a:buNone/>
+            </a:pPr>
+            <a:r>
+              <a:rPr lang="en-US" sz="1500" dirty="0">
+                <a:solidFill>
+                  <a:schemeClr val="accent6"/>
+                </a:solidFill>
+              </a:rPr>
+              <a:t>Rinden casi igual (AUROC 0.73–0.75); con 112k todos suben ~0.05 y ResNet18 gana por &lt;0.01.</a:t>
+            </a:r>
+            <a:endParaRPr lang="en-US" sz="1800" dirty="0"/>
+          </a:p>
+        </p:txBody>
+      </p:sp>
+      <p:sp>
+        <p:nvSpPr>
+          <p:cNvPr id="5" name="Shape 3"/>
+          <p:cNvSpPr/>
+          <p:nvPr/>
+        </p:nvSpPr>
+        <p:spPr>
+          <a:xfrm>
+            <a:off x="548640" y="2423160"/>
+            <a:ext cx="274320" cy="274320"/>
+          </a:xfrm>
+          <a:prstGeom prst="ellipse">
+            <a:avLst/>
+          </a:prstGeom>
+          <a:solidFill>
+            <a:srgbClr val="6250D6"/>
+          </a:solidFill>
+          <a:ln w="12700">
+            <a:solidFill>
+              <a:srgbClr val="6250D6"/>
+            </a:solidFill>
+            <a:prstDash val="solid"/>
+          </a:ln>
+        </p:spPr>
+      </p:sp>
+      <p:sp>
+        <p:nvSpPr>
+          <p:cNvPr id="6" name="Text 4"/>
+          <p:cNvSpPr txBox="1"/>
+          <p:nvPr/>
+        </p:nvSpPr>
+        <p:spPr>
+          <a:xfrm>
+            <a:off x="1051560" y="2350008"/>
+            <a:ext cx="10515600" cy="914400"/>
+          </a:xfrm>
+          <a:prstGeom prst="rect">
+            <a:avLst/>
+          </a:prstGeom>
+          <a:noFill/>
+          <a:ln/>
+        </p:spPr>
+        <p:txBody>
+          <a:bodyPr wrap="square" lIns="0" tIns="0" rIns="0" bIns="0" rtlCol="0" anchor="t"/>
+          <a:lstStyle/>
+          <a:p>
+            <a:pPr indent="0" marL="0">
+              <a:buNone/>
+            </a:pPr>
+            <a:r>
+              <a:rPr lang="en-US" sz="1800" b="1" dirty="0">
+                <a:solidFill>
+                  <a:schemeClr val="bg1"/>
+                </a:solidFill>
+              </a:rPr>
+              <a:t>Ensemble e híbrido</a:t>
+            </a:r>
+            <a:endParaRPr lang="en-US" sz="1800" dirty="0"/>
+          </a:p>
+          <a:p>
+            <a:pPr indent="0" marL="0">
+              <a:buNone/>
+            </a:pPr>
+            <a:r>
+              <a:rPr lang="en-US" sz="1500" dirty="0">
+                <a:solidFill>
+                  <a:schemeClr val="accent6"/>
+                </a:solidFill>
+              </a:rPr>
+              <a:t>Combinar los cuatro mejora a todos (AUROC 0.767). Con 112k llega a 0.813. El híbrido es el que más gana con más datos.</a:t>
+            </a:r>
+            <a:endParaRPr lang="en-US" sz="1800" dirty="0"/>
+          </a:p>
+        </p:txBody>
+      </p:sp>
+      <p:sp>
+        <p:nvSpPr>
+          <p:cNvPr id="7" name="Shape 5"/>
+          <p:cNvSpPr/>
+          <p:nvPr/>
+        </p:nvSpPr>
+        <p:spPr>
+          <a:xfrm>
+            <a:off x="548640" y="3447288"/>
+            <a:ext cx="274320" cy="274320"/>
+          </a:xfrm>
+          <a:prstGeom prst="ellipse">
+            <a:avLst/>
+          </a:prstGeom>
+          <a:solidFill>
+            <a:srgbClr val="EB6834"/>
+          </a:solidFill>
+          <a:ln w="12700">
+            <a:solidFill>
+              <a:srgbClr val="EB6834"/>
+            </a:solidFill>
+            <a:prstDash val="solid"/>
+          </a:ln>
+        </p:spPr>
+      </p:sp>
+      <p:sp>
+        <p:nvSpPr>
+          <p:cNvPr id="8" name="Text 6"/>
+          <p:cNvSpPr txBox="1"/>
+          <p:nvPr/>
+        </p:nvSpPr>
+        <p:spPr>
+          <a:xfrm>
+            <a:off x="1051560" y="3374136"/>
+            <a:ext cx="10515600" cy="914400"/>
+          </a:xfrm>
+          <a:prstGeom prst="rect">
+            <a:avLst/>
+          </a:prstGeom>
+          <a:noFill/>
+          <a:ln/>
+        </p:spPr>
+        <p:txBody>
+          <a:bodyPr wrap="square" lIns="0" tIns="0" rIns="0" bIns="0" rtlCol="0" anchor="t"/>
+          <a:lstStyle/>
+          <a:p>
+            <a:pPr indent="0" marL="0">
+              <a:buNone/>
+            </a:pPr>
+            <a:r>
+              <a:rPr lang="en-US" sz="1800" b="1" dirty="0">
+                <a:solidFill>
+                  <a:schemeClr val="bg1"/>
+                </a:solidFill>
+              </a:rPr>
+              <a:t>Costo</a:t>
+            </a:r>
+            <a:endParaRPr lang="en-US" sz="1800" dirty="0"/>
+          </a:p>
+          <a:p>
+            <a:pPr indent="0" marL="0">
+              <a:buNone/>
+            </a:pPr>
+            <a:r>
+              <a:rPr lang="en-US" sz="1500" dirty="0">
+                <a:solidFill>
+                  <a:schemeClr val="accent6"/>
+                </a:solidFill>
+              </a:rPr>
+              <a:t>ResNet18 es el mejor compromiso individual; ViT y MaxViT son ~13× más lentos sin rendir más.</a:t>
+            </a:r>
+            <a:endParaRPr lang="en-US" sz="1800" dirty="0"/>
+          </a:p>
+        </p:txBody>
+      </p:sp>
+      <p:sp>
+        <p:nvSpPr>
+          <p:cNvPr id="9" name="Shape 7"/>
+          <p:cNvSpPr/>
+          <p:nvPr/>
+        </p:nvSpPr>
+        <p:spPr>
+          <a:xfrm>
+            <a:off x="548640" y="4471416"/>
+            <a:ext cx="274320" cy="274320"/>
+          </a:xfrm>
+          <a:prstGeom prst="ellipse">
+            <a:avLst/>
+          </a:prstGeom>
+          <a:solidFill>
+            <a:srgbClr val="1BAF7A"/>
+          </a:solidFill>
+          <a:ln w="12700">
+            <a:solidFill>
+              <a:srgbClr val="1BAF7A"/>
+            </a:solidFill>
+            <a:prstDash val="solid"/>
+          </a:ln>
+        </p:spPr>
+      </p:sp>
+      <p:sp>
+        <p:nvSpPr>
+          <p:cNvPr id="10" name="Text 8"/>
+          <p:cNvSpPr txBox="1"/>
+          <p:nvPr/>
+        </p:nvSpPr>
+        <p:spPr>
+          <a:xfrm>
+            <a:off x="1051560" y="4398264"/>
+            <a:ext cx="10515600" cy="914400"/>
+          </a:xfrm>
+          <a:prstGeom prst="rect">
+            <a:avLst/>
+          </a:prstGeom>
+          <a:noFill/>
+          <a:ln/>
+        </p:spPr>
+        <p:txBody>
+          <a:bodyPr wrap="square" lIns="0" tIns="0" rIns="0" bIns="0" rtlCol="0" anchor="t"/>
+          <a:lstStyle/>
+          <a:p>
+            <a:pPr indent="0" marL="0">
+              <a:buNone/>
+            </a:pPr>
+            <a:r>
+              <a:rPr lang="en-US" sz="1800" b="1" dirty="0">
+                <a:solidFill>
+                  <a:schemeClr val="bg1"/>
+                </a:solidFill>
+              </a:rPr>
+              <a:t>Método</a:t>
+            </a:r>
+            <a:endParaRPr lang="en-US" sz="1800" dirty="0"/>
+          </a:p>
+          <a:p>
+            <a:pPr indent="0" marL="0">
+              <a:buNone/>
+            </a:pPr>
+            <a:r>
+              <a:rPr lang="en-US" sz="1500" dirty="0">
+                <a:solidFill>
+                  <a:schemeClr val="accent6"/>
+                </a:solidFill>
+              </a:rPr>
+              <a:t>Split por paciente, umbral en validación, intervalos de confianza y repetir el experimento evitaron sobreinterpretar diferencias pequeñas.</a:t>
+            </a:r>
+            <a:endParaRPr lang="en-US" sz="1800" dirty="0"/>
+          </a:p>
+        </p:txBody>
+      </p:sp>
+      <p:sp>
+        <p:nvSpPr>
+          <p:cNvPr id="11" name="Text 9"/>
+          <p:cNvSpPr txBox="1"/>
+          <p:nvPr/>
+        </p:nvSpPr>
+        <p:spPr>
+          <a:xfrm>
+            <a:off x="548640" y="5440680"/>
+            <a:ext cx="11064240" cy="822960"/>
+          </a:xfrm>
+          <a:prstGeom prst="rect">
+            <a:avLst/>
+          </a:prstGeom>
+          <a:noFill/>
+          <a:ln/>
+        </p:spPr>
+        <p:txBody>
+          <a:bodyPr wrap="square" lIns="0" tIns="0" rIns="0" bIns="0" rtlCol="0" anchor="ctr"/>
+          <a:lstStyle/>
+          <a:p>
+            <a:pPr indent="0" marL="0">
+              <a:buNone/>
+            </a:pPr>
+            <a:r>
+              <a:rPr lang="en-US" sz="1300" i="1" dirty="0">
+                <a:solidFill>
+                  <a:schemeClr val="accent6"/>
+                </a:solidFill>
+              </a:rPr>
+              <a:t>Limitaciones: resultados principales con 12k imágenes (confirmados con 112k), etiquetas ruidosas, 5 épocas con fine-tuning parcial, una semilla por corrida, 224 px. Trabajo futuro: fine-tuning completo y más épocas, aprendizaje auto-supervisado sobre radiografías sin etiquetar, y multimodalidad (edad, sexo, proyección y texto del reporte).</a:t>
+            </a:r>
+            <a:endParaRPr lang="en-US" sz="1300" dirty="0"/>
+          </a:p>
+        </p:txBody>
+      </p:sp>
+      <p:sp>
+        <p:nvSpPr>
+          <p:cNvPr id="25" name="Slide Number Placeholder 0"/>
+          <p:cNvSpPr>
+            <a:spLocks noGrp="1"/>
+          </p:cNvSpPr>
+          <p:nvPr>
+            <p:ph type="sldNum" sz="quarter" idx="4294967295"/>
+          </p:nvPr>
+        </p:nvSpPr>
+        <p:spPr>
+          <a:xfrm>
+            <a:off x="11155680" y="6400800"/>
+            <a:ext cx="457200" cy="274320"/>
+          </a:xfrm>
+          <a:prstGeom prst="rect">
+            <a:avLst/>
+          </a:prstGeom>
+          <a:extLst>
+            <a:ext uri="{C572A759-6A51-4108-AA02-DFA0A04FC94B}">
+              <ma14:wrappingTextBoxFlag xmlns:ma14="http://schemas.microsoft.com/office/mac/drawingml/2011/main" val="0"/>
+            </a:ext>
+          </a:extLst>
+        </p:spPr>
+        <p:txBody>
+          <a:bodyPr/>
+          <a:lstStyle>
+            <a:lvl1pPr>
+              <a:defRPr sz="1000">
+                <a:solidFill>
+                  <a:srgbClr val="C9D3DD"/>
+                </a:solidFill>
+              </a:defRPr>
+            </a:lvl1pPr>
+          </a:lstStyle>
+          <a:p>
+            <a:pPr algn="r"/>
+            <a:fld id="{F7021451-1387-4CA6-816F-3879F97B5CBC}" type="slidenum">
+              <a:rPr b="0" lang="en-US"/>
+              <a:t>10</a:t>
+            </a:fld>
+            <a:endParaRPr lang="en-US"/>
+          </a:p>
+        </p:txBody>
+      </p:sp>
+    </p:spTree>
+  </p:cSld>
+  <p:clrMapOvr>
+    <a:masterClrMapping/>
+  </p:clrMapOvr>
+</p:sld>
+</file>
+
 <file path=ppt/slides/slide2.xml><?xml version="1.0" encoding="utf-8"?>
 <p:sld xmlns:a="http://schemas.openxmlformats.org/drawingml/2006/main" xmlns:r="http://schemas.openxmlformats.org/officeDocument/2006/relationships" xmlns:p="http://schemas.openxmlformats.org/presentationml/2006/main">
   <p:cSld name="Slide 2">
@@ -8120,6 +8654,2329 @@
                   <a:schemeClr val="tx1"/>
                 </a:solidFill>
               </a:rPr>
+              <a:t>Con 112k imágenes todos mejoran ~0.05</a:t>
+            </a:r>
+            <a:endParaRPr lang="en-US" sz="2800" dirty="0"/>
+          </a:p>
+        </p:txBody>
+      </p:sp>
+      <p:graphicFrame>
+        <p:nvGraphicFramePr>
+          <p:cNvPr id="7" name="tabla-112k"/>
+          <p:cNvGraphicFramePr>
+            <a:graphicFrameLocks noGrp="1"/>
+          </p:cNvGraphicFramePr>
+          <p:nvPr>
+            <p:extLst>
+              <p:ext uri="{D42A27DB-BD31-4B8C-83A1-F6EECF244321}">
+                <p14:modId xmlns:p14="http://schemas.microsoft.com/office/powerpoint/2010/main" val="1579011935"/>
+              </p:ext>
+            </p:extLst>
+          </p:nvPr>
+        </p:nvGraphicFramePr>
+        <p:xfrm>
+          <a:off x="548640" y="1325880"/>
+          <a:ext cx="11064240" cy="914400"/>
+        </p:xfrm>
+        <a:graphic>
+          <a:graphicData uri="http://schemas.openxmlformats.org/drawingml/2006/table">
+            <a:tbl>
+              <a:tblPr/>
+              <a:tblGrid>
+                <a:gridCol w="2286000"/>
+                <a:gridCol w="1737360"/>
+                <a:gridCol w="3291840"/>
+                <a:gridCol w="1737360"/>
+                <a:gridCol w="2011680"/>
+              </a:tblGrid>
+              <a:tr h="438912">
+                <a:tc>
+                  <a:txBody>
+                    <a:bodyPr/>
+                    <a:lstStyle/>
+                    <a:p>
+                      <a:pPr algn="ctr" indent="0" marL="0">
+                        <a:buNone/>
+                      </a:pPr>
+                      <a:r>
+                        <a:rPr lang="en-US" sz="1500" b="1" dirty="0">
+                          <a:solidFill>
+                            <a:srgbClr val="FFFFFF"/>
+                          </a:solidFill>
+                        </a:rPr>
+                        <a:t>Modelo</a:t>
+                      </a:r>
+                      <a:endParaRPr lang="en-US" sz="1500" dirty="0"/>
+                    </a:p>
+                  </a:txBody>
+                  <a:tcPr marL="91440" marR="91440" marT="45720" marB="45720" anchor="ctr">
+                    <a:lnL w="12700" cap="flat" cmpd="sng" algn="ctr">
+                      <a:solidFill>
+                        <a:srgbClr val="C9D3DD"/>
+                      </a:solidFill>
+                      <a:prstDash val="solid"/>
+                      <a:round/>
+                      <a:headEnd type="none" w="med" len="med"/>
+                      <a:tailEnd type="none" w="med" len="med"/>
+                    </a:lnL>
+                    <a:lnR w="12700" cap="flat" cmpd="sng" algn="ctr">
+                      <a:solidFill>
+                        <a:srgbClr val="C9D3DD"/>
+                      </a:solidFill>
+                      <a:prstDash val="solid"/>
+                      <a:round/>
+                      <a:headEnd type="none" w="med" len="med"/>
+                      <a:tailEnd type="none" w="med" len="med"/>
+                    </a:lnR>
+                    <a:lnT w="12700" cap="flat" cmpd="sng" algn="ctr">
+                      <a:solidFill>
+                        <a:srgbClr val="C9D3DD"/>
+                      </a:solidFill>
+                      <a:prstDash val="solid"/>
+                      <a:round/>
+                      <a:headEnd type="none" w="med" len="med"/>
+                      <a:tailEnd type="none" w="med" len="med"/>
+                    </a:lnT>
+                    <a:lnB w="12700" cap="flat" cmpd="sng" algn="ctr">
+                      <a:solidFill>
+                        <a:srgbClr val="C9D3DD"/>
+                      </a:solidFill>
+                      <a:prstDash val="solid"/>
+                      <a:round/>
+                      <a:headEnd type="none" w="med" len="med"/>
+                      <a:tailEnd type="none" w="med" len="med"/>
+                    </a:lnB>
+                    <a:solidFill>
+                      <a:srgbClr val="1B2430"/>
+                    </a:solidFill>
+                  </a:tcPr>
+                </a:tc>
+                <a:tc>
+                  <a:txBody>
+                    <a:bodyPr/>
+                    <a:lstStyle/>
+                    <a:p>
+                      <a:pPr algn="ctr" indent="0" marL="0">
+                        <a:buNone/>
+                      </a:pPr>
+                      <a:r>
+                        <a:rPr lang="en-US" sz="1500" b="1" dirty="0">
+                          <a:solidFill>
+                            <a:srgbClr val="FFFFFF"/>
+                          </a:solidFill>
+                        </a:rPr>
+                        <a:t>AUROC 12k</a:t>
+                      </a:r>
+                      <a:endParaRPr lang="en-US" sz="1500" dirty="0"/>
+                    </a:p>
+                  </a:txBody>
+                  <a:tcPr marL="91440" marR="91440" marT="45720" marB="45720" anchor="ctr">
+                    <a:lnL w="12700" cap="flat" cmpd="sng" algn="ctr">
+                      <a:solidFill>
+                        <a:srgbClr val="C9D3DD"/>
+                      </a:solidFill>
+                      <a:prstDash val="solid"/>
+                      <a:round/>
+                      <a:headEnd type="none" w="med" len="med"/>
+                      <a:tailEnd type="none" w="med" len="med"/>
+                    </a:lnL>
+                    <a:lnR w="12700" cap="flat" cmpd="sng" algn="ctr">
+                      <a:solidFill>
+                        <a:srgbClr val="C9D3DD"/>
+                      </a:solidFill>
+                      <a:prstDash val="solid"/>
+                      <a:round/>
+                      <a:headEnd type="none" w="med" len="med"/>
+                      <a:tailEnd type="none" w="med" len="med"/>
+                    </a:lnR>
+                    <a:lnT w="12700" cap="flat" cmpd="sng" algn="ctr">
+                      <a:solidFill>
+                        <a:srgbClr val="C9D3DD"/>
+                      </a:solidFill>
+                      <a:prstDash val="solid"/>
+                      <a:round/>
+                      <a:headEnd type="none" w="med" len="med"/>
+                      <a:tailEnd type="none" w="med" len="med"/>
+                    </a:lnT>
+                    <a:lnB w="12700" cap="flat" cmpd="sng" algn="ctr">
+                      <a:solidFill>
+                        <a:srgbClr val="C9D3DD"/>
+                      </a:solidFill>
+                      <a:prstDash val="solid"/>
+                      <a:round/>
+                      <a:headEnd type="none" w="med" len="med"/>
+                      <a:tailEnd type="none" w="med" len="med"/>
+                    </a:lnB>
+                    <a:solidFill>
+                      <a:srgbClr val="1B2430"/>
+                    </a:solidFill>
+                  </a:tcPr>
+                </a:tc>
+                <a:tc>
+                  <a:txBody>
+                    <a:bodyPr/>
+                    <a:lstStyle/>
+                    <a:p>
+                      <a:pPr algn="ctr" indent="0" marL="0">
+                        <a:buNone/>
+                      </a:pPr>
+                      <a:r>
+                        <a:rPr lang="en-US" sz="1500" b="1" dirty="0">
+                          <a:solidFill>
+                            <a:srgbClr val="FFFFFF"/>
+                          </a:solidFill>
+                        </a:rPr>
+                        <a:t>AUROC 112k [IC 95%]</a:t>
+                      </a:r>
+                      <a:endParaRPr lang="en-US" sz="1500" dirty="0"/>
+                    </a:p>
+                  </a:txBody>
+                  <a:tcPr marL="91440" marR="91440" marT="45720" marB="45720" anchor="ctr">
+                    <a:lnL w="12700" cap="flat" cmpd="sng" algn="ctr">
+                      <a:solidFill>
+                        <a:srgbClr val="C9D3DD"/>
+                      </a:solidFill>
+                      <a:prstDash val="solid"/>
+                      <a:round/>
+                      <a:headEnd type="none" w="med" len="med"/>
+                      <a:tailEnd type="none" w="med" len="med"/>
+                    </a:lnL>
+                    <a:lnR w="12700" cap="flat" cmpd="sng" algn="ctr">
+                      <a:solidFill>
+                        <a:srgbClr val="C9D3DD"/>
+                      </a:solidFill>
+                      <a:prstDash val="solid"/>
+                      <a:round/>
+                      <a:headEnd type="none" w="med" len="med"/>
+                      <a:tailEnd type="none" w="med" len="med"/>
+                    </a:lnR>
+                    <a:lnT w="12700" cap="flat" cmpd="sng" algn="ctr">
+                      <a:solidFill>
+                        <a:srgbClr val="C9D3DD"/>
+                      </a:solidFill>
+                      <a:prstDash val="solid"/>
+                      <a:round/>
+                      <a:headEnd type="none" w="med" len="med"/>
+                      <a:tailEnd type="none" w="med" len="med"/>
+                    </a:lnT>
+                    <a:lnB w="12700" cap="flat" cmpd="sng" algn="ctr">
+                      <a:solidFill>
+                        <a:srgbClr val="C9D3DD"/>
+                      </a:solidFill>
+                      <a:prstDash val="solid"/>
+                      <a:round/>
+                      <a:headEnd type="none" w="med" len="med"/>
+                      <a:tailEnd type="none" w="med" len="med"/>
+                    </a:lnB>
+                    <a:solidFill>
+                      <a:srgbClr val="1B2430"/>
+                    </a:solidFill>
+                  </a:tcPr>
+                </a:tc>
+                <a:tc>
+                  <a:txBody>
+                    <a:bodyPr/>
+                    <a:lstStyle/>
+                    <a:p>
+                      <a:pPr algn="ctr" indent="0" marL="0">
+                        <a:buNone/>
+                      </a:pPr>
+                      <a:r>
+                        <a:rPr lang="en-US" sz="1500" b="1" dirty="0">
+                          <a:solidFill>
+                            <a:srgbClr val="FFFFFF"/>
+                          </a:solidFill>
+                        </a:rPr>
+                        <a:t>Cambio</a:t>
+                      </a:r>
+                      <a:endParaRPr lang="en-US" sz="1500" dirty="0"/>
+                    </a:p>
+                  </a:txBody>
+                  <a:tcPr marL="91440" marR="91440" marT="45720" marB="45720" anchor="ctr">
+                    <a:lnL w="12700" cap="flat" cmpd="sng" algn="ctr">
+                      <a:solidFill>
+                        <a:srgbClr val="C9D3DD"/>
+                      </a:solidFill>
+                      <a:prstDash val="solid"/>
+                      <a:round/>
+                      <a:headEnd type="none" w="med" len="med"/>
+                      <a:tailEnd type="none" w="med" len="med"/>
+                    </a:lnL>
+                    <a:lnR w="12700" cap="flat" cmpd="sng" algn="ctr">
+                      <a:solidFill>
+                        <a:srgbClr val="C9D3DD"/>
+                      </a:solidFill>
+                      <a:prstDash val="solid"/>
+                      <a:round/>
+                      <a:headEnd type="none" w="med" len="med"/>
+                      <a:tailEnd type="none" w="med" len="med"/>
+                    </a:lnR>
+                    <a:lnT w="12700" cap="flat" cmpd="sng" algn="ctr">
+                      <a:solidFill>
+                        <a:srgbClr val="C9D3DD"/>
+                      </a:solidFill>
+                      <a:prstDash val="solid"/>
+                      <a:round/>
+                      <a:headEnd type="none" w="med" len="med"/>
+                      <a:tailEnd type="none" w="med" len="med"/>
+                    </a:lnT>
+                    <a:lnB w="12700" cap="flat" cmpd="sng" algn="ctr">
+                      <a:solidFill>
+                        <a:srgbClr val="C9D3DD"/>
+                      </a:solidFill>
+                      <a:prstDash val="solid"/>
+                      <a:round/>
+                      <a:headEnd type="none" w="med" len="med"/>
+                      <a:tailEnd type="none" w="med" len="med"/>
+                    </a:lnB>
+                    <a:solidFill>
+                      <a:srgbClr val="1B2430"/>
+                    </a:solidFill>
+                  </a:tcPr>
+                </a:tc>
+                <a:tc>
+                  <a:txBody>
+                    <a:bodyPr/>
+                    <a:lstStyle/>
+                    <a:p>
+                      <a:pPr algn="ctr" indent="0" marL="0">
+                        <a:buNone/>
+                      </a:pPr>
+                      <a:r>
+                        <a:rPr lang="en-US" sz="1500" b="1" dirty="0">
+                          <a:solidFill>
+                            <a:srgbClr val="FFFFFF"/>
+                          </a:solidFill>
+                        </a:rPr>
+                        <a:t>Mejor época</a:t>
+                      </a:r>
+                      <a:endParaRPr lang="en-US" sz="1500" dirty="0"/>
+                    </a:p>
+                  </a:txBody>
+                  <a:tcPr marL="91440" marR="91440" marT="45720" marB="45720" anchor="ctr">
+                    <a:lnL w="12700" cap="flat" cmpd="sng" algn="ctr">
+                      <a:solidFill>
+                        <a:srgbClr val="C9D3DD"/>
+                      </a:solidFill>
+                      <a:prstDash val="solid"/>
+                      <a:round/>
+                      <a:headEnd type="none" w="med" len="med"/>
+                      <a:tailEnd type="none" w="med" len="med"/>
+                    </a:lnL>
+                    <a:lnR w="12700" cap="flat" cmpd="sng" algn="ctr">
+                      <a:solidFill>
+                        <a:srgbClr val="C9D3DD"/>
+                      </a:solidFill>
+                      <a:prstDash val="solid"/>
+                      <a:round/>
+                      <a:headEnd type="none" w="med" len="med"/>
+                      <a:tailEnd type="none" w="med" len="med"/>
+                    </a:lnR>
+                    <a:lnT w="12700" cap="flat" cmpd="sng" algn="ctr">
+                      <a:solidFill>
+                        <a:srgbClr val="C9D3DD"/>
+                      </a:solidFill>
+                      <a:prstDash val="solid"/>
+                      <a:round/>
+                      <a:headEnd type="none" w="med" len="med"/>
+                      <a:tailEnd type="none" w="med" len="med"/>
+                    </a:lnT>
+                    <a:lnB w="12700" cap="flat" cmpd="sng" algn="ctr">
+                      <a:solidFill>
+                        <a:srgbClr val="C9D3DD"/>
+                      </a:solidFill>
+                      <a:prstDash val="solid"/>
+                      <a:round/>
+                      <a:headEnd type="none" w="med" len="med"/>
+                      <a:tailEnd type="none" w="med" len="med"/>
+                    </a:lnB>
+                    <a:solidFill>
+                      <a:srgbClr val="1B2430"/>
+                    </a:solidFill>
+                  </a:tcPr>
+                </a:tc>
+              </a:tr>
+              <a:tr h="438912">
+                <a:tc>
+                  <a:txBody>
+                    <a:bodyPr/>
+                    <a:lstStyle/>
+                    <a:p>
+                      <a:pPr indent="0" marL="0">
+                        <a:buNone/>
+                      </a:pPr>
+                      <a:r>
+                        <a:rPr lang="en-US" sz="1500" dirty="0">
+                          <a:solidFill>
+                            <a:srgbClr val="2A78D6"/>
+                          </a:solidFill>
+                        </a:rPr>
+                        <a:t>●  </a:t>
+                      </a:r>
+                      <a:pPr indent="0" marL="0">
+                        <a:buNone/>
+                      </a:pPr>
+                      <a:r>
+                        <a:rPr lang="en-US" sz="1500" b="1" dirty="0">
+                          <a:solidFill>
+                            <a:srgbClr val="1B2430"/>
+                          </a:solidFill>
+                        </a:rPr>
+                        <a:t>DenseNet121</a:t>
+                      </a:r>
+                      <a:endParaRPr lang="en-US" sz="1500" dirty="0"/>
+                    </a:p>
+                  </a:txBody>
+                  <a:tcPr marL="91440" marR="91440" marT="45720" marB="45720" anchor="ctr">
+                    <a:lnL w="12700" cap="flat" cmpd="sng" algn="ctr">
+                      <a:solidFill>
+                        <a:srgbClr val="C9D3DD"/>
+                      </a:solidFill>
+                      <a:prstDash val="solid"/>
+                      <a:round/>
+                      <a:headEnd type="none" w="med" len="med"/>
+                      <a:tailEnd type="none" w="med" len="med"/>
+                    </a:lnL>
+                    <a:lnR w="12700" cap="flat" cmpd="sng" algn="ctr">
+                      <a:solidFill>
+                        <a:srgbClr val="C9D3DD"/>
+                      </a:solidFill>
+                      <a:prstDash val="solid"/>
+                      <a:round/>
+                      <a:headEnd type="none" w="med" len="med"/>
+                      <a:tailEnd type="none" w="med" len="med"/>
+                    </a:lnR>
+                    <a:lnT w="12700" cap="flat" cmpd="sng" algn="ctr">
+                      <a:solidFill>
+                        <a:srgbClr val="C9D3DD"/>
+                      </a:solidFill>
+                      <a:prstDash val="solid"/>
+                      <a:round/>
+                      <a:headEnd type="none" w="med" len="med"/>
+                      <a:tailEnd type="none" w="med" len="med"/>
+                    </a:lnT>
+                    <a:lnB w="12700" cap="flat" cmpd="sng" algn="ctr">
+                      <a:solidFill>
+                        <a:srgbClr val="C9D3DD"/>
+                      </a:solidFill>
+                      <a:prstDash val="solid"/>
+                      <a:round/>
+                      <a:headEnd type="none" w="med" len="med"/>
+                      <a:tailEnd type="none" w="med" len="med"/>
+                    </a:lnB>
+                    <a:solidFill>
+                      <a:srgbClr val="FFFFFF"/>
+                    </a:solidFill>
+                  </a:tcPr>
+                </a:tc>
+                <a:tc>
+                  <a:txBody>
+                    <a:bodyPr/>
+                    <a:lstStyle/>
+                    <a:p>
+                      <a:pPr algn="ctr" indent="0" marL="0">
+                        <a:buNone/>
+                      </a:pPr>
+                      <a:r>
+                        <a:rPr lang="en-US" sz="1500" dirty="0">
+                          <a:solidFill>
+                            <a:srgbClr val="1B2430"/>
+                          </a:solidFill>
+                        </a:rPr>
+                        <a:t>0.745</a:t>
+                      </a:r>
+                      <a:endParaRPr lang="en-US" sz="1500" dirty="0"/>
+                    </a:p>
+                  </a:txBody>
+                  <a:tcPr marL="91440" marR="91440" marT="45720" marB="45720" anchor="ctr">
+                    <a:lnL w="12700" cap="flat" cmpd="sng" algn="ctr">
+                      <a:solidFill>
+                        <a:srgbClr val="C9D3DD"/>
+                      </a:solidFill>
+                      <a:prstDash val="solid"/>
+                      <a:round/>
+                      <a:headEnd type="none" w="med" len="med"/>
+                      <a:tailEnd type="none" w="med" len="med"/>
+                    </a:lnL>
+                    <a:lnR w="12700" cap="flat" cmpd="sng" algn="ctr">
+                      <a:solidFill>
+                        <a:srgbClr val="C9D3DD"/>
+                      </a:solidFill>
+                      <a:prstDash val="solid"/>
+                      <a:round/>
+                      <a:headEnd type="none" w="med" len="med"/>
+                      <a:tailEnd type="none" w="med" len="med"/>
+                    </a:lnR>
+                    <a:lnT w="12700" cap="flat" cmpd="sng" algn="ctr">
+                      <a:solidFill>
+                        <a:srgbClr val="C9D3DD"/>
+                      </a:solidFill>
+                      <a:prstDash val="solid"/>
+                      <a:round/>
+                      <a:headEnd type="none" w="med" len="med"/>
+                      <a:tailEnd type="none" w="med" len="med"/>
+                    </a:lnT>
+                    <a:lnB w="12700" cap="flat" cmpd="sng" algn="ctr">
+                      <a:solidFill>
+                        <a:srgbClr val="C9D3DD"/>
+                      </a:solidFill>
+                      <a:prstDash val="solid"/>
+                      <a:round/>
+                      <a:headEnd type="none" w="med" len="med"/>
+                      <a:tailEnd type="none" w="med" len="med"/>
+                    </a:lnB>
+                    <a:solidFill>
+                      <a:srgbClr val="FFFFFF"/>
+                    </a:solidFill>
+                  </a:tcPr>
+                </a:tc>
+                <a:tc>
+                  <a:txBody>
+                    <a:bodyPr/>
+                    <a:lstStyle/>
+                    <a:p>
+                      <a:pPr algn="ctr" indent="0" marL="0">
+                        <a:buNone/>
+                      </a:pPr>
+                      <a:r>
+                        <a:rPr lang="en-US" sz="1500" dirty="0">
+                          <a:solidFill>
+                            <a:srgbClr val="1B2430"/>
+                          </a:solidFill>
+                        </a:rPr>
+                        <a:t>0.792  [0.785, 0.799]</a:t>
+                      </a:r>
+                      <a:endParaRPr lang="en-US" sz="1500" dirty="0"/>
+                    </a:p>
+                  </a:txBody>
+                  <a:tcPr marL="91440" marR="91440" marT="45720" marB="45720" anchor="ctr">
+                    <a:lnL w="12700" cap="flat" cmpd="sng" algn="ctr">
+                      <a:solidFill>
+                        <a:srgbClr val="C9D3DD"/>
+                      </a:solidFill>
+                      <a:prstDash val="solid"/>
+                      <a:round/>
+                      <a:headEnd type="none" w="med" len="med"/>
+                      <a:tailEnd type="none" w="med" len="med"/>
+                    </a:lnL>
+                    <a:lnR w="12700" cap="flat" cmpd="sng" algn="ctr">
+                      <a:solidFill>
+                        <a:srgbClr val="C9D3DD"/>
+                      </a:solidFill>
+                      <a:prstDash val="solid"/>
+                      <a:round/>
+                      <a:headEnd type="none" w="med" len="med"/>
+                      <a:tailEnd type="none" w="med" len="med"/>
+                    </a:lnR>
+                    <a:lnT w="12700" cap="flat" cmpd="sng" algn="ctr">
+                      <a:solidFill>
+                        <a:srgbClr val="C9D3DD"/>
+                      </a:solidFill>
+                      <a:prstDash val="solid"/>
+                      <a:round/>
+                      <a:headEnd type="none" w="med" len="med"/>
+                      <a:tailEnd type="none" w="med" len="med"/>
+                    </a:lnT>
+                    <a:lnB w="12700" cap="flat" cmpd="sng" algn="ctr">
+                      <a:solidFill>
+                        <a:srgbClr val="C9D3DD"/>
+                      </a:solidFill>
+                      <a:prstDash val="solid"/>
+                      <a:round/>
+                      <a:headEnd type="none" w="med" len="med"/>
+                      <a:tailEnd type="none" w="med" len="med"/>
+                    </a:lnB>
+                    <a:solidFill>
+                      <a:srgbClr val="FFFFFF"/>
+                    </a:solidFill>
+                  </a:tcPr>
+                </a:tc>
+                <a:tc>
+                  <a:txBody>
+                    <a:bodyPr/>
+                    <a:lstStyle/>
+                    <a:p>
+                      <a:pPr algn="ctr" indent="0" marL="0">
+                        <a:buNone/>
+                      </a:pPr>
+                      <a:r>
+                        <a:rPr lang="en-US" sz="1500" dirty="0">
+                          <a:solidFill>
+                            <a:srgbClr val="1B2430"/>
+                          </a:solidFill>
+                        </a:rPr>
+                        <a:t>+0.046</a:t>
+                      </a:r>
+                      <a:endParaRPr lang="en-US" sz="1500" dirty="0"/>
+                    </a:p>
+                  </a:txBody>
+                  <a:tcPr marL="91440" marR="91440" marT="45720" marB="45720" anchor="ctr">
+                    <a:lnL w="12700" cap="flat" cmpd="sng" algn="ctr">
+                      <a:solidFill>
+                        <a:srgbClr val="C9D3DD"/>
+                      </a:solidFill>
+                      <a:prstDash val="solid"/>
+                      <a:round/>
+                      <a:headEnd type="none" w="med" len="med"/>
+                      <a:tailEnd type="none" w="med" len="med"/>
+                    </a:lnL>
+                    <a:lnR w="12700" cap="flat" cmpd="sng" algn="ctr">
+                      <a:solidFill>
+                        <a:srgbClr val="C9D3DD"/>
+                      </a:solidFill>
+                      <a:prstDash val="solid"/>
+                      <a:round/>
+                      <a:headEnd type="none" w="med" len="med"/>
+                      <a:tailEnd type="none" w="med" len="med"/>
+                    </a:lnR>
+                    <a:lnT w="12700" cap="flat" cmpd="sng" algn="ctr">
+                      <a:solidFill>
+                        <a:srgbClr val="C9D3DD"/>
+                      </a:solidFill>
+                      <a:prstDash val="solid"/>
+                      <a:round/>
+                      <a:headEnd type="none" w="med" len="med"/>
+                      <a:tailEnd type="none" w="med" len="med"/>
+                    </a:lnT>
+                    <a:lnB w="12700" cap="flat" cmpd="sng" algn="ctr">
+                      <a:solidFill>
+                        <a:srgbClr val="C9D3DD"/>
+                      </a:solidFill>
+                      <a:prstDash val="solid"/>
+                      <a:round/>
+                      <a:headEnd type="none" w="med" len="med"/>
+                      <a:tailEnd type="none" w="med" len="med"/>
+                    </a:lnB>
+                    <a:solidFill>
+                      <a:srgbClr val="FFFFFF"/>
+                    </a:solidFill>
+                  </a:tcPr>
+                </a:tc>
+                <a:tc>
+                  <a:txBody>
+                    <a:bodyPr/>
+                    <a:lstStyle/>
+                    <a:p>
+                      <a:pPr algn="ctr" indent="0" marL="0">
+                        <a:buNone/>
+                      </a:pPr>
+                      <a:r>
+                        <a:rPr lang="en-US" sz="1500" dirty="0">
+                          <a:solidFill>
+                            <a:srgbClr val="1B2430"/>
+                          </a:solidFill>
+                        </a:rPr>
+                        <a:t>3 → 2</a:t>
+                      </a:r>
+                      <a:endParaRPr lang="en-US" sz="1500" dirty="0"/>
+                    </a:p>
+                  </a:txBody>
+                  <a:tcPr marL="91440" marR="91440" marT="45720" marB="45720" anchor="ctr">
+                    <a:lnL w="12700" cap="flat" cmpd="sng" algn="ctr">
+                      <a:solidFill>
+                        <a:srgbClr val="C9D3DD"/>
+                      </a:solidFill>
+                      <a:prstDash val="solid"/>
+                      <a:round/>
+                      <a:headEnd type="none" w="med" len="med"/>
+                      <a:tailEnd type="none" w="med" len="med"/>
+                    </a:lnL>
+                    <a:lnR w="12700" cap="flat" cmpd="sng" algn="ctr">
+                      <a:solidFill>
+                        <a:srgbClr val="C9D3DD"/>
+                      </a:solidFill>
+                      <a:prstDash val="solid"/>
+                      <a:round/>
+                      <a:headEnd type="none" w="med" len="med"/>
+                      <a:tailEnd type="none" w="med" len="med"/>
+                    </a:lnR>
+                    <a:lnT w="12700" cap="flat" cmpd="sng" algn="ctr">
+                      <a:solidFill>
+                        <a:srgbClr val="C9D3DD"/>
+                      </a:solidFill>
+                      <a:prstDash val="solid"/>
+                      <a:round/>
+                      <a:headEnd type="none" w="med" len="med"/>
+                      <a:tailEnd type="none" w="med" len="med"/>
+                    </a:lnT>
+                    <a:lnB w="12700" cap="flat" cmpd="sng" algn="ctr">
+                      <a:solidFill>
+                        <a:srgbClr val="C9D3DD"/>
+                      </a:solidFill>
+                      <a:prstDash val="solid"/>
+                      <a:round/>
+                      <a:headEnd type="none" w="med" len="med"/>
+                      <a:tailEnd type="none" w="med" len="med"/>
+                    </a:lnB>
+                    <a:solidFill>
+                      <a:srgbClr val="FFFFFF"/>
+                    </a:solidFill>
+                  </a:tcPr>
+                </a:tc>
+              </a:tr>
+              <a:tr h="438912">
+                <a:tc>
+                  <a:txBody>
+                    <a:bodyPr/>
+                    <a:lstStyle/>
+                    <a:p>
+                      <a:pPr indent="0" marL="0">
+                        <a:buNone/>
+                      </a:pPr>
+                      <a:r>
+                        <a:rPr lang="en-US" sz="1500" dirty="0">
+                          <a:solidFill>
+                            <a:srgbClr val="EB6834"/>
+                          </a:solidFill>
+                        </a:rPr>
+                        <a:t>●  </a:t>
+                      </a:r>
+                      <a:pPr indent="0" marL="0">
+                        <a:buNone/>
+                      </a:pPr>
+                      <a:r>
+                        <a:rPr lang="en-US" sz="1500" b="1" dirty="0">
+                          <a:solidFill>
+                            <a:srgbClr val="1B2430"/>
+                          </a:solidFill>
+                        </a:rPr>
+                        <a:t>ResNet18</a:t>
+                      </a:r>
+                      <a:endParaRPr lang="en-US" sz="1500" dirty="0"/>
+                    </a:p>
+                  </a:txBody>
+                  <a:tcPr marL="91440" marR="91440" marT="45720" marB="45720" anchor="ctr">
+                    <a:lnL w="12700" cap="flat" cmpd="sng" algn="ctr">
+                      <a:solidFill>
+                        <a:srgbClr val="C9D3DD"/>
+                      </a:solidFill>
+                      <a:prstDash val="solid"/>
+                      <a:round/>
+                      <a:headEnd type="none" w="med" len="med"/>
+                      <a:tailEnd type="none" w="med" len="med"/>
+                    </a:lnL>
+                    <a:lnR w="12700" cap="flat" cmpd="sng" algn="ctr">
+                      <a:solidFill>
+                        <a:srgbClr val="C9D3DD"/>
+                      </a:solidFill>
+                      <a:prstDash val="solid"/>
+                      <a:round/>
+                      <a:headEnd type="none" w="med" len="med"/>
+                      <a:tailEnd type="none" w="med" len="med"/>
+                    </a:lnR>
+                    <a:lnT w="12700" cap="flat" cmpd="sng" algn="ctr">
+                      <a:solidFill>
+                        <a:srgbClr val="C9D3DD"/>
+                      </a:solidFill>
+                      <a:prstDash val="solid"/>
+                      <a:round/>
+                      <a:headEnd type="none" w="med" len="med"/>
+                      <a:tailEnd type="none" w="med" len="med"/>
+                    </a:lnT>
+                    <a:lnB w="12700" cap="flat" cmpd="sng" algn="ctr">
+                      <a:solidFill>
+                        <a:srgbClr val="C9D3DD"/>
+                      </a:solidFill>
+                      <a:prstDash val="solid"/>
+                      <a:round/>
+                      <a:headEnd type="none" w="med" len="med"/>
+                      <a:tailEnd type="none" w="med" len="med"/>
+                    </a:lnB>
+                    <a:solidFill>
+                      <a:srgbClr val="FFFFFF"/>
+                    </a:solidFill>
+                  </a:tcPr>
+                </a:tc>
+                <a:tc>
+                  <a:txBody>
+                    <a:bodyPr/>
+                    <a:lstStyle/>
+                    <a:p>
+                      <a:pPr algn="ctr" indent="0" marL="0">
+                        <a:buNone/>
+                      </a:pPr>
+                      <a:r>
+                        <a:rPr lang="en-US" sz="1500" dirty="0">
+                          <a:solidFill>
+                            <a:srgbClr val="1B2430"/>
+                          </a:solidFill>
+                        </a:rPr>
+                        <a:t>0.749</a:t>
+                      </a:r>
+                      <a:endParaRPr lang="en-US" sz="1500" dirty="0"/>
+                    </a:p>
+                  </a:txBody>
+                  <a:tcPr marL="91440" marR="91440" marT="45720" marB="45720" anchor="ctr">
+                    <a:lnL w="12700" cap="flat" cmpd="sng" algn="ctr">
+                      <a:solidFill>
+                        <a:srgbClr val="C9D3DD"/>
+                      </a:solidFill>
+                      <a:prstDash val="solid"/>
+                      <a:round/>
+                      <a:headEnd type="none" w="med" len="med"/>
+                      <a:tailEnd type="none" w="med" len="med"/>
+                    </a:lnL>
+                    <a:lnR w="12700" cap="flat" cmpd="sng" algn="ctr">
+                      <a:solidFill>
+                        <a:srgbClr val="C9D3DD"/>
+                      </a:solidFill>
+                      <a:prstDash val="solid"/>
+                      <a:round/>
+                      <a:headEnd type="none" w="med" len="med"/>
+                      <a:tailEnd type="none" w="med" len="med"/>
+                    </a:lnR>
+                    <a:lnT w="12700" cap="flat" cmpd="sng" algn="ctr">
+                      <a:solidFill>
+                        <a:srgbClr val="C9D3DD"/>
+                      </a:solidFill>
+                      <a:prstDash val="solid"/>
+                      <a:round/>
+                      <a:headEnd type="none" w="med" len="med"/>
+                      <a:tailEnd type="none" w="med" len="med"/>
+                    </a:lnT>
+                    <a:lnB w="12700" cap="flat" cmpd="sng" algn="ctr">
+                      <a:solidFill>
+                        <a:srgbClr val="C9D3DD"/>
+                      </a:solidFill>
+                      <a:prstDash val="solid"/>
+                      <a:round/>
+                      <a:headEnd type="none" w="med" len="med"/>
+                      <a:tailEnd type="none" w="med" len="med"/>
+                    </a:lnB>
+                    <a:solidFill>
+                      <a:srgbClr val="FFFFFF"/>
+                    </a:solidFill>
+                  </a:tcPr>
+                </a:tc>
+                <a:tc>
+                  <a:txBody>
+                    <a:bodyPr/>
+                    <a:lstStyle/>
+                    <a:p>
+                      <a:pPr algn="ctr" indent="0" marL="0">
+                        <a:buNone/>
+                      </a:pPr>
+                      <a:r>
+                        <a:rPr lang="en-US" sz="1500" b="1" dirty="0">
+                          <a:solidFill>
+                            <a:srgbClr val="1B2430"/>
+                          </a:solidFill>
+                        </a:rPr>
+                        <a:t>0.799  [0.792, 0.806]</a:t>
+                      </a:r>
+                      <a:endParaRPr lang="en-US" sz="1500" dirty="0"/>
+                    </a:p>
+                  </a:txBody>
+                  <a:tcPr marL="91440" marR="91440" marT="45720" marB="45720" anchor="ctr">
+                    <a:lnL w="12700" cap="flat" cmpd="sng" algn="ctr">
+                      <a:solidFill>
+                        <a:srgbClr val="C9D3DD"/>
+                      </a:solidFill>
+                      <a:prstDash val="solid"/>
+                      <a:round/>
+                      <a:headEnd type="none" w="med" len="med"/>
+                      <a:tailEnd type="none" w="med" len="med"/>
+                    </a:lnL>
+                    <a:lnR w="12700" cap="flat" cmpd="sng" algn="ctr">
+                      <a:solidFill>
+                        <a:srgbClr val="C9D3DD"/>
+                      </a:solidFill>
+                      <a:prstDash val="solid"/>
+                      <a:round/>
+                      <a:headEnd type="none" w="med" len="med"/>
+                      <a:tailEnd type="none" w="med" len="med"/>
+                    </a:lnR>
+                    <a:lnT w="12700" cap="flat" cmpd="sng" algn="ctr">
+                      <a:solidFill>
+                        <a:srgbClr val="C9D3DD"/>
+                      </a:solidFill>
+                      <a:prstDash val="solid"/>
+                      <a:round/>
+                      <a:headEnd type="none" w="med" len="med"/>
+                      <a:tailEnd type="none" w="med" len="med"/>
+                    </a:lnT>
+                    <a:lnB w="12700" cap="flat" cmpd="sng" algn="ctr">
+                      <a:solidFill>
+                        <a:srgbClr val="C9D3DD"/>
+                      </a:solidFill>
+                      <a:prstDash val="solid"/>
+                      <a:round/>
+                      <a:headEnd type="none" w="med" len="med"/>
+                      <a:tailEnd type="none" w="med" len="med"/>
+                    </a:lnB>
+                    <a:solidFill>
+                      <a:srgbClr val="FFFFFF"/>
+                    </a:solidFill>
+                  </a:tcPr>
+                </a:tc>
+                <a:tc>
+                  <a:txBody>
+                    <a:bodyPr/>
+                    <a:lstStyle/>
+                    <a:p>
+                      <a:pPr algn="ctr" indent="0" marL="0">
+                        <a:buNone/>
+                      </a:pPr>
+                      <a:r>
+                        <a:rPr lang="en-US" sz="1500" dirty="0">
+                          <a:solidFill>
+                            <a:srgbClr val="1B2430"/>
+                          </a:solidFill>
+                        </a:rPr>
+                        <a:t>+0.050</a:t>
+                      </a:r>
+                      <a:endParaRPr lang="en-US" sz="1500" dirty="0"/>
+                    </a:p>
+                  </a:txBody>
+                  <a:tcPr marL="91440" marR="91440" marT="45720" marB="45720" anchor="ctr">
+                    <a:lnL w="12700" cap="flat" cmpd="sng" algn="ctr">
+                      <a:solidFill>
+                        <a:srgbClr val="C9D3DD"/>
+                      </a:solidFill>
+                      <a:prstDash val="solid"/>
+                      <a:round/>
+                      <a:headEnd type="none" w="med" len="med"/>
+                      <a:tailEnd type="none" w="med" len="med"/>
+                    </a:lnL>
+                    <a:lnR w="12700" cap="flat" cmpd="sng" algn="ctr">
+                      <a:solidFill>
+                        <a:srgbClr val="C9D3DD"/>
+                      </a:solidFill>
+                      <a:prstDash val="solid"/>
+                      <a:round/>
+                      <a:headEnd type="none" w="med" len="med"/>
+                      <a:tailEnd type="none" w="med" len="med"/>
+                    </a:lnR>
+                    <a:lnT w="12700" cap="flat" cmpd="sng" algn="ctr">
+                      <a:solidFill>
+                        <a:srgbClr val="C9D3DD"/>
+                      </a:solidFill>
+                      <a:prstDash val="solid"/>
+                      <a:round/>
+                      <a:headEnd type="none" w="med" len="med"/>
+                      <a:tailEnd type="none" w="med" len="med"/>
+                    </a:lnT>
+                    <a:lnB w="12700" cap="flat" cmpd="sng" algn="ctr">
+                      <a:solidFill>
+                        <a:srgbClr val="C9D3DD"/>
+                      </a:solidFill>
+                      <a:prstDash val="solid"/>
+                      <a:round/>
+                      <a:headEnd type="none" w="med" len="med"/>
+                      <a:tailEnd type="none" w="med" len="med"/>
+                    </a:lnB>
+                    <a:solidFill>
+                      <a:srgbClr val="FFFFFF"/>
+                    </a:solidFill>
+                  </a:tcPr>
+                </a:tc>
+                <a:tc>
+                  <a:txBody>
+                    <a:bodyPr/>
+                    <a:lstStyle/>
+                    <a:p>
+                      <a:pPr algn="ctr" indent="0" marL="0">
+                        <a:buNone/>
+                      </a:pPr>
+                      <a:r>
+                        <a:rPr lang="en-US" sz="1500" dirty="0">
+                          <a:solidFill>
+                            <a:srgbClr val="1B2430"/>
+                          </a:solidFill>
+                        </a:rPr>
+                        <a:t>2 → 2</a:t>
+                      </a:r>
+                      <a:endParaRPr lang="en-US" sz="1500" dirty="0"/>
+                    </a:p>
+                  </a:txBody>
+                  <a:tcPr marL="91440" marR="91440" marT="45720" marB="45720" anchor="ctr">
+                    <a:lnL w="12700" cap="flat" cmpd="sng" algn="ctr">
+                      <a:solidFill>
+                        <a:srgbClr val="C9D3DD"/>
+                      </a:solidFill>
+                      <a:prstDash val="solid"/>
+                      <a:round/>
+                      <a:headEnd type="none" w="med" len="med"/>
+                      <a:tailEnd type="none" w="med" len="med"/>
+                    </a:lnL>
+                    <a:lnR w="12700" cap="flat" cmpd="sng" algn="ctr">
+                      <a:solidFill>
+                        <a:srgbClr val="C9D3DD"/>
+                      </a:solidFill>
+                      <a:prstDash val="solid"/>
+                      <a:round/>
+                      <a:headEnd type="none" w="med" len="med"/>
+                      <a:tailEnd type="none" w="med" len="med"/>
+                    </a:lnR>
+                    <a:lnT w="12700" cap="flat" cmpd="sng" algn="ctr">
+                      <a:solidFill>
+                        <a:srgbClr val="C9D3DD"/>
+                      </a:solidFill>
+                      <a:prstDash val="solid"/>
+                      <a:round/>
+                      <a:headEnd type="none" w="med" len="med"/>
+                      <a:tailEnd type="none" w="med" len="med"/>
+                    </a:lnT>
+                    <a:lnB w="12700" cap="flat" cmpd="sng" algn="ctr">
+                      <a:solidFill>
+                        <a:srgbClr val="C9D3DD"/>
+                      </a:solidFill>
+                      <a:prstDash val="solid"/>
+                      <a:round/>
+                      <a:headEnd type="none" w="med" len="med"/>
+                      <a:tailEnd type="none" w="med" len="med"/>
+                    </a:lnB>
+                    <a:solidFill>
+                      <a:srgbClr val="FFFFFF"/>
+                    </a:solidFill>
+                  </a:tcPr>
+                </a:tc>
+              </a:tr>
+              <a:tr h="438912">
+                <a:tc>
+                  <a:txBody>
+                    <a:bodyPr/>
+                    <a:lstStyle/>
+                    <a:p>
+                      <a:pPr indent="0" marL="0">
+                        <a:buNone/>
+                      </a:pPr>
+                      <a:r>
+                        <a:rPr lang="en-US" sz="1500" dirty="0">
+                          <a:solidFill>
+                            <a:srgbClr val="1BAF7A"/>
+                          </a:solidFill>
+                        </a:rPr>
+                        <a:t>●  </a:t>
+                      </a:r>
+                      <a:pPr indent="0" marL="0">
+                        <a:buNone/>
+                      </a:pPr>
+                      <a:r>
+                        <a:rPr lang="en-US" sz="1500" b="1" dirty="0">
+                          <a:solidFill>
+                            <a:srgbClr val="1B2430"/>
+                          </a:solidFill>
+                        </a:rPr>
+                        <a:t>ViT-B/16</a:t>
+                      </a:r>
+                      <a:endParaRPr lang="en-US" sz="1500" dirty="0"/>
+                    </a:p>
+                  </a:txBody>
+                  <a:tcPr marL="91440" marR="91440" marT="45720" marB="45720" anchor="ctr">
+                    <a:lnL w="12700" cap="flat" cmpd="sng" algn="ctr">
+                      <a:solidFill>
+                        <a:srgbClr val="C9D3DD"/>
+                      </a:solidFill>
+                      <a:prstDash val="solid"/>
+                      <a:round/>
+                      <a:headEnd type="none" w="med" len="med"/>
+                      <a:tailEnd type="none" w="med" len="med"/>
+                    </a:lnL>
+                    <a:lnR w="12700" cap="flat" cmpd="sng" algn="ctr">
+                      <a:solidFill>
+                        <a:srgbClr val="C9D3DD"/>
+                      </a:solidFill>
+                      <a:prstDash val="solid"/>
+                      <a:round/>
+                      <a:headEnd type="none" w="med" len="med"/>
+                      <a:tailEnd type="none" w="med" len="med"/>
+                    </a:lnR>
+                    <a:lnT w="12700" cap="flat" cmpd="sng" algn="ctr">
+                      <a:solidFill>
+                        <a:srgbClr val="C9D3DD"/>
+                      </a:solidFill>
+                      <a:prstDash val="solid"/>
+                      <a:round/>
+                      <a:headEnd type="none" w="med" len="med"/>
+                      <a:tailEnd type="none" w="med" len="med"/>
+                    </a:lnT>
+                    <a:lnB w="12700" cap="flat" cmpd="sng" algn="ctr">
+                      <a:solidFill>
+                        <a:srgbClr val="C9D3DD"/>
+                      </a:solidFill>
+                      <a:prstDash val="solid"/>
+                      <a:round/>
+                      <a:headEnd type="none" w="med" len="med"/>
+                      <a:tailEnd type="none" w="med" len="med"/>
+                    </a:lnB>
+                    <a:solidFill>
+                      <a:srgbClr val="FFFFFF"/>
+                    </a:solidFill>
+                  </a:tcPr>
+                </a:tc>
+                <a:tc>
+                  <a:txBody>
+                    <a:bodyPr/>
+                    <a:lstStyle/>
+                    <a:p>
+                      <a:pPr algn="ctr" indent="0" marL="0">
+                        <a:buNone/>
+                      </a:pPr>
+                      <a:r>
+                        <a:rPr lang="en-US" sz="1500" dirty="0">
+                          <a:solidFill>
+                            <a:srgbClr val="1B2430"/>
+                          </a:solidFill>
+                        </a:rPr>
+                        <a:t>0.742</a:t>
+                      </a:r>
+                      <a:endParaRPr lang="en-US" sz="1500" dirty="0"/>
+                    </a:p>
+                  </a:txBody>
+                  <a:tcPr marL="91440" marR="91440" marT="45720" marB="45720" anchor="ctr">
+                    <a:lnL w="12700" cap="flat" cmpd="sng" algn="ctr">
+                      <a:solidFill>
+                        <a:srgbClr val="C9D3DD"/>
+                      </a:solidFill>
+                      <a:prstDash val="solid"/>
+                      <a:round/>
+                      <a:headEnd type="none" w="med" len="med"/>
+                      <a:tailEnd type="none" w="med" len="med"/>
+                    </a:lnL>
+                    <a:lnR w="12700" cap="flat" cmpd="sng" algn="ctr">
+                      <a:solidFill>
+                        <a:srgbClr val="C9D3DD"/>
+                      </a:solidFill>
+                      <a:prstDash val="solid"/>
+                      <a:round/>
+                      <a:headEnd type="none" w="med" len="med"/>
+                      <a:tailEnd type="none" w="med" len="med"/>
+                    </a:lnR>
+                    <a:lnT w="12700" cap="flat" cmpd="sng" algn="ctr">
+                      <a:solidFill>
+                        <a:srgbClr val="C9D3DD"/>
+                      </a:solidFill>
+                      <a:prstDash val="solid"/>
+                      <a:round/>
+                      <a:headEnd type="none" w="med" len="med"/>
+                      <a:tailEnd type="none" w="med" len="med"/>
+                    </a:lnT>
+                    <a:lnB w="12700" cap="flat" cmpd="sng" algn="ctr">
+                      <a:solidFill>
+                        <a:srgbClr val="C9D3DD"/>
+                      </a:solidFill>
+                      <a:prstDash val="solid"/>
+                      <a:round/>
+                      <a:headEnd type="none" w="med" len="med"/>
+                      <a:tailEnd type="none" w="med" len="med"/>
+                    </a:lnB>
+                    <a:solidFill>
+                      <a:srgbClr val="FFFFFF"/>
+                    </a:solidFill>
+                  </a:tcPr>
+                </a:tc>
+                <a:tc>
+                  <a:txBody>
+                    <a:bodyPr/>
+                    <a:lstStyle/>
+                    <a:p>
+                      <a:pPr algn="ctr" indent="0" marL="0">
+                        <a:buNone/>
+                      </a:pPr>
+                      <a:r>
+                        <a:rPr lang="en-US" sz="1500" dirty="0">
+                          <a:solidFill>
+                            <a:srgbClr val="1B2430"/>
+                          </a:solidFill>
+                        </a:rPr>
+                        <a:t>0.793  [0.787, 0.799]</a:t>
+                      </a:r>
+                      <a:endParaRPr lang="en-US" sz="1500" dirty="0"/>
+                    </a:p>
+                  </a:txBody>
+                  <a:tcPr marL="91440" marR="91440" marT="45720" marB="45720" anchor="ctr">
+                    <a:lnL w="12700" cap="flat" cmpd="sng" algn="ctr">
+                      <a:solidFill>
+                        <a:srgbClr val="C9D3DD"/>
+                      </a:solidFill>
+                      <a:prstDash val="solid"/>
+                      <a:round/>
+                      <a:headEnd type="none" w="med" len="med"/>
+                      <a:tailEnd type="none" w="med" len="med"/>
+                    </a:lnL>
+                    <a:lnR w="12700" cap="flat" cmpd="sng" algn="ctr">
+                      <a:solidFill>
+                        <a:srgbClr val="C9D3DD"/>
+                      </a:solidFill>
+                      <a:prstDash val="solid"/>
+                      <a:round/>
+                      <a:headEnd type="none" w="med" len="med"/>
+                      <a:tailEnd type="none" w="med" len="med"/>
+                    </a:lnR>
+                    <a:lnT w="12700" cap="flat" cmpd="sng" algn="ctr">
+                      <a:solidFill>
+                        <a:srgbClr val="C9D3DD"/>
+                      </a:solidFill>
+                      <a:prstDash val="solid"/>
+                      <a:round/>
+                      <a:headEnd type="none" w="med" len="med"/>
+                      <a:tailEnd type="none" w="med" len="med"/>
+                    </a:lnT>
+                    <a:lnB w="12700" cap="flat" cmpd="sng" algn="ctr">
+                      <a:solidFill>
+                        <a:srgbClr val="C9D3DD"/>
+                      </a:solidFill>
+                      <a:prstDash val="solid"/>
+                      <a:round/>
+                      <a:headEnd type="none" w="med" len="med"/>
+                      <a:tailEnd type="none" w="med" len="med"/>
+                    </a:lnB>
+                    <a:solidFill>
+                      <a:srgbClr val="FFFFFF"/>
+                    </a:solidFill>
+                  </a:tcPr>
+                </a:tc>
+                <a:tc>
+                  <a:txBody>
+                    <a:bodyPr/>
+                    <a:lstStyle/>
+                    <a:p>
+                      <a:pPr algn="ctr" indent="0" marL="0">
+                        <a:buNone/>
+                      </a:pPr>
+                      <a:r>
+                        <a:rPr lang="en-US" sz="1500" dirty="0">
+                          <a:solidFill>
+                            <a:srgbClr val="1B2430"/>
+                          </a:solidFill>
+                        </a:rPr>
+                        <a:t>+0.051</a:t>
+                      </a:r>
+                      <a:endParaRPr lang="en-US" sz="1500" dirty="0"/>
+                    </a:p>
+                  </a:txBody>
+                  <a:tcPr marL="91440" marR="91440" marT="45720" marB="45720" anchor="ctr">
+                    <a:lnL w="12700" cap="flat" cmpd="sng" algn="ctr">
+                      <a:solidFill>
+                        <a:srgbClr val="C9D3DD"/>
+                      </a:solidFill>
+                      <a:prstDash val="solid"/>
+                      <a:round/>
+                      <a:headEnd type="none" w="med" len="med"/>
+                      <a:tailEnd type="none" w="med" len="med"/>
+                    </a:lnL>
+                    <a:lnR w="12700" cap="flat" cmpd="sng" algn="ctr">
+                      <a:solidFill>
+                        <a:srgbClr val="C9D3DD"/>
+                      </a:solidFill>
+                      <a:prstDash val="solid"/>
+                      <a:round/>
+                      <a:headEnd type="none" w="med" len="med"/>
+                      <a:tailEnd type="none" w="med" len="med"/>
+                    </a:lnR>
+                    <a:lnT w="12700" cap="flat" cmpd="sng" algn="ctr">
+                      <a:solidFill>
+                        <a:srgbClr val="C9D3DD"/>
+                      </a:solidFill>
+                      <a:prstDash val="solid"/>
+                      <a:round/>
+                      <a:headEnd type="none" w="med" len="med"/>
+                      <a:tailEnd type="none" w="med" len="med"/>
+                    </a:lnT>
+                    <a:lnB w="12700" cap="flat" cmpd="sng" algn="ctr">
+                      <a:solidFill>
+                        <a:srgbClr val="C9D3DD"/>
+                      </a:solidFill>
+                      <a:prstDash val="solid"/>
+                      <a:round/>
+                      <a:headEnd type="none" w="med" len="med"/>
+                      <a:tailEnd type="none" w="med" len="med"/>
+                    </a:lnB>
+                    <a:solidFill>
+                      <a:srgbClr val="FFFFFF"/>
+                    </a:solidFill>
+                  </a:tcPr>
+                </a:tc>
+                <a:tc>
+                  <a:txBody>
+                    <a:bodyPr/>
+                    <a:lstStyle/>
+                    <a:p>
+                      <a:pPr algn="ctr" indent="0" marL="0">
+                        <a:buNone/>
+                      </a:pPr>
+                      <a:r>
+                        <a:rPr lang="en-US" sz="1500" dirty="0">
+                          <a:solidFill>
+                            <a:srgbClr val="1B2430"/>
+                          </a:solidFill>
+                        </a:rPr>
+                        <a:t>3 → 2</a:t>
+                      </a:r>
+                      <a:endParaRPr lang="en-US" sz="1500" dirty="0"/>
+                    </a:p>
+                  </a:txBody>
+                  <a:tcPr marL="91440" marR="91440" marT="45720" marB="45720" anchor="ctr">
+                    <a:lnL w="12700" cap="flat" cmpd="sng" algn="ctr">
+                      <a:solidFill>
+                        <a:srgbClr val="C9D3DD"/>
+                      </a:solidFill>
+                      <a:prstDash val="solid"/>
+                      <a:round/>
+                      <a:headEnd type="none" w="med" len="med"/>
+                      <a:tailEnd type="none" w="med" len="med"/>
+                    </a:lnL>
+                    <a:lnR w="12700" cap="flat" cmpd="sng" algn="ctr">
+                      <a:solidFill>
+                        <a:srgbClr val="C9D3DD"/>
+                      </a:solidFill>
+                      <a:prstDash val="solid"/>
+                      <a:round/>
+                      <a:headEnd type="none" w="med" len="med"/>
+                      <a:tailEnd type="none" w="med" len="med"/>
+                    </a:lnR>
+                    <a:lnT w="12700" cap="flat" cmpd="sng" algn="ctr">
+                      <a:solidFill>
+                        <a:srgbClr val="C9D3DD"/>
+                      </a:solidFill>
+                      <a:prstDash val="solid"/>
+                      <a:round/>
+                      <a:headEnd type="none" w="med" len="med"/>
+                      <a:tailEnd type="none" w="med" len="med"/>
+                    </a:lnT>
+                    <a:lnB w="12700" cap="flat" cmpd="sng" algn="ctr">
+                      <a:solidFill>
+                        <a:srgbClr val="C9D3DD"/>
+                      </a:solidFill>
+                      <a:prstDash val="solid"/>
+                      <a:round/>
+                      <a:headEnd type="none" w="med" len="med"/>
+                      <a:tailEnd type="none" w="med" len="med"/>
+                    </a:lnB>
+                    <a:solidFill>
+                      <a:srgbClr val="FFFFFF"/>
+                    </a:solidFill>
+                  </a:tcPr>
+                </a:tc>
+              </a:tr>
+              <a:tr h="438912">
+                <a:tc>
+                  <a:txBody>
+                    <a:bodyPr/>
+                    <a:lstStyle/>
+                    <a:p>
+                      <a:pPr indent="0" marL="0">
+                        <a:buNone/>
+                      </a:pPr>
+                      <a:r>
+                        <a:rPr lang="en-US" sz="1500" dirty="0">
+                          <a:solidFill>
+                            <a:srgbClr val="EDA100"/>
+                          </a:solidFill>
+                        </a:rPr>
+                        <a:t>●  </a:t>
+                      </a:r>
+                      <a:pPr indent="0" marL="0">
+                        <a:buNone/>
+                      </a:pPr>
+                      <a:r>
+                        <a:rPr lang="en-US" sz="1500" b="1" dirty="0">
+                          <a:solidFill>
+                            <a:srgbClr val="1B2430"/>
+                          </a:solidFill>
+                        </a:rPr>
+                        <a:t>MaxViT-T</a:t>
+                      </a:r>
+                      <a:endParaRPr lang="en-US" sz="1500" dirty="0"/>
+                    </a:p>
+                  </a:txBody>
+                  <a:tcPr marL="91440" marR="91440" marT="45720" marB="45720" anchor="ctr">
+                    <a:lnL w="12700" cap="flat" cmpd="sng" algn="ctr">
+                      <a:solidFill>
+                        <a:srgbClr val="C9D3DD"/>
+                      </a:solidFill>
+                      <a:prstDash val="solid"/>
+                      <a:round/>
+                      <a:headEnd type="none" w="med" len="med"/>
+                      <a:tailEnd type="none" w="med" len="med"/>
+                    </a:lnL>
+                    <a:lnR w="12700" cap="flat" cmpd="sng" algn="ctr">
+                      <a:solidFill>
+                        <a:srgbClr val="C9D3DD"/>
+                      </a:solidFill>
+                      <a:prstDash val="solid"/>
+                      <a:round/>
+                      <a:headEnd type="none" w="med" len="med"/>
+                      <a:tailEnd type="none" w="med" len="med"/>
+                    </a:lnR>
+                    <a:lnT w="12700" cap="flat" cmpd="sng" algn="ctr">
+                      <a:solidFill>
+                        <a:srgbClr val="C9D3DD"/>
+                      </a:solidFill>
+                      <a:prstDash val="solid"/>
+                      <a:round/>
+                      <a:headEnd type="none" w="med" len="med"/>
+                      <a:tailEnd type="none" w="med" len="med"/>
+                    </a:lnT>
+                    <a:lnB w="12700" cap="flat" cmpd="sng" algn="ctr">
+                      <a:solidFill>
+                        <a:srgbClr val="C9D3DD"/>
+                      </a:solidFill>
+                      <a:prstDash val="solid"/>
+                      <a:round/>
+                      <a:headEnd type="none" w="med" len="med"/>
+                      <a:tailEnd type="none" w="med" len="med"/>
+                    </a:lnB>
+                    <a:solidFill>
+                      <a:srgbClr val="FFFFFF"/>
+                    </a:solidFill>
+                  </a:tcPr>
+                </a:tc>
+                <a:tc>
+                  <a:txBody>
+                    <a:bodyPr/>
+                    <a:lstStyle/>
+                    <a:p>
+                      <a:pPr algn="ctr" indent="0" marL="0">
+                        <a:buNone/>
+                      </a:pPr>
+                      <a:r>
+                        <a:rPr lang="en-US" sz="1500" dirty="0">
+                          <a:solidFill>
+                            <a:srgbClr val="1B2430"/>
+                          </a:solidFill>
+                        </a:rPr>
+                        <a:t>0.733</a:t>
+                      </a:r>
+                      <a:endParaRPr lang="en-US" sz="1500" dirty="0"/>
+                    </a:p>
+                  </a:txBody>
+                  <a:tcPr marL="91440" marR="91440" marT="45720" marB="45720" anchor="ctr">
+                    <a:lnL w="12700" cap="flat" cmpd="sng" algn="ctr">
+                      <a:solidFill>
+                        <a:srgbClr val="C9D3DD"/>
+                      </a:solidFill>
+                      <a:prstDash val="solid"/>
+                      <a:round/>
+                      <a:headEnd type="none" w="med" len="med"/>
+                      <a:tailEnd type="none" w="med" len="med"/>
+                    </a:lnL>
+                    <a:lnR w="12700" cap="flat" cmpd="sng" algn="ctr">
+                      <a:solidFill>
+                        <a:srgbClr val="C9D3DD"/>
+                      </a:solidFill>
+                      <a:prstDash val="solid"/>
+                      <a:round/>
+                      <a:headEnd type="none" w="med" len="med"/>
+                      <a:tailEnd type="none" w="med" len="med"/>
+                    </a:lnR>
+                    <a:lnT w="12700" cap="flat" cmpd="sng" algn="ctr">
+                      <a:solidFill>
+                        <a:srgbClr val="C9D3DD"/>
+                      </a:solidFill>
+                      <a:prstDash val="solid"/>
+                      <a:round/>
+                      <a:headEnd type="none" w="med" len="med"/>
+                      <a:tailEnd type="none" w="med" len="med"/>
+                    </a:lnT>
+                    <a:lnB w="12700" cap="flat" cmpd="sng" algn="ctr">
+                      <a:solidFill>
+                        <a:srgbClr val="C9D3DD"/>
+                      </a:solidFill>
+                      <a:prstDash val="solid"/>
+                      <a:round/>
+                      <a:headEnd type="none" w="med" len="med"/>
+                      <a:tailEnd type="none" w="med" len="med"/>
+                    </a:lnB>
+                    <a:solidFill>
+                      <a:srgbClr val="FFFFFF"/>
+                    </a:solidFill>
+                  </a:tcPr>
+                </a:tc>
+                <a:tc>
+                  <a:txBody>
+                    <a:bodyPr/>
+                    <a:lstStyle/>
+                    <a:p>
+                      <a:pPr algn="ctr" indent="0" marL="0">
+                        <a:buNone/>
+                      </a:pPr>
+                      <a:r>
+                        <a:rPr lang="en-US" sz="1500" dirty="0">
+                          <a:solidFill>
+                            <a:srgbClr val="1B2430"/>
+                          </a:solidFill>
+                        </a:rPr>
+                        <a:t>0.790  [0.783, 0.797]</a:t>
+                      </a:r>
+                      <a:endParaRPr lang="en-US" sz="1500" dirty="0"/>
+                    </a:p>
+                  </a:txBody>
+                  <a:tcPr marL="91440" marR="91440" marT="45720" marB="45720" anchor="ctr">
+                    <a:lnL w="12700" cap="flat" cmpd="sng" algn="ctr">
+                      <a:solidFill>
+                        <a:srgbClr val="C9D3DD"/>
+                      </a:solidFill>
+                      <a:prstDash val="solid"/>
+                      <a:round/>
+                      <a:headEnd type="none" w="med" len="med"/>
+                      <a:tailEnd type="none" w="med" len="med"/>
+                    </a:lnL>
+                    <a:lnR w="12700" cap="flat" cmpd="sng" algn="ctr">
+                      <a:solidFill>
+                        <a:srgbClr val="C9D3DD"/>
+                      </a:solidFill>
+                      <a:prstDash val="solid"/>
+                      <a:round/>
+                      <a:headEnd type="none" w="med" len="med"/>
+                      <a:tailEnd type="none" w="med" len="med"/>
+                    </a:lnR>
+                    <a:lnT w="12700" cap="flat" cmpd="sng" algn="ctr">
+                      <a:solidFill>
+                        <a:srgbClr val="C9D3DD"/>
+                      </a:solidFill>
+                      <a:prstDash val="solid"/>
+                      <a:round/>
+                      <a:headEnd type="none" w="med" len="med"/>
+                      <a:tailEnd type="none" w="med" len="med"/>
+                    </a:lnT>
+                    <a:lnB w="12700" cap="flat" cmpd="sng" algn="ctr">
+                      <a:solidFill>
+                        <a:srgbClr val="C9D3DD"/>
+                      </a:solidFill>
+                      <a:prstDash val="solid"/>
+                      <a:round/>
+                      <a:headEnd type="none" w="med" len="med"/>
+                      <a:tailEnd type="none" w="med" len="med"/>
+                    </a:lnB>
+                    <a:solidFill>
+                      <a:srgbClr val="FFFFFF"/>
+                    </a:solidFill>
+                  </a:tcPr>
+                </a:tc>
+                <a:tc>
+                  <a:txBody>
+                    <a:bodyPr/>
+                    <a:lstStyle/>
+                    <a:p>
+                      <a:pPr algn="ctr" indent="0" marL="0">
+                        <a:buNone/>
+                      </a:pPr>
+                      <a:r>
+                        <a:rPr lang="en-US" sz="1500" b="1" dirty="0">
+                          <a:solidFill>
+                            <a:srgbClr val="1B2430"/>
+                          </a:solidFill>
+                        </a:rPr>
+                        <a:t>+0.057</a:t>
+                      </a:r>
+                      <a:endParaRPr lang="en-US" sz="1500" dirty="0"/>
+                    </a:p>
+                  </a:txBody>
+                  <a:tcPr marL="91440" marR="91440" marT="45720" marB="45720" anchor="ctr">
+                    <a:lnL w="12700" cap="flat" cmpd="sng" algn="ctr">
+                      <a:solidFill>
+                        <a:srgbClr val="C9D3DD"/>
+                      </a:solidFill>
+                      <a:prstDash val="solid"/>
+                      <a:round/>
+                      <a:headEnd type="none" w="med" len="med"/>
+                      <a:tailEnd type="none" w="med" len="med"/>
+                    </a:lnL>
+                    <a:lnR w="12700" cap="flat" cmpd="sng" algn="ctr">
+                      <a:solidFill>
+                        <a:srgbClr val="C9D3DD"/>
+                      </a:solidFill>
+                      <a:prstDash val="solid"/>
+                      <a:round/>
+                      <a:headEnd type="none" w="med" len="med"/>
+                      <a:tailEnd type="none" w="med" len="med"/>
+                    </a:lnR>
+                    <a:lnT w="12700" cap="flat" cmpd="sng" algn="ctr">
+                      <a:solidFill>
+                        <a:srgbClr val="C9D3DD"/>
+                      </a:solidFill>
+                      <a:prstDash val="solid"/>
+                      <a:round/>
+                      <a:headEnd type="none" w="med" len="med"/>
+                      <a:tailEnd type="none" w="med" len="med"/>
+                    </a:lnT>
+                    <a:lnB w="12700" cap="flat" cmpd="sng" algn="ctr">
+                      <a:solidFill>
+                        <a:srgbClr val="C9D3DD"/>
+                      </a:solidFill>
+                      <a:prstDash val="solid"/>
+                      <a:round/>
+                      <a:headEnd type="none" w="med" len="med"/>
+                      <a:tailEnd type="none" w="med" len="med"/>
+                    </a:lnB>
+                    <a:solidFill>
+                      <a:srgbClr val="FFFFFF"/>
+                    </a:solidFill>
+                  </a:tcPr>
+                </a:tc>
+                <a:tc>
+                  <a:txBody>
+                    <a:bodyPr/>
+                    <a:lstStyle/>
+                    <a:p>
+                      <a:pPr algn="ctr" indent="0" marL="0">
+                        <a:buNone/>
+                      </a:pPr>
+                      <a:r>
+                        <a:rPr lang="en-US" sz="1500" dirty="0">
+                          <a:solidFill>
+                            <a:srgbClr val="1B2430"/>
+                          </a:solidFill>
+                        </a:rPr>
+                        <a:t>5 → 4</a:t>
+                      </a:r>
+                      <a:endParaRPr lang="en-US" sz="1500" dirty="0"/>
+                    </a:p>
+                  </a:txBody>
+                  <a:tcPr marL="91440" marR="91440" marT="45720" marB="45720" anchor="ctr">
+                    <a:lnL w="12700" cap="flat" cmpd="sng" algn="ctr">
+                      <a:solidFill>
+                        <a:srgbClr val="C9D3DD"/>
+                      </a:solidFill>
+                      <a:prstDash val="solid"/>
+                      <a:round/>
+                      <a:headEnd type="none" w="med" len="med"/>
+                      <a:tailEnd type="none" w="med" len="med"/>
+                    </a:lnL>
+                    <a:lnR w="12700" cap="flat" cmpd="sng" algn="ctr">
+                      <a:solidFill>
+                        <a:srgbClr val="C9D3DD"/>
+                      </a:solidFill>
+                      <a:prstDash val="solid"/>
+                      <a:round/>
+                      <a:headEnd type="none" w="med" len="med"/>
+                      <a:tailEnd type="none" w="med" len="med"/>
+                    </a:lnR>
+                    <a:lnT w="12700" cap="flat" cmpd="sng" algn="ctr">
+                      <a:solidFill>
+                        <a:srgbClr val="C9D3DD"/>
+                      </a:solidFill>
+                      <a:prstDash val="solid"/>
+                      <a:round/>
+                      <a:headEnd type="none" w="med" len="med"/>
+                      <a:tailEnd type="none" w="med" len="med"/>
+                    </a:lnT>
+                    <a:lnB w="12700" cap="flat" cmpd="sng" algn="ctr">
+                      <a:solidFill>
+                        <a:srgbClr val="C9D3DD"/>
+                      </a:solidFill>
+                      <a:prstDash val="solid"/>
+                      <a:round/>
+                      <a:headEnd type="none" w="med" len="med"/>
+                      <a:tailEnd type="none" w="med" len="med"/>
+                    </a:lnB>
+                    <a:solidFill>
+                      <a:srgbClr val="FFFFFF"/>
+                    </a:solidFill>
+                  </a:tcPr>
+                </a:tc>
+              </a:tr>
+              <a:tr h="438912">
+                <a:tc>
+                  <a:txBody>
+                    <a:bodyPr/>
+                    <a:lstStyle/>
+                    <a:p>
+                      <a:pPr indent="0" marL="0">
+                        <a:buNone/>
+                      </a:pPr>
+                      <a:r>
+                        <a:rPr lang="en-US" sz="1500" dirty="0">
+                          <a:solidFill>
+                            <a:srgbClr val="6250D6"/>
+                          </a:solidFill>
+                        </a:rPr>
+                        <a:t>●  </a:t>
+                      </a:r>
+                      <a:pPr indent="0" marL="0">
+                        <a:buNone/>
+                      </a:pPr>
+                      <a:r>
+                        <a:rPr lang="en-US" sz="1500" b="1" dirty="0">
+                          <a:solidFill>
+                            <a:srgbClr val="1B2430"/>
+                          </a:solidFill>
+                        </a:rPr>
+                        <a:t>Ensemble</a:t>
+                      </a:r>
+                      <a:endParaRPr lang="en-US" sz="1500" dirty="0"/>
+                    </a:p>
+                  </a:txBody>
+                  <a:tcPr marL="91440" marR="91440" marT="45720" marB="45720" anchor="ctr">
+                    <a:lnL w="12700" cap="flat" cmpd="sng" algn="ctr">
+                      <a:solidFill>
+                        <a:srgbClr val="C9D3DD"/>
+                      </a:solidFill>
+                      <a:prstDash val="solid"/>
+                      <a:round/>
+                      <a:headEnd type="none" w="med" len="med"/>
+                      <a:tailEnd type="none" w="med" len="med"/>
+                    </a:lnL>
+                    <a:lnR w="12700" cap="flat" cmpd="sng" algn="ctr">
+                      <a:solidFill>
+                        <a:srgbClr val="C9D3DD"/>
+                      </a:solidFill>
+                      <a:prstDash val="solid"/>
+                      <a:round/>
+                      <a:headEnd type="none" w="med" len="med"/>
+                      <a:tailEnd type="none" w="med" len="med"/>
+                    </a:lnR>
+                    <a:lnT w="12700" cap="flat" cmpd="sng" algn="ctr">
+                      <a:solidFill>
+                        <a:srgbClr val="C9D3DD"/>
+                      </a:solidFill>
+                      <a:prstDash val="solid"/>
+                      <a:round/>
+                      <a:headEnd type="none" w="med" len="med"/>
+                      <a:tailEnd type="none" w="med" len="med"/>
+                    </a:lnT>
+                    <a:lnB w="12700" cap="flat" cmpd="sng" algn="ctr">
+                      <a:solidFill>
+                        <a:srgbClr val="C9D3DD"/>
+                      </a:solidFill>
+                      <a:prstDash val="solid"/>
+                      <a:round/>
+                      <a:headEnd type="none" w="med" len="med"/>
+                      <a:tailEnd type="none" w="med" len="med"/>
+                    </a:lnB>
+                    <a:solidFill>
+                      <a:srgbClr val="EEF2F5"/>
+                    </a:solidFill>
+                  </a:tcPr>
+                </a:tc>
+                <a:tc>
+                  <a:txBody>
+                    <a:bodyPr/>
+                    <a:lstStyle/>
+                    <a:p>
+                      <a:pPr algn="ctr" indent="0" marL="0">
+                        <a:buNone/>
+                      </a:pPr>
+                      <a:r>
+                        <a:rPr lang="en-US" sz="1500" dirty="0">
+                          <a:solidFill>
+                            <a:srgbClr val="1B2430"/>
+                          </a:solidFill>
+                        </a:rPr>
+                        <a:t>0.767</a:t>
+                      </a:r>
+                      <a:endParaRPr lang="en-US" sz="1500" dirty="0"/>
+                    </a:p>
+                  </a:txBody>
+                  <a:tcPr marL="91440" marR="91440" marT="45720" marB="45720" anchor="ctr">
+                    <a:lnL w="12700" cap="flat" cmpd="sng" algn="ctr">
+                      <a:solidFill>
+                        <a:srgbClr val="C9D3DD"/>
+                      </a:solidFill>
+                      <a:prstDash val="solid"/>
+                      <a:round/>
+                      <a:headEnd type="none" w="med" len="med"/>
+                      <a:tailEnd type="none" w="med" len="med"/>
+                    </a:lnL>
+                    <a:lnR w="12700" cap="flat" cmpd="sng" algn="ctr">
+                      <a:solidFill>
+                        <a:srgbClr val="C9D3DD"/>
+                      </a:solidFill>
+                      <a:prstDash val="solid"/>
+                      <a:round/>
+                      <a:headEnd type="none" w="med" len="med"/>
+                      <a:tailEnd type="none" w="med" len="med"/>
+                    </a:lnR>
+                    <a:lnT w="12700" cap="flat" cmpd="sng" algn="ctr">
+                      <a:solidFill>
+                        <a:srgbClr val="C9D3DD"/>
+                      </a:solidFill>
+                      <a:prstDash val="solid"/>
+                      <a:round/>
+                      <a:headEnd type="none" w="med" len="med"/>
+                      <a:tailEnd type="none" w="med" len="med"/>
+                    </a:lnT>
+                    <a:lnB w="12700" cap="flat" cmpd="sng" algn="ctr">
+                      <a:solidFill>
+                        <a:srgbClr val="C9D3DD"/>
+                      </a:solidFill>
+                      <a:prstDash val="solid"/>
+                      <a:round/>
+                      <a:headEnd type="none" w="med" len="med"/>
+                      <a:tailEnd type="none" w="med" len="med"/>
+                    </a:lnB>
+                    <a:solidFill>
+                      <a:srgbClr val="EEF2F5"/>
+                    </a:solidFill>
+                  </a:tcPr>
+                </a:tc>
+                <a:tc>
+                  <a:txBody>
+                    <a:bodyPr/>
+                    <a:lstStyle/>
+                    <a:p>
+                      <a:pPr algn="ctr" indent="0" marL="0">
+                        <a:buNone/>
+                      </a:pPr>
+                      <a:r>
+                        <a:rPr lang="en-US" sz="1500" b="1" dirty="0">
+                          <a:solidFill>
+                            <a:srgbClr val="1B2430"/>
+                          </a:solidFill>
+                        </a:rPr>
+                        <a:t>0.813  [0.807, 0.820]</a:t>
+                      </a:r>
+                      <a:endParaRPr lang="en-US" sz="1500" dirty="0"/>
+                    </a:p>
+                  </a:txBody>
+                  <a:tcPr marL="91440" marR="91440" marT="45720" marB="45720" anchor="ctr">
+                    <a:lnL w="12700" cap="flat" cmpd="sng" algn="ctr">
+                      <a:solidFill>
+                        <a:srgbClr val="C9D3DD"/>
+                      </a:solidFill>
+                      <a:prstDash val="solid"/>
+                      <a:round/>
+                      <a:headEnd type="none" w="med" len="med"/>
+                      <a:tailEnd type="none" w="med" len="med"/>
+                    </a:lnL>
+                    <a:lnR w="12700" cap="flat" cmpd="sng" algn="ctr">
+                      <a:solidFill>
+                        <a:srgbClr val="C9D3DD"/>
+                      </a:solidFill>
+                      <a:prstDash val="solid"/>
+                      <a:round/>
+                      <a:headEnd type="none" w="med" len="med"/>
+                      <a:tailEnd type="none" w="med" len="med"/>
+                    </a:lnR>
+                    <a:lnT w="12700" cap="flat" cmpd="sng" algn="ctr">
+                      <a:solidFill>
+                        <a:srgbClr val="C9D3DD"/>
+                      </a:solidFill>
+                      <a:prstDash val="solid"/>
+                      <a:round/>
+                      <a:headEnd type="none" w="med" len="med"/>
+                      <a:tailEnd type="none" w="med" len="med"/>
+                    </a:lnT>
+                    <a:lnB w="12700" cap="flat" cmpd="sng" algn="ctr">
+                      <a:solidFill>
+                        <a:srgbClr val="C9D3DD"/>
+                      </a:solidFill>
+                      <a:prstDash val="solid"/>
+                      <a:round/>
+                      <a:headEnd type="none" w="med" len="med"/>
+                      <a:tailEnd type="none" w="med" len="med"/>
+                    </a:lnB>
+                    <a:solidFill>
+                      <a:srgbClr val="EEF2F5"/>
+                    </a:solidFill>
+                  </a:tcPr>
+                </a:tc>
+                <a:tc>
+                  <a:txBody>
+                    <a:bodyPr/>
+                    <a:lstStyle/>
+                    <a:p>
+                      <a:pPr algn="ctr" indent="0" marL="0">
+                        <a:buNone/>
+                      </a:pPr>
+                      <a:r>
+                        <a:rPr lang="en-US" sz="1500" dirty="0">
+                          <a:solidFill>
+                            <a:srgbClr val="1B2430"/>
+                          </a:solidFill>
+                        </a:rPr>
+                        <a:t>+0.046</a:t>
+                      </a:r>
+                      <a:endParaRPr lang="en-US" sz="1500" dirty="0"/>
+                    </a:p>
+                  </a:txBody>
+                  <a:tcPr marL="91440" marR="91440" marT="45720" marB="45720" anchor="ctr">
+                    <a:lnL w="12700" cap="flat" cmpd="sng" algn="ctr">
+                      <a:solidFill>
+                        <a:srgbClr val="C9D3DD"/>
+                      </a:solidFill>
+                      <a:prstDash val="solid"/>
+                      <a:round/>
+                      <a:headEnd type="none" w="med" len="med"/>
+                      <a:tailEnd type="none" w="med" len="med"/>
+                    </a:lnL>
+                    <a:lnR w="12700" cap="flat" cmpd="sng" algn="ctr">
+                      <a:solidFill>
+                        <a:srgbClr val="C9D3DD"/>
+                      </a:solidFill>
+                      <a:prstDash val="solid"/>
+                      <a:round/>
+                      <a:headEnd type="none" w="med" len="med"/>
+                      <a:tailEnd type="none" w="med" len="med"/>
+                    </a:lnR>
+                    <a:lnT w="12700" cap="flat" cmpd="sng" algn="ctr">
+                      <a:solidFill>
+                        <a:srgbClr val="C9D3DD"/>
+                      </a:solidFill>
+                      <a:prstDash val="solid"/>
+                      <a:round/>
+                      <a:headEnd type="none" w="med" len="med"/>
+                      <a:tailEnd type="none" w="med" len="med"/>
+                    </a:lnT>
+                    <a:lnB w="12700" cap="flat" cmpd="sng" algn="ctr">
+                      <a:solidFill>
+                        <a:srgbClr val="C9D3DD"/>
+                      </a:solidFill>
+                      <a:prstDash val="solid"/>
+                      <a:round/>
+                      <a:headEnd type="none" w="med" len="med"/>
+                      <a:tailEnd type="none" w="med" len="med"/>
+                    </a:lnB>
+                    <a:solidFill>
+                      <a:srgbClr val="EEF2F5"/>
+                    </a:solidFill>
+                  </a:tcPr>
+                </a:tc>
+                <a:tc>
+                  <a:txBody>
+                    <a:bodyPr/>
+                    <a:lstStyle/>
+                    <a:p>
+                      <a:pPr algn="ctr" indent="0" marL="0">
+                        <a:buNone/>
+                      </a:pPr>
+                      <a:r>
+                        <a:rPr lang="en-US" sz="1500" dirty="0">
+                          <a:solidFill>
+                            <a:srgbClr val="1B2430"/>
+                          </a:solidFill>
+                        </a:rPr>
+                        <a:t>–</a:t>
+                      </a:r>
+                      <a:endParaRPr lang="en-US" sz="1500" dirty="0"/>
+                    </a:p>
+                  </a:txBody>
+                  <a:tcPr marL="91440" marR="91440" marT="45720" marB="45720" anchor="ctr">
+                    <a:lnL w="12700" cap="flat" cmpd="sng" algn="ctr">
+                      <a:solidFill>
+                        <a:srgbClr val="C9D3DD"/>
+                      </a:solidFill>
+                      <a:prstDash val="solid"/>
+                      <a:round/>
+                      <a:headEnd type="none" w="med" len="med"/>
+                      <a:tailEnd type="none" w="med" len="med"/>
+                    </a:lnL>
+                    <a:lnR w="12700" cap="flat" cmpd="sng" algn="ctr">
+                      <a:solidFill>
+                        <a:srgbClr val="C9D3DD"/>
+                      </a:solidFill>
+                      <a:prstDash val="solid"/>
+                      <a:round/>
+                      <a:headEnd type="none" w="med" len="med"/>
+                      <a:tailEnd type="none" w="med" len="med"/>
+                    </a:lnR>
+                    <a:lnT w="12700" cap="flat" cmpd="sng" algn="ctr">
+                      <a:solidFill>
+                        <a:srgbClr val="C9D3DD"/>
+                      </a:solidFill>
+                      <a:prstDash val="solid"/>
+                      <a:round/>
+                      <a:headEnd type="none" w="med" len="med"/>
+                      <a:tailEnd type="none" w="med" len="med"/>
+                    </a:lnT>
+                    <a:lnB w="12700" cap="flat" cmpd="sng" algn="ctr">
+                      <a:solidFill>
+                        <a:srgbClr val="C9D3DD"/>
+                      </a:solidFill>
+                      <a:prstDash val="solid"/>
+                      <a:round/>
+                      <a:headEnd type="none" w="med" len="med"/>
+                      <a:tailEnd type="none" w="med" len="med"/>
+                    </a:lnB>
+                    <a:solidFill>
+                      <a:srgbClr val="EEF2F5"/>
+                    </a:solidFill>
+                  </a:tcPr>
+                </a:tc>
+              </a:tr>
+            </a:tbl>
+          </a:graphicData>
+        </a:graphic>
+      </p:graphicFrame>
+      <p:sp>
+        <p:nvSpPr>
+          <p:cNvPr id="4" name="hallazgo112k-0"/>
+          <p:cNvSpPr/>
+          <p:nvPr/>
+        </p:nvSpPr>
+        <p:spPr>
+          <a:xfrm>
+            <a:off x="548640" y="4206240"/>
+            <a:ext cx="3520440" cy="1417320"/>
+          </a:xfrm>
+          <a:prstGeom prst="roundRect">
+            <a:avLst>
+              <a:gd name="adj" fmla="val 7742"/>
+            </a:avLst>
+          </a:prstGeom>
+          <a:solidFill>
+            <a:srgbClr val="EEF2F5"/>
+          </a:solidFill>
+          <a:ln w="12700">
+            <a:solidFill>
+              <a:srgbClr val="EEF2F5"/>
+            </a:solidFill>
+            <a:prstDash val="solid"/>
+          </a:ln>
+        </p:spPr>
+      </p:sp>
+      <p:sp>
+        <p:nvSpPr>
+          <p:cNvPr id="5" name="Text 2"/>
+          <p:cNvSpPr txBox="1"/>
+          <p:nvPr/>
+        </p:nvSpPr>
+        <p:spPr>
+          <a:xfrm>
+            <a:off x="777240" y="4343400"/>
+            <a:ext cx="3108960" cy="1188720"/>
+          </a:xfrm>
+          <a:prstGeom prst="rect">
+            <a:avLst/>
+          </a:prstGeom>
+          <a:noFill/>
+          <a:ln/>
+        </p:spPr>
+        <p:txBody>
+          <a:bodyPr wrap="square" lIns="0" tIns="0" rIns="0" bIns="0" rtlCol="0" anchor="t"/>
+          <a:lstStyle/>
+          <a:p>
+            <a:pPr indent="0" marL="0">
+              <a:spcAft>
+                <a:spcPts val="600"/>
+              </a:spcAft>
+              <a:buNone/>
+            </a:pPr>
+            <a:r>
+              <a:rPr lang="en-US" sz="1600" b="1" dirty="0">
+                <a:solidFill>
+                  <a:schemeClr val="tx1"/>
+                </a:solidFill>
+              </a:rPr>
+              <a:t>El híbrido es el que más gana</a:t>
+            </a:r>
+            <a:endParaRPr lang="en-US" sz="1600" dirty="0"/>
+          </a:p>
+          <a:p>
+            <a:pPr indent="0" marL="0">
+              <a:spcAft>
+                <a:spcPts val="600"/>
+              </a:spcAft>
+              <a:buNone/>
+            </a:pPr>
+            <a:r>
+              <a:rPr lang="en-US" sz="1400" dirty="0">
+                <a:solidFill>
+                  <a:schemeClr val="tx2"/>
+                </a:solidFill>
+              </a:rPr>
+              <a:t>MaxViT-T +0.057 y ahora converge (mejor época 4): le faltaban datos</a:t>
+            </a:r>
+            <a:endParaRPr lang="en-US" sz="1600" dirty="0"/>
+          </a:p>
+        </p:txBody>
+      </p:sp>
+      <p:sp>
+        <p:nvSpPr>
+          <p:cNvPr id="6" name="hallazgo112k-1"/>
+          <p:cNvSpPr/>
+          <p:nvPr/>
+        </p:nvSpPr>
+        <p:spPr>
+          <a:xfrm>
+            <a:off x="4297680" y="4206240"/>
+            <a:ext cx="3520440" cy="1417320"/>
+          </a:xfrm>
+          <a:prstGeom prst="roundRect">
+            <a:avLst>
+              <a:gd name="adj" fmla="val 7742"/>
+            </a:avLst>
+          </a:prstGeom>
+          <a:solidFill>
+            <a:srgbClr val="EEF2F5"/>
+          </a:solidFill>
+          <a:ln w="12700">
+            <a:solidFill>
+              <a:srgbClr val="EEF2F5"/>
+            </a:solidFill>
+            <a:prstDash val="solid"/>
+          </a:ln>
+        </p:spPr>
+      </p:sp>
+      <p:sp>
+        <p:nvSpPr>
+          <p:cNvPr id="7" name="Text 4"/>
+          <p:cNvSpPr txBox="1"/>
+          <p:nvPr/>
+        </p:nvSpPr>
+        <p:spPr>
+          <a:xfrm>
+            <a:off x="4526280" y="4343400"/>
+            <a:ext cx="3108960" cy="1188720"/>
+          </a:xfrm>
+          <a:prstGeom prst="rect">
+            <a:avLst/>
+          </a:prstGeom>
+          <a:noFill/>
+          <a:ln/>
+        </p:spPr>
+        <p:txBody>
+          <a:bodyPr wrap="square" lIns="0" tIns="0" rIns="0" bIns="0" rtlCol="0" anchor="t"/>
+          <a:lstStyle/>
+          <a:p>
+            <a:pPr indent="0" marL="0">
+              <a:spcAft>
+                <a:spcPts val="600"/>
+              </a:spcAft>
+              <a:buNone/>
+            </a:pPr>
+            <a:r>
+              <a:rPr lang="en-US" sz="1600" b="1" dirty="0">
+                <a:solidFill>
+                  <a:schemeClr val="tx1"/>
+                </a:solidFill>
+              </a:rPr>
+              <a:t>El ensemble sigue arriba</a:t>
+            </a:r>
+            <a:endParaRPr lang="en-US" sz="1600" dirty="0"/>
+          </a:p>
+          <a:p>
+            <a:pPr indent="0" marL="0">
+              <a:spcAft>
+                <a:spcPts val="600"/>
+              </a:spcAft>
+              <a:buNone/>
+            </a:pPr>
+            <a:r>
+              <a:rPr lang="en-US" sz="1400" dirty="0">
+                <a:solidFill>
+                  <a:schemeClr val="tx2"/>
+                </a:solidFill>
+              </a:rPr>
+              <a:t>AUROC 0.813, significativamente mejor que cada modelo</a:t>
+            </a:r>
+            <a:endParaRPr lang="en-US" sz="1600" dirty="0"/>
+          </a:p>
+        </p:txBody>
+      </p:sp>
+      <p:sp>
+        <p:nvSpPr>
+          <p:cNvPr id="8" name="hallazgo112k-2"/>
+          <p:cNvSpPr/>
+          <p:nvPr/>
+        </p:nvSpPr>
+        <p:spPr>
+          <a:xfrm>
+            <a:off x="8046720" y="4206240"/>
+            <a:ext cx="3520440" cy="1417320"/>
+          </a:xfrm>
+          <a:prstGeom prst="roundRect">
+            <a:avLst>
+              <a:gd name="adj" fmla="val 7742"/>
+            </a:avLst>
+          </a:prstGeom>
+          <a:solidFill>
+            <a:srgbClr val="EEF2F5"/>
+          </a:solidFill>
+          <a:ln w="12700">
+            <a:solidFill>
+              <a:srgbClr val="EEF2F5"/>
+            </a:solidFill>
+            <a:prstDash val="solid"/>
+          </a:ln>
+        </p:spPr>
+      </p:sp>
+      <p:sp>
+        <p:nvSpPr>
+          <p:cNvPr id="9" name="Text 6"/>
+          <p:cNvSpPr txBox="1"/>
+          <p:nvPr/>
+        </p:nvSpPr>
+        <p:spPr>
+          <a:xfrm>
+            <a:off x="8275320" y="4343400"/>
+            <a:ext cx="3108960" cy="1188720"/>
+          </a:xfrm>
+          <a:prstGeom prst="rect">
+            <a:avLst/>
+          </a:prstGeom>
+          <a:noFill/>
+          <a:ln/>
+        </p:spPr>
+        <p:txBody>
+          <a:bodyPr wrap="square" lIns="0" tIns="0" rIns="0" bIns="0" rtlCol="0" anchor="t"/>
+          <a:lstStyle/>
+          <a:p>
+            <a:pPr indent="0" marL="0">
+              <a:spcAft>
+                <a:spcPts val="600"/>
+              </a:spcAft>
+              <a:buNone/>
+            </a:pPr>
+            <a:r>
+              <a:rPr lang="en-US" sz="1600" b="1" dirty="0">
+                <a:solidFill>
+                  <a:schemeClr val="tx1"/>
+                </a:solidFill>
+              </a:rPr>
+              <a:t>ResNet18, mejor individual</a:t>
+            </a:r>
+            <a:endParaRPr lang="en-US" sz="1600" dirty="0"/>
+          </a:p>
+          <a:p>
+            <a:pPr indent="0" marL="0">
+              <a:spcAft>
+                <a:spcPts val="600"/>
+              </a:spcAft>
+              <a:buNone/>
+            </a:pPr>
+            <a:r>
+              <a:rPr lang="en-US" sz="1400" dirty="0">
+                <a:solidFill>
+                  <a:schemeClr val="tx2"/>
+                </a:solidFill>
+              </a:rPr>
+              <a:t>Con 9× más datos de prueba la diferencia ya es significativa, pero pequeña (&lt;0.01)</a:t>
+            </a:r>
+            <a:endParaRPr lang="en-US" sz="1600" dirty="0"/>
+          </a:p>
+        </p:txBody>
+      </p:sp>
+      <p:sp>
+        <p:nvSpPr>
+          <p:cNvPr id="10" name="Text 7"/>
+          <p:cNvSpPr txBox="1"/>
+          <p:nvPr/>
+        </p:nvSpPr>
+        <p:spPr>
+          <a:xfrm>
+            <a:off x="548640" y="5806440"/>
+            <a:ext cx="11064240" cy="365760"/>
+          </a:xfrm>
+          <a:prstGeom prst="rect">
+            <a:avLst/>
+          </a:prstGeom>
+          <a:noFill/>
+          <a:ln/>
+        </p:spPr>
+        <p:txBody>
+          <a:bodyPr wrap="square" lIns="0" tIns="0" rIns="0" bIns="0" rtlCol="0" anchor="ctr"/>
+          <a:lstStyle/>
+          <a:p>
+            <a:pPr indent="0" marL="0">
+              <a:buNone/>
+            </a:pPr>
+            <a:r>
+              <a:rPr lang="en-US" sz="1300" i="1" dirty="0">
+                <a:solidFill>
+                  <a:schemeClr val="accent5"/>
+                </a:solidFill>
+              </a:rPr>
+              <a:t>Mismo protocolo con las 112,120 imágenes (prueba: 16,822); corrida en modo de bajo consumo para evitar los apagados del equipo.</a:t>
+            </a:r>
+            <a:endParaRPr lang="en-US" sz="1300" dirty="0"/>
+          </a:p>
+        </p:txBody>
+      </p:sp>
+      <p:sp>
+        <p:nvSpPr>
+          <p:cNvPr id="25" name="Slide Number Placeholder 0"/>
+          <p:cNvSpPr>
+            <a:spLocks noGrp="1"/>
+          </p:cNvSpPr>
+          <p:nvPr>
+            <p:ph type="sldNum" sz="quarter" idx="4294967295"/>
+          </p:nvPr>
+        </p:nvSpPr>
+        <p:spPr>
+          <a:xfrm>
+            <a:off x="11155680" y="6400800"/>
+            <a:ext cx="457200" cy="274320"/>
+          </a:xfrm>
+          <a:prstGeom prst="rect">
+            <a:avLst/>
+          </a:prstGeom>
+          <a:extLst>
+            <a:ext uri="{C572A759-6A51-4108-AA02-DFA0A04FC94B}">
+              <ma14:wrappingTextBoxFlag xmlns:ma14="http://schemas.microsoft.com/office/mac/drawingml/2011/main" val="0"/>
+            </a:ext>
+          </a:extLst>
+        </p:spPr>
+        <p:txBody>
+          <a:bodyPr/>
+          <a:lstStyle>
+            <a:lvl1pPr>
+              <a:defRPr sz="1000">
+                <a:solidFill>
+                  <a:srgbClr val="6B7A8C"/>
+                </a:solidFill>
+              </a:defRPr>
+            </a:lvl1pPr>
+          </a:lstStyle>
+          <a:p>
+            <a:pPr algn="r"/>
+            <a:fld id="{F7021451-1387-4CA6-816F-3879F97B5CBC}" type="slidenum">
+              <a:rPr b="0" lang="en-US"/>
+              <a:t>6</a:t>
+            </a:fld>
+            <a:endParaRPr lang="en-US"/>
+          </a:p>
+        </p:txBody>
+      </p:sp>
+    </p:spTree>
+  </p:cSld>
+  <p:clrMapOvr>
+    <a:masterClrMapping/>
+  </p:clrMapOvr>
+</p:sld>
+</file>
+
+<file path=ppt/slides/slide7.xml><?xml version="1.0" encoding="utf-8"?>
+<p:sld xmlns:a="http://schemas.openxmlformats.org/drawingml/2006/main" xmlns:r="http://schemas.openxmlformats.org/officeDocument/2006/relationships" xmlns:p="http://schemas.openxmlformats.org/presentationml/2006/main">
+  <p:cSld name="Slide 7">
+    <p:spTree>
+      <p:nvGrpSpPr>
+        <p:cNvPr id="1" name=""/>
+        <p:cNvGrpSpPr/>
+        <p:nvPr/>
+      </p:nvGrpSpPr>
+      <p:grpSpPr>
+        <a:xfrm>
+          <a:off x="0" y="0"/>
+          <a:ext cx="0" cy="0"/>
+          <a:chOff x="0" y="0"/>
+          <a:chExt cx="0" cy="0"/>
+        </a:xfrm>
+      </p:grpSpPr>
+      <p:sp>
+        <p:nvSpPr>
+          <p:cNvPr id="2" name="Text 0"/>
+          <p:cNvSpPr/>
+          <p:nvPr>
+            <p:ph idx="100" type="title" hasCustomPrompt="1"/>
+          </p:nvPr>
+        </p:nvSpPr>
+        <p:spPr>
+          <a:xfrm>
+            <a:off x="548640" y="320040"/>
+            <a:ext cx="11064240" cy="868680"/>
+          </a:xfrm>
+          <a:prstGeom prst="rect">
+            <a:avLst/>
+          </a:prstGeom>
+          <a:noFill/>
+          <a:ln/>
+        </p:spPr>
+        <p:txBody>
+          <a:bodyPr wrap="square" rtlCol="0" anchor="ctr"/>
+          <a:lstStyle/>
+          <a:p>
+            <a:pPr indent="0" marL="0">
+              <a:buNone/>
+            </a:pPr>
+            <a:r>
+              <a:rPr lang="en-US" sz="2800" b="1" dirty="0">
+                <a:solidFill>
+                  <a:schemeClr val="tx1"/>
+                </a:solidFill>
+              </a:rPr>
               <a:t>Por hallazgo, la dificultad pesa más que la arquitectura</a:t>
             </a:r>
             <a:endParaRPr lang="en-US" sz="2800" dirty="0"/>
@@ -8404,7 +11261,7 @@
             <a:pPr algn="r"/>
             <a:fld id="{F7021451-1387-4CA6-816F-3879F97B5CBC}" type="slidenum">
               <a:rPr b="0" lang="en-US"/>
-              <a:t>6</a:t>
+              <a:t>7</a:t>
             </a:fld>
             <a:endParaRPr lang="en-US"/>
           </a:p>
@@ -8418,9 +11275,9 @@
 </p:sld>
 </file>
 
-<file path=ppt/slides/slide7.xml><?xml version="1.0" encoding="utf-8"?>
+<file path=ppt/slides/slide8.xml><?xml version="1.0" encoding="utf-8"?>
 <p:sld xmlns:a="http://schemas.openxmlformats.org/drawingml/2006/main" xmlns:r="http://schemas.openxmlformats.org/officeDocument/2006/relationships" xmlns:p="http://schemas.openxmlformats.org/presentationml/2006/main">
-  <p:cSld name="Slide 7">
+  <p:cSld name="Slide 8">
     <p:spTree>
       <p:nvGrpSpPr>
         <p:cNvPr id="1" name=""/>
@@ -8596,234 +11453,6 @@
             <a:pPr algn="r"/>
             <a:fld id="{F7021451-1387-4CA6-816F-3879F97B5CBC}" type="slidenum">
               <a:rPr b="0" lang="en-US"/>
-              <a:t>7</a:t>
-            </a:fld>
-            <a:endParaRPr lang="en-US"/>
-          </a:p>
-        </p:txBody>
-      </p:sp>
-    </p:spTree>
-  </p:cSld>
-  <p:clrMapOvr>
-    <a:masterClrMapping/>
-  </p:clrMapOvr>
-</p:sld>
-</file>
-
-<file path=ppt/slides/slide8.xml><?xml version="1.0" encoding="utf-8"?>
-<p:sld xmlns:a="http://schemas.openxmlformats.org/drawingml/2006/main" xmlns:r="http://schemas.openxmlformats.org/officeDocument/2006/relationships" xmlns:p="http://schemas.openxmlformats.org/presentationml/2006/main">
-  <p:cSld name="Slide 8">
-    <p:spTree>
-      <p:nvGrpSpPr>
-        <p:cNvPr id="1" name=""/>
-        <p:cNvGrpSpPr/>
-        <p:nvPr/>
-      </p:nvGrpSpPr>
-      <p:grpSpPr>
-        <a:xfrm>
-          <a:off x="0" y="0"/>
-          <a:ext cx="0" cy="0"/>
-          <a:chOff x="0" y="0"/>
-          <a:chExt cx="0" cy="0"/>
-        </a:xfrm>
-      </p:grpSpPr>
-      <p:sp>
-        <p:nvSpPr>
-          <p:cNvPr id="2" name="Text 0"/>
-          <p:cNvSpPr/>
-          <p:nvPr>
-            <p:ph idx="100" type="title" hasCustomPrompt="1"/>
-          </p:nvPr>
-        </p:nvSpPr>
-        <p:spPr>
-          <a:xfrm>
-            <a:off x="548640" y="320040"/>
-            <a:ext cx="11064240" cy="868680"/>
-          </a:xfrm>
-          <a:prstGeom prst="rect">
-            <a:avLst/>
-          </a:prstGeom>
-          <a:noFill/>
-          <a:ln/>
-        </p:spPr>
-        <p:txBody>
-          <a:bodyPr wrap="square" rtlCol="0" anchor="ctr"/>
-          <a:lstStyle/>
-          <a:p>
-            <a:pPr indent="0" marL="0">
-              <a:buNone/>
-            </a:pPr>
-            <a:r>
-              <a:rPr lang="en-US" sz="2800" b="1" dirty="0">
-                <a:solidFill>
-                  <a:schemeClr val="tx1"/>
-                </a:solidFill>
-              </a:rPr>
-              <a:t>¿Dónde miran los modelos?</a:t>
-            </a:r>
-            <a:endParaRPr lang="en-US" sz="2800" dirty="0"/>
-          </a:p>
-        </p:txBody>
-      </p:sp>
-      <p:pic>
-        <p:nvPicPr>
-          <p:cNvPr id="3" name="gradcam" descr="gradcam">    </p:cNvPr>
-          <p:cNvPicPr>
-            <a:picLocks noChangeAspect="1"/>
-          </p:cNvPicPr>
-          <p:nvPr/>
-        </p:nvPicPr>
-        <p:blipFill>
-          <a:blip r:embed="rId1"/>
-          <a:stretch>
-            <a:fillRect/>
-          </a:stretch>
-        </p:blipFill>
-        <p:spPr>
-          <a:xfrm>
-            <a:off x="670560" y="1188720"/>
-            <a:ext cx="6339840" cy="4754880"/>
-          </a:xfrm>
-          <a:prstGeom prst="rect">
-            <a:avLst/>
-          </a:prstGeom>
-        </p:spPr>
-      </p:pic>
-      <p:pic>
-        <p:nvPicPr>
-          <p:cNvPr id="4" name="atencion-vit" descr="atencion-vit">    </p:cNvPr>
-          <p:cNvPicPr>
-            <a:picLocks noChangeAspect="1"/>
-          </p:cNvPicPr>
-          <p:nvPr/>
-        </p:nvPicPr>
-        <p:blipFill>
-          <a:blip r:embed="rId2"/>
-          <a:stretch>
-            <a:fillRect/>
-          </a:stretch>
-        </p:blipFill>
-        <p:spPr>
-          <a:xfrm>
-            <a:off x="7406640" y="1325880"/>
-            <a:ext cx="4480560" cy="4480560"/>
-          </a:xfrm>
-          <a:prstGeom prst="rect">
-            <a:avLst/>
-          </a:prstGeom>
-        </p:spPr>
-      </p:pic>
-      <p:sp>
-        <p:nvSpPr>
-          <p:cNvPr id="5" name="Text 1"/>
-          <p:cNvSpPr txBox="1"/>
-          <p:nvPr/>
-        </p:nvSpPr>
-        <p:spPr>
-          <a:xfrm>
-            <a:off x="365760" y="5989320"/>
-            <a:ext cx="6949440" cy="365760"/>
-          </a:xfrm>
-          <a:prstGeom prst="rect">
-            <a:avLst/>
-          </a:prstGeom>
-          <a:noFill/>
-          <a:ln/>
-        </p:spPr>
-        <p:txBody>
-          <a:bodyPr wrap="square" lIns="0" tIns="0" rIns="0" bIns="0" rtlCol="0" anchor="ctr"/>
-          <a:lstStyle/>
-          <a:p>
-            <a:pPr algn="ctr" indent="0" marL="0">
-              <a:buNone/>
-            </a:pPr>
-            <a:r>
-              <a:rPr lang="en-US" sz="1300" dirty="0">
-                <a:solidFill>
-                  <a:schemeClr val="accent5"/>
-                </a:solidFill>
-              </a:rPr>
-              <a:t>Grad-CAM: DenseNet121, ResNet18 y MaxViT-T (híbrido), para la clase real</a:t>
-            </a:r>
-            <a:endParaRPr lang="en-US" sz="1300" dirty="0"/>
-          </a:p>
-        </p:txBody>
-      </p:sp>
-      <p:sp>
-        <p:nvSpPr>
-          <p:cNvPr id="6" name="Text 2"/>
-          <p:cNvSpPr txBox="1"/>
-          <p:nvPr/>
-        </p:nvSpPr>
-        <p:spPr>
-          <a:xfrm>
-            <a:off x="7406640" y="5989320"/>
-            <a:ext cx="4480560" cy="365760"/>
-          </a:xfrm>
-          <a:prstGeom prst="rect">
-            <a:avLst/>
-          </a:prstGeom>
-          <a:noFill/>
-          <a:ln/>
-        </p:spPr>
-        <p:txBody>
-          <a:bodyPr wrap="square" lIns="0" tIns="0" rIns="0" bIns="0" rtlCol="0" anchor="ctr"/>
-          <a:lstStyle/>
-          <a:p>
-            <a:pPr algn="ctr" indent="0" marL="0">
-              <a:buNone/>
-            </a:pPr>
-            <a:r>
-              <a:rPr lang="en-US" sz="1300" dirty="0">
-                <a:solidFill>
-                  <a:schemeClr val="accent5"/>
-                </a:solidFill>
-              </a:rPr>
-              <a:t>ViT-B/16: atención del último bloque y rollout</a:t>
-            </a:r>
-            <a:endParaRPr lang="en-US" sz="1300" dirty="0"/>
-          </a:p>
-        </p:txBody>
-      </p:sp>
-      <p:sp>
-        <p:nvSpPr>
-          <p:cNvPr id="25" name="Slide Number Placeholder 0"/>
-          <p:cNvSpPr>
-            <a:spLocks noGrp="1"/>
-          </p:cNvSpPr>
-          <p:nvPr>
-            <p:ph type="sldNum" sz="quarter" idx="4294967295"/>
-          </p:nvPr>
-        </p:nvSpPr>
-        <p:spPr>
-          <a:xfrm>
-            <a:off x="11155680" y="6400800"/>
-            <a:ext cx="457200" cy="274320"/>
-          </a:xfrm>
-          <a:prstGeom prst="rect">
-            <a:avLst/>
-          </a:prstGeom>
-          <a:extLst>
-            <a:ext uri="{C572A759-6A51-4108-AA02-DFA0A04FC94B}">
-              <ma14:wrappingTextBoxFlag xmlns:ma14="http://schemas.microsoft.com/office/mac/drawingml/2011/main" val="0"/>
-            </a:ext>
-          </a:extLst>
-        </p:spPr>
-        <p:txBody>
-          <a:bodyPr/>
-          <a:lstStyle>
-            <a:lvl1pPr>
-              <a:defRPr sz="1000">
-                <a:solidFill>
-                  <a:srgbClr val="6B7A8C"/>
-                </a:solidFill>
-              </a:defRPr>
-            </a:lvl1pPr>
-          </a:lstStyle>
-          <a:p>
-            <a:pPr algn="r"/>
-            <a:fld id="{F7021451-1387-4CA6-816F-3879F97B5CBC}" type="slidenum">
-              <a:rPr b="0" lang="en-US"/>
               <a:t>8</a:t>
             </a:fld>
             <a:endParaRPr lang="en-US"/>
@@ -8884,50 +11513,73 @@
             <a:r>
               <a:rPr lang="en-US" sz="2800" b="1" dirty="0">
                 <a:solidFill>
-                  <a:schemeClr val="bg1"/>
+                  <a:schemeClr val="tx1"/>
                 </a:solidFill>
               </a:rPr>
-              <a:t>Conclusiones</a:t>
+              <a:t>¿Dónde miran los modelos?</a:t>
             </a:r>
             <a:endParaRPr lang="en-US" sz="2800" dirty="0"/>
           </a:p>
         </p:txBody>
       </p:sp>
-      <p:sp>
-        <p:nvSpPr>
-          <p:cNvPr id="3" name="Shape 1"/>
-          <p:cNvSpPr/>
+      <p:pic>
+        <p:nvPicPr>
+          <p:cNvPr id="3" name="gradcam" descr="gradcam">    </p:cNvPr>
+          <p:cNvPicPr>
+            <a:picLocks noChangeAspect="1"/>
+          </p:cNvPicPr>
           <p:nvPr/>
-        </p:nvSpPr>
-        <p:spPr>
-          <a:xfrm>
-            <a:off x="548640" y="1399032"/>
-            <a:ext cx="274320" cy="274320"/>
-          </a:xfrm>
-          <a:prstGeom prst="ellipse">
+        </p:nvPicPr>
+        <p:blipFill>
+          <a:blip r:embed="rId1"/>
+          <a:stretch>
+            <a:fillRect/>
+          </a:stretch>
+        </p:blipFill>
+        <p:spPr>
+          <a:xfrm>
+            <a:off x="670560" y="1188720"/>
+            <a:ext cx="6339840" cy="4754880"/>
+          </a:xfrm>
+          <a:prstGeom prst="rect">
             <a:avLst/>
           </a:prstGeom>
-          <a:solidFill>
-            <a:srgbClr val="2A78D6"/>
-          </a:solidFill>
-          <a:ln w="12700">
-            <a:solidFill>
-              <a:srgbClr val="2A78D6"/>
-            </a:solidFill>
-            <a:prstDash val="solid"/>
-          </a:ln>
-        </p:spPr>
-      </p:sp>
-      <p:sp>
-        <p:nvSpPr>
-          <p:cNvPr id="4" name="Text 2"/>
+        </p:spPr>
+      </p:pic>
+      <p:pic>
+        <p:nvPicPr>
+          <p:cNvPr id="4" name="atencion-vit" descr="atencion-vit">    </p:cNvPr>
+          <p:cNvPicPr>
+            <a:picLocks noChangeAspect="1"/>
+          </p:cNvPicPr>
+          <p:nvPr/>
+        </p:nvPicPr>
+        <p:blipFill>
+          <a:blip r:embed="rId2"/>
+          <a:stretch>
+            <a:fillRect/>
+          </a:stretch>
+        </p:blipFill>
+        <p:spPr>
+          <a:xfrm>
+            <a:off x="7406640" y="1325880"/>
+            <a:ext cx="4480560" cy="4480560"/>
+          </a:xfrm>
+          <a:prstGeom prst="rect">
+            <a:avLst/>
+          </a:prstGeom>
+        </p:spPr>
+      </p:pic>
+      <p:sp>
+        <p:nvSpPr>
+          <p:cNvPr id="5" name="Text 1"/>
           <p:cNvSpPr txBox="1"/>
           <p:nvPr/>
         </p:nvSpPr>
         <p:spPr>
           <a:xfrm>
-            <a:off x="1051560" y="1325880"/>
-            <a:ext cx="10515600" cy="914400"/>
+            <a:off x="365760" y="5989320"/>
+            <a:ext cx="6949440" cy="365760"/>
           </a:xfrm>
           <a:prstGeom prst="rect">
             <a:avLst/>
@@ -8936,294 +11588,55 @@
           <a:ln/>
         </p:spPr>
         <p:txBody>
-          <a:bodyPr wrap="square" lIns="0" tIns="0" rIns="0" bIns="0" rtlCol="0" anchor="t"/>
+          <a:bodyPr wrap="square" lIns="0" tIns="0" rIns="0" bIns="0" rtlCol="0" anchor="ctr"/>
           <a:lstStyle/>
           <a:p>
-            <a:pPr indent="0" marL="0">
+            <a:pPr algn="ctr" indent="0" marL="0">
               <a:buNone/>
             </a:pPr>
             <a:r>
-              <a:rPr lang="en-US" sz="1800" b="1" dirty="0">
+              <a:rPr lang="en-US" sz="1300" dirty="0">
                 <a:solidFill>
-                  <a:schemeClr val="bg1"/>
+                  <a:schemeClr val="accent5"/>
                 </a:solidFill>
               </a:rPr>
-              <a:t>Desempeño</a:t>
+              <a:t>Grad-CAM: DenseNet121, ResNet18 y MaxViT-T (híbrido), para la clase real</a:t>
             </a:r>
-            <a:endParaRPr lang="en-US" sz="1800" dirty="0"/>
-          </a:p>
-          <a:p>
-            <a:pPr indent="0" marL="0">
+            <a:endParaRPr lang="en-US" sz="1300" dirty="0"/>
+          </a:p>
+        </p:txBody>
+      </p:sp>
+      <p:sp>
+        <p:nvSpPr>
+          <p:cNvPr id="6" name="Text 2"/>
+          <p:cNvSpPr txBox="1"/>
+          <p:nvPr/>
+        </p:nvSpPr>
+        <p:spPr>
+          <a:xfrm>
+            <a:off x="7406640" y="5989320"/>
+            <a:ext cx="4480560" cy="365760"/>
+          </a:xfrm>
+          <a:prstGeom prst="rect">
+            <a:avLst/>
+          </a:prstGeom>
+          <a:noFill/>
+          <a:ln/>
+        </p:spPr>
+        <p:txBody>
+          <a:bodyPr wrap="square" lIns="0" tIns="0" rIns="0" bIns="0" rtlCol="0" anchor="ctr"/>
+          <a:lstStyle/>
+          <a:p>
+            <a:pPr algn="ctr" indent="0" marL="0">
               <a:buNone/>
             </a:pPr>
             <a:r>
-              <a:rPr lang="en-US" sz="1500" dirty="0">
+              <a:rPr lang="en-US" sz="1300" dirty="0">
                 <a:solidFill>
-                  <a:schemeClr val="accent6"/>
+                  <a:schemeClr val="accent5"/>
                 </a:solidFill>
               </a:rPr>
-              <a:t>CNN, Transformer e híbrido rinden igual con este presupuesto (AUROC 0.73–0.75); la dificultad depende más del hallazgo que de la arquitectura.</a:t>
-            </a:r>
-            <a:endParaRPr lang="en-US" sz="1800" dirty="0"/>
-          </a:p>
-        </p:txBody>
-      </p:sp>
-      <p:sp>
-        <p:nvSpPr>
-          <p:cNvPr id="5" name="Shape 3"/>
-          <p:cNvSpPr/>
-          <p:nvPr/>
-        </p:nvSpPr>
-        <p:spPr>
-          <a:xfrm>
-            <a:off x="548640" y="2423160"/>
-            <a:ext cx="274320" cy="274320"/>
-          </a:xfrm>
-          <a:prstGeom prst="ellipse">
-            <a:avLst/>
-          </a:prstGeom>
-          <a:solidFill>
-            <a:srgbClr val="6250D6"/>
-          </a:solidFill>
-          <a:ln w="12700">
-            <a:solidFill>
-              <a:srgbClr val="6250D6"/>
-            </a:solidFill>
-            <a:prstDash val="solid"/>
-          </a:ln>
-        </p:spPr>
-      </p:sp>
-      <p:sp>
-        <p:nvSpPr>
-          <p:cNvPr id="6" name="Text 4"/>
-          <p:cNvSpPr txBox="1"/>
-          <p:nvPr/>
-        </p:nvSpPr>
-        <p:spPr>
-          <a:xfrm>
-            <a:off x="1051560" y="2350008"/>
-            <a:ext cx="10515600" cy="914400"/>
-          </a:xfrm>
-          <a:prstGeom prst="rect">
-            <a:avLst/>
-          </a:prstGeom>
-          <a:noFill/>
-          <a:ln/>
-        </p:spPr>
-        <p:txBody>
-          <a:bodyPr wrap="square" lIns="0" tIns="0" rIns="0" bIns="0" rtlCol="0" anchor="t"/>
-          <a:lstStyle/>
-          <a:p>
-            <a:pPr indent="0" marL="0">
-              <a:buNone/>
-            </a:pPr>
-            <a:r>
-              <a:rPr lang="en-US" sz="1800" b="1" dirty="0">
-                <a:solidFill>
-                  <a:schemeClr val="bg1"/>
-                </a:solidFill>
-              </a:rPr>
-              <a:t>Ensemble e híbrido</a:t>
-            </a:r>
-            <a:endParaRPr lang="en-US" sz="1800" dirty="0"/>
-          </a:p>
-          <a:p>
-            <a:pPr indent="0" marL="0">
-              <a:buNone/>
-            </a:pPr>
-            <a:r>
-              <a:rPr lang="en-US" sz="1500" dirty="0">
-                <a:solidFill>
-                  <a:schemeClr val="accent6"/>
-                </a:solidFill>
-              </a:rPr>
-              <a:t>Combinar los cuatro mejora a todos (AUROC 0.767). El híbrido necesita más entrenamiento para mostrar su ventaja.</a:t>
-            </a:r>
-            <a:endParaRPr lang="en-US" sz="1800" dirty="0"/>
-          </a:p>
-        </p:txBody>
-      </p:sp>
-      <p:sp>
-        <p:nvSpPr>
-          <p:cNvPr id="7" name="Shape 5"/>
-          <p:cNvSpPr/>
-          <p:nvPr/>
-        </p:nvSpPr>
-        <p:spPr>
-          <a:xfrm>
-            <a:off x="548640" y="3447288"/>
-            <a:ext cx="274320" cy="274320"/>
-          </a:xfrm>
-          <a:prstGeom prst="ellipse">
-            <a:avLst/>
-          </a:prstGeom>
-          <a:solidFill>
-            <a:srgbClr val="EB6834"/>
-          </a:solidFill>
-          <a:ln w="12700">
-            <a:solidFill>
-              <a:srgbClr val="EB6834"/>
-            </a:solidFill>
-            <a:prstDash val="solid"/>
-          </a:ln>
-        </p:spPr>
-      </p:sp>
-      <p:sp>
-        <p:nvSpPr>
-          <p:cNvPr id="8" name="Text 6"/>
-          <p:cNvSpPr txBox="1"/>
-          <p:nvPr/>
-        </p:nvSpPr>
-        <p:spPr>
-          <a:xfrm>
-            <a:off x="1051560" y="3374136"/>
-            <a:ext cx="10515600" cy="914400"/>
-          </a:xfrm>
-          <a:prstGeom prst="rect">
-            <a:avLst/>
-          </a:prstGeom>
-          <a:noFill/>
-          <a:ln/>
-        </p:spPr>
-        <p:txBody>
-          <a:bodyPr wrap="square" lIns="0" tIns="0" rIns="0" bIns="0" rtlCol="0" anchor="t"/>
-          <a:lstStyle/>
-          <a:p>
-            <a:pPr indent="0" marL="0">
-              <a:buNone/>
-            </a:pPr>
-            <a:r>
-              <a:rPr lang="en-US" sz="1800" b="1" dirty="0">
-                <a:solidFill>
-                  <a:schemeClr val="bg1"/>
-                </a:solidFill>
-              </a:rPr>
-              <a:t>Costo</a:t>
-            </a:r>
-            <a:endParaRPr lang="en-US" sz="1800" dirty="0"/>
-          </a:p>
-          <a:p>
-            <a:pPr indent="0" marL="0">
-              <a:buNone/>
-            </a:pPr>
-            <a:r>
-              <a:rPr lang="en-US" sz="1500" dirty="0">
-                <a:solidFill>
-                  <a:schemeClr val="accent6"/>
-                </a:solidFill>
-              </a:rPr>
-              <a:t>ResNet18 es el mejor compromiso individual; ViT y MaxViT son ~13× más lentos sin rendir más.</a:t>
-            </a:r>
-            <a:endParaRPr lang="en-US" sz="1800" dirty="0"/>
-          </a:p>
-        </p:txBody>
-      </p:sp>
-      <p:sp>
-        <p:nvSpPr>
-          <p:cNvPr id="9" name="Shape 7"/>
-          <p:cNvSpPr/>
-          <p:nvPr/>
-        </p:nvSpPr>
-        <p:spPr>
-          <a:xfrm>
-            <a:off x="548640" y="4471416"/>
-            <a:ext cx="274320" cy="274320"/>
-          </a:xfrm>
-          <a:prstGeom prst="ellipse">
-            <a:avLst/>
-          </a:prstGeom>
-          <a:solidFill>
-            <a:srgbClr val="1BAF7A"/>
-          </a:solidFill>
-          <a:ln w="12700">
-            <a:solidFill>
-              <a:srgbClr val="1BAF7A"/>
-            </a:solidFill>
-            <a:prstDash val="solid"/>
-          </a:ln>
-        </p:spPr>
-      </p:sp>
-      <p:sp>
-        <p:nvSpPr>
-          <p:cNvPr id="10" name="Text 8"/>
-          <p:cNvSpPr txBox="1"/>
-          <p:nvPr/>
-        </p:nvSpPr>
-        <p:spPr>
-          <a:xfrm>
-            <a:off x="1051560" y="4398264"/>
-            <a:ext cx="10515600" cy="914400"/>
-          </a:xfrm>
-          <a:prstGeom prst="rect">
-            <a:avLst/>
-          </a:prstGeom>
-          <a:noFill/>
-          <a:ln/>
-        </p:spPr>
-        <p:txBody>
-          <a:bodyPr wrap="square" lIns="0" tIns="0" rIns="0" bIns="0" rtlCol="0" anchor="t"/>
-          <a:lstStyle/>
-          <a:p>
-            <a:pPr indent="0" marL="0">
-              <a:buNone/>
-            </a:pPr>
-            <a:r>
-              <a:rPr lang="en-US" sz="1800" b="1" dirty="0">
-                <a:solidFill>
-                  <a:schemeClr val="bg1"/>
-                </a:solidFill>
-              </a:rPr>
-              <a:t>Método</a:t>
-            </a:r>
-            <a:endParaRPr lang="en-US" sz="1800" dirty="0"/>
-          </a:p>
-          <a:p>
-            <a:pPr indent="0" marL="0">
-              <a:buNone/>
-            </a:pPr>
-            <a:r>
-              <a:rPr lang="en-US" sz="1500" dirty="0">
-                <a:solidFill>
-                  <a:schemeClr val="accent6"/>
-                </a:solidFill>
-              </a:rPr>
-              <a:t>Split por paciente, umbral en validación, intervalos de confianza y repetir el experimento evitaron sobreinterpretar diferencias pequeñas.</a:t>
-            </a:r>
-            <a:endParaRPr lang="en-US" sz="1800" dirty="0"/>
-          </a:p>
-        </p:txBody>
-      </p:sp>
-      <p:sp>
-        <p:nvSpPr>
-          <p:cNvPr id="11" name="Text 9"/>
-          <p:cNvSpPr txBox="1"/>
-          <p:nvPr/>
-        </p:nvSpPr>
-        <p:spPr>
-          <a:xfrm>
-            <a:off x="548640" y="5440680"/>
-            <a:ext cx="11064240" cy="822960"/>
-          </a:xfrm>
-          <a:prstGeom prst="rect">
-            <a:avLst/>
-          </a:prstGeom>
-          <a:noFill/>
-          <a:ln/>
-        </p:spPr>
-        <p:txBody>
-          <a:bodyPr wrap="square" lIns="0" tIns="0" rIns="0" bIns="0" rtlCol="0" anchor="ctr"/>
-          <a:lstStyle/>
-          <a:p>
-            <a:pPr indent="0" marL="0">
-              <a:buNone/>
-            </a:pPr>
-            <a:r>
-              <a:rPr lang="en-US" sz="1300" i="1" dirty="0">
-                <a:solidFill>
-                  <a:schemeClr val="accent6"/>
-                </a:solidFill>
-              </a:rPr>
-              <a:t>Limitaciones: subconjunto de 12k imágenes (11%), etiquetas ruidosas, 5 épocas con fine-tuning parcial, una semilla por corrida, 224 px. Trabajo futuro: las 112k imágenes y fine-tuning completo, aprendizaje auto-supervisado sobre radiografías sin etiquetar, y multimodalidad (edad, sexo, proyección y texto del reporte).</a:t>
+              <a:t>ViT-B/16: atención del último bloque y rollout</a:t>
             </a:r>
             <a:endParaRPr lang="en-US" sz="1300" dirty="0"/>
           </a:p>
@@ -9259,7 +11672,7 @@
             <a:lvl1pPr>
               <a:defRPr sz="1000">
                 <a:solidFill>
-                  <a:srgbClr val="C9D3DD"/>
+                  <a:srgbClr val="6B7A8C"/>
                 </a:solidFill>
               </a:defRPr>
             </a:lvl1pPr>

</xml_diff>

<commit_message>
Make full fine-tuning an explicit future-work item and clarify the 112k run
- Paper: future work item (i) "Fine-tuning completo" with its rationale
  (the 112k run changed only the data size, keeping partial fine-tuning to
  isolate its effect; full fine-tuning is what CheXNet did and would likely
  help ViT/MaxViT most; needs more compute). The 112k subsection now states
  that partial fine-tuning was kept.
- Slides: slide 6 footnote and conclusion footer say so; speaker notes too.
- Guide: slide 6/conclusion text and new question 27 with code evidence.
- CORRIDA_112K.md: "dataset completo" is not "fine-tuning completo".

Co-Authored-By: Claude Opus 5.5 <noreply@anthropic.com>
</commit_message>
<xml_diff>
--- a/slides/presentacion_final.pptx
+++ b/slides/presentacion_final.pptx
@@ -116,18 +116,18 @@
   <p:extLst>
     <p:ext uri="{521415D9-36F7-43E2-AB2F-B90AF26B5E84}">
       <p14:sectionLst xmlns:p14="http://schemas.microsoft.com/office/powerpoint/2010/main">
-        <p14:section name="Introducción" id="{1d38ae1e-6d0c-9004-d72c-d6b9ba5d589c}">
+        <p14:section name="Introducción" id="{e569b3f8-73fe-b9f5-b6c3-f195a9107394}">
           <p14:sldIdLst>
             <p14:sldId id="256"/>
             <p14:sldId id="257"/>
           </p14:sldIdLst>
         </p14:section>
-        <p14:section name="Método" id="{edef95be-7fd6-2944-bf4c-1bb662dfbf17}">
+        <p14:section name="Método" id="{73781d5f-6821-35b4-5dcf-448c46d4c44a}">
           <p14:sldIdLst>
             <p14:sldId id="258"/>
           </p14:sldIdLst>
         </p14:section>
-        <p14:section name="Resultados" id="{4c340ee9-6335-885d-2379-f9fafde95c1e}">
+        <p14:section name="Resultados" id="{33803c50-f0a0-910b-0d75-729bdaab3a4c}">
           <p14:sldIdLst>
             <p14:sldId id="259"/>
             <p14:sldId id="260"/>
@@ -137,7 +137,7 @@
             <p14:sldId id="264"/>
           </p14:sldIdLst>
         </p14:section>
-        <p14:section name="Cierre" id="{b7c12d51-d2c9-6b79-10cc-d7726bd3bfe1}">
+        <p14:section name="Cierre" id="{78941740-d2a1-6ba7-e4d3-bc98e0b9359f}">
           <p14:sldIdLst>
             <p14:sldId id="265"/>
           </p14:sldIdLst>
@@ -1998,7 +1998,7 @@
           <a:p>
             <a:r>
               <a:rPr lang="en-US" dirty="0"/>
-              <a:t>También repetí todo con el dataset completo, 112 mil imágenes. Para que la computadora no se apagara, lo corrí en modo de bajo consumo: la GPU descansa la mitad del tiempo, sin cambiar el entrenamiento. Resultado: todos mejoran unos 0.05 de AUROC, y el híbrido es el que más gana, 0.057, y ahora sí converge; le faltaban datos. El ensemble sigue siendo el mejor, con 0.813, cerca de CheXNet. Y con un conjunto de prueba nueve veces mayor, ResNet18 ya es significativamente el mejor modelo individual, aunque por menos de 0.01. Las conclusiones se sostienen.</a:t>
+              <a:t>También repetí todo con el dataset completo, 112 mil imágenes. Con el mismo protocolo, incluido el mismo fine-tuning parcial, para que lo único que cambie sea la cantidad de datos. Para que la computadora no se apagara, lo corrí en modo de bajo consumo: la GPU descansa la mitad del tiempo, sin cambiar el entrenamiento. Resultado: todos mejoran unos 0.05 de AUROC, y el híbrido es el que más gana, 0.057, y ahora sí converge; le faltaban datos. El ensemble sigue siendo el mejor, con 0.813, cerca de CheXNet. Y con un conjunto de prueba nueve veces mayor, ResNet18 ya es significativamente el mejor modelo individual, aunque por menos de 0.01. Las conclusiones se sostienen.</a:t>
             </a:r>
             <a:endParaRPr lang="en-US" dirty="0"/>
           </a:p>
@@ -3662,7 +3662,7 @@
                   <a:schemeClr val="accent6"/>
                 </a:solidFill>
               </a:rPr>
-              <a:t>Limitaciones: resultados principales con 12k imágenes (confirmados con 112k), etiquetas ruidosas, 5 épocas con fine-tuning parcial, una semilla por corrida, 224 px. Trabajo futuro: fine-tuning completo y más épocas, aprendizaje auto-supervisado sobre radiografías sin etiquetar, y multimodalidad (edad, sexo, proyección y texto del reporte).</a:t>
+              <a:t>Limitaciones: resultados principales con 12k imágenes (confirmados con 112k), etiquetas ruidosas, 5 épocas con fine-tuning parcial, una semilla por corrida, 224 px. Trabajo futuro: fine-tuning completo (todas las capas) sobre las 112k imágenes, aprendizaje auto-supervisado sobre radiografías sin etiquetar, y multimodalidad (edad, sexo, proyección y texto del reporte).</a:t>
             </a:r>
             <a:endParaRPr lang="en-US" sz="1300" dirty="0"/>
           </a:p>
@@ -10869,7 +10869,7 @@
                   <a:schemeClr val="accent5"/>
                 </a:solidFill>
               </a:rPr>
-              <a:t>Mismo protocolo con las 112,120 imágenes (prueba: 16,822); corrida en modo de bajo consumo para evitar los apagados del equipo.</a:t>
+              <a:t>Mismo protocolo, incluido el fine-tuning parcial, con las 112,120 imágenes (prueba: 16,822); corrida en modo de bajo consumo para evitar los apagados del equipo.</a:t>
             </a:r>
             <a:endParaRPr lang="en-US" sz="1300" dirty="0"/>
           </a:p>

</xml_diff>

<commit_message>
Rewrite the speech to be easier to say; speaker notes now come from the guide
- Speech (guide part 1): short spoken sentences, rounded numbers, simple
  model names, analogies (exam seen in advance, hiring someone who already
  knows images, second medical opinion), [actions] to point at, a key idea
  per slide and a pronunciation table. ~833 spoken words (5.2-5.7 min).
- build_deck.js reads each "### N." section of the guide as that slide's
  speaker notes, so the notes shown while presenting always match the guide.

Co-Authored-By: Claude Opus 5.5 <noreply@anthropic.com>
</commit_message>
<xml_diff>
--- a/slides/presentacion_final.pptx
+++ b/slides/presentacion_final.pptx
@@ -116,18 +116,18 @@
   <p:extLst>
     <p:ext uri="{521415D9-36F7-43E2-AB2F-B90AF26B5E84}">
       <p14:sectionLst xmlns:p14="http://schemas.microsoft.com/office/powerpoint/2010/main">
-        <p14:section name="Introducción" id="{e569b3f8-73fe-b9f5-b6c3-f195a9107394}">
+        <p14:section name="Introducción" id="{2ae58300-2300-6538-5e59-d9a3a104d36f}">
           <p14:sldIdLst>
             <p14:sldId id="256"/>
             <p14:sldId id="257"/>
           </p14:sldIdLst>
         </p14:section>
-        <p14:section name="Método" id="{73781d5f-6821-35b4-5dcf-448c46d4c44a}">
+        <p14:section name="Método" id="{42327332-0fee-d09e-39c0-987d0dd98b7d}">
           <p14:sldIdLst>
             <p14:sldId id="258"/>
           </p14:sldIdLst>
         </p14:section>
-        <p14:section name="Resultados" id="{33803c50-f0a0-910b-0d75-729bdaab3a4c}">
+        <p14:section name="Resultados" id="{368152f7-6879-327a-1597-3265ff19e7e1}">
           <p14:sldIdLst>
             <p14:sldId id="259"/>
             <p14:sldId id="260"/>
@@ -137,7 +137,7 @@
             <p14:sldId id="264"/>
           </p14:sldIdLst>
         </p14:section>
-        <p14:section name="Cierre" id="{78941740-d2a1-6ba7-e4d3-bc98e0b9359f}">
+        <p14:section name="Cierre" id="{15027108-20b5-e88a-17c9-f2e9842ce6a1}">
           <p14:sldIdLst>
             <p14:sldId id="265"/>
           </p14:sldIdLst>
@@ -1470,7 +1470,8 @@
           <a:p>
             <a:r>
               <a:rPr lang="en-US" dirty="0"/>
-              <a:t>Presento una comparación de cuatro arquitecturas para detectar 14 hallazgos en radiografías de tórax: dos redes convolucionales, DenseNet121 y ResNet18; un Vision Transformer, ViT-B/16; y un híbrido que combina convoluciones y atención, MaxViT-T. Además combino los cuatro en un ensemble. La pregunta es qué enfoque conviene en este problema bajo un mismo presupuesto.</a:t>
+              <a:t>Buenas tardes, soy Alfredo Gallegos López.
+Hoy quiero responder una pregunta sencilla: si queremos que una computadora lea radiografías de tórax, ¿qué conviene más? ¿Una red convolucional, un Transformer, o una mezcla de los dos?</a:t>
             </a:r>
             <a:endParaRPr lang="en-US" dirty="0"/>
           </a:p>
@@ -1558,7 +1559,12 @@
           <a:p>
             <a:r>
               <a:rPr lang="en-US" dirty="0"/>
-              <a:t>En resumen: con el mismo presupuesto, ninguna arquitectura domina; la diferencia real está en el costo, donde ResNet18 es el más eficiente. Lo que sí mejora el desempeño es combinar los modelos. Con el dataset completo todo mejora unos 0.05 y las conclusiones se sostienen; el híbrido es el que más se beneficia de tener más datos. Y metodológicamente, evaluar bien —por paciente, con umbrales en validación, intervalos de confianza y repitiendo el experimento— fue lo que evitó conclusiones engañosas. Como siguientes pasos: entrenar con todo el dataset, preentrenamiento auto-supervisado y multimodalidad. Gracias.</a:t>
+              <a:t>Para cerrar, me quedo con tres ideas:
+Uno. Con las mismas reglas, convolucional, Transformer e híbrido rinden casi igual. Con más datos todos mejoran, y ResNet gana por poco.
+Dos. Lo que sí marca la diferencia es combinarlos, y en la práctica, el costo, donde ResNet es el más eficiente.
+Y tres. Medir bien importa tanto como el modelo. Separar por paciente, usar intervalos de confianza y repetir el experimento me evitó sacar conclusiones equivocadas.
+Como siguientes pasos: reentrenar la red completa, aprovechar radiografías sin etiquetas y sumar datos clínicos del paciente.
+[Pausa] Muchas gracias. Quedo atento a sus preguntas.</a:t>
             </a:r>
             <a:endParaRPr lang="en-US" dirty="0"/>
           </a:p>
@@ -1646,7 +1652,12 @@
           <a:p>
             <a:r>
               <a:rPr lang="en-US" dirty="0"/>
-              <a:t>NIH ChestX-ray14 tiene 112 mil radiografías de unos 30 mil pacientes, con 14 hallazgos que pueden aparecer juntos. Las etiquetas se extrajeron automáticamente de los reportes, así que tienen ruido, y las clases están muy desbalanceadas: Hernia aparece en 0.2% de las imágenes e Infiltration en 18%. Por eso la exactitud no sirve y la métrica principal es el AUROC.</a:t>
+              <a:t>Trabajé con ChestX-ray14: ciento doce mil radiografías de unos treinta mil pacientes, con catorce posibles hallazgos.
+Y no es un problema fácil, por tres razones:
+• Una misma radiografía puede tener varios hallazgos a la vez.
+• Las etiquetas tienen errores, porque salieron automáticamente de los reportes médicos.
+• Hay hallazgos rarísimos. La hernia aparece en apenas dos de cada mil imágenes.
+Por eso no comparo con el porcentaje de aciertos, sino con el AUROC. La idea es simple: si le doy al modelo una radiografía enferma y una sana, ¿qué tan seguido le da más puntaje a la enferma? Medio punto es adivinar al azar; uno es perfecto.</a:t>
             </a:r>
             <a:endParaRPr lang="en-US" dirty="0"/>
           </a:p>
@@ -1734,7 +1745,14 @@
           <a:p>
             <a:r>
               <a:rPr lang="en-US" dirty="0"/>
-              <a:t>Los cuatro modelos se entrenan exactamente igual. La partición es por paciente, para que el modelo nunca se evalúe sobre un paciente que ya vio. El desbalance se trata en la evaluación: AUROC, que no depende de la prevalencia, y un umbral por clase elegido en validación. Hice fine-tuning parcial: parto de los pesos de ImageNet y ajusto solo el último bloque y la capa de salida. Por cuatro razones: las primeras capas aprenden rasgos genéricos como bordes y texturas que sirven igual en radiografías; con 8,400 imágenes, ajustar los 86 millones de parámetros del ViT sobreajustaría; el presupuesto de cómputo no daba para fine-tuning completo de cuatro modelos; y aplicar la misma regla a todos mantiene la comparación justa. En el híbrido descongelé solo su última capa para que su capacidad entrenable sea comparable. Y el ensemble es simplemente el promedio de las probabilidades de los cuatro.</a:t>
+              <a:t>Para que la comparación sea justa, los cuatro modelos siguen exactamente las mismas reglas.
+Primero, separé las imágenes por paciente: nadie aparece al mismo tiempo en entrenamiento y en prueba. Si no, sería como dejar que el alumno vea el examen antes de presentarlo.
+Los modelos son cuatro:
+• Dos redes convolucionales, DenseNet y ResNet. Miran la imagen con filtros pequeños, como una lupa que recorre la placa.
+• Un Transformer, el ViT. Corta la imagen en cuadritos y los compara todos entre sí.
+• Un híbrido, MaxViT, que combina las dos ideas.
+Ninguno empieza de cero. Todos vienen entrenados con millones de fotos normales, y yo solo reentreno su última parte. Es como contratar a alguien que ya sabe mirar imágenes y enseñarle solamente a leer radiografías. A esto se le llama fine-tuning parcial.
+Y además pruebo un ensemble: juntar a los cuatro modelos y promediar su opinión.</a:t>
             </a:r>
             <a:endParaRPr lang="en-US" dirty="0"/>
           </a:p>
@@ -1822,7 +1840,10 @@
           <a:p>
             <a:r>
               <a:rPr lang="en-US" dirty="0"/>
-              <a:t>La métrica principal es el AUROC promedio. Los cuatro modelos individuales quedan entre 0.733 y 0.749, y ninguna diferencia entre ellos es significativa. Además, repetí el experimento y el orden cambió: en la corrida anterior ResNet18 parecía significativamente mejor que DenseNet121 y en esta ya no. El ensemble, en cambio, mejora a todos con significancia: AUROC 0.767. La exactitud es igual a la de un modelo que siempre dice 'sano', por eso no sirve para comparar.</a:t>
+              <a:t>[Señala la tabla] Este es el resultado principal.
+Los cuatro modelos quedan muy parejos, entre 0.73 y 0.75 de AUROC, y sus diferencias están dentro del margen de error. De hecho, cuando repetí el experimento, el orden cambió.
+En cambio, el ensemble sí destaca: llega a 0.77 y le gana a todos, con diferencia significativa.
+Y un detalle curioso. [Señala la columna de exactitud] La exactitud es de 95% para todos. Pero un modelo que siempre dice "está sano" también saca 95%. Por eso esa métrica, aquí, no sirve para comparar.</a:t>
             </a:r>
             <a:endParaRPr lang="en-US" dirty="0"/>
           </a:p>
@@ -1910,7 +1931,9 @@
           <a:p>
             <a:r>
               <a:rPr lang="en-US" dirty="0"/>
-              <a:t>Aquí está la parte exploratoria. El ensemble, que solo promedia las probabilidades, mejora a cada modelo entre 0.018 y 0.034 de AUROC, todas significativas: los modelos cometen errores distintos. Su costo es ejecutar los cuatro. El híbrido MaxViT-T quedó con el AUROC más bajo, pero la curva explica por qué: es el único cuya pérdida de validación seguía bajando en la quinta época. En la literatura los híbridos son los mejores en este dataset, pero con entrenamiento completo; con este presupuesto no alcanzó a converger.</a:t>
+              <a:t>¿Por qué funciona el ensemble? Por lo mismo que una segunda opinión médica: cada modelo se equivoca en cosas distintas, y al juntarlos, los errores se compensan.
+¿Y el híbrido? Quedó en último lugar. Pero miren su curva. [Señala la línea amarilla] Todavía estaba aprendiendo cuando se terminó el entrenamiento. Simplemente le faltó tiempo.
+ResNet, en cambio, aprende tan rápido que pronto empieza a memorizar. Por eso siempre uso su mejor momento, no el último.</a:t>
             </a:r>
             <a:endParaRPr lang="en-US" dirty="0"/>
           </a:p>
@@ -1998,7 +2021,9 @@
           <a:p>
             <a:r>
               <a:rPr lang="en-US" dirty="0"/>
-              <a:t>También repetí todo con el dataset completo, 112 mil imágenes. Con el mismo protocolo, incluido el mismo fine-tuning parcial, para que lo único que cambie sea la cantidad de datos. Para que la computadora no se apagara, lo corrí en modo de bajo consumo: la GPU descansa la mitad del tiempo, sin cambiar el entrenamiento. Resultado: todos mejoran unos 0.05 de AUROC, y el híbrido es el que más gana, 0.057, y ahora sí converge; le faltaban datos. El ensemble sigue siendo el mejor, con 0.813, cerca de CheXNet. Y con un conjunto de prueba nueve veces mayor, ResNet18 ya es significativamente el mejor modelo individual, aunque por menos de 0.01. Las conclusiones se sostienen.</a:t>
+              <a:t>Después quise saber qué pasa con todos los datos. Así que repetí todo con las ciento doce mil imágenes, con las mismas reglas; lo único que cambia es la cantidad de datos.
+Mi computadora se apagaba con tanta carga, así que puse la tarjeta gráfica a medio ritmo. Tardó casi cuatro horas, pero sin un solo apagado.
+¿El resultado? Todos mejoran unos cinco puntos. El híbrido es el que más gana, y ahora sí termina de aprender. El ensemble sube a 0.81, muy cerca de los mejores trabajos publicados. Y con tantos datos, ResNet ya se separa como el mejor modelo individual, aunque por muy poquito.</a:t>
             </a:r>
             <a:endParaRPr lang="en-US" dirty="0"/>
           </a:p>
@@ -2086,7 +2111,7 @@
           <a:p>
             <a:r>
               <a:rPr lang="en-US" dirty="0"/>
-              <a:t>Las diferencias entre hallazgos son mucho mayores que entre modelos. Los más fáciles son Emphysema, Edema, Effusion; los más difíciles, Pneumonia, Nodule, Infiltration: lesiones pequeñas como los nódulos o con etiquetas ambiguas como neumonía e infiltración. Todos los modelos siguen el mismo patrón, lo que sugiere que el límite está en los datos y la resolución más que en la arquitectura.</a:t>
+              <a:t>Algo que me pareció muy interesante: la dificultad depende más de la enfermedad que del modelo. Las que son grandes y evidentes, como el edema o el derrame, se detectan bien. Las pequeñas, como los nódulos, les cuestan a todos.</a:t>
             </a:r>
             <a:endParaRPr lang="en-US" dirty="0"/>
           </a:p>
@@ -2174,7 +2199,9 @@
           <a:p>
             <a:r>
               <a:rPr lang="en-US" dirty="0"/>
-              <a:t>El costo es donde los modelos sí se separan. ViT-B/16 tiene 12 veces los parámetros de DenseNet121, y tanto el ViT como el híbrido son unas 13 veces más lentos que ResNet18 en inferencia, sin rendir más. Con desempeño equivalente, ResNet18 es el mejor compromiso individual; si se busca el máximo desempeño, el ensemble, pagando el costo de correr los cuatro. Nota: en ROCm no hay atención eficiente en memoria, así que los modelos con atención salen algo pesimistas.</a:t>
+              <a:t>Y donde sí hay diferencias grandes es en el costo.
+El ViT tiene doce veces más parámetros que DenseNet. Y el ViT y el híbrido son unas trece veces más lentos que ResNet para clasificar, sin dar mejores resultados.
+Si tuviera que elegir uno para la práctica, sería ResNet: rinde igual o mejor, y es el más rápido y ligero.</a:t>
             </a:r>
             <a:endParaRPr lang="en-US" dirty="0"/>
           </a:p>
@@ -2262,7 +2289,10 @@
           <a:p>
             <a:r>
               <a:rPr lang="en-US" dirty="0"/>
-              <a:t>En el derrame pleural, con probabilidades altas, las CNN miran la región torácica correcta. En la infiltración, con probabilidades bajas, los mapas se van a los bordes de la imagen, a la marca de texto 'PORTABLE' o fuera de los pulmones: señal de posibles atajos, un problema conocido en este dataset. Para el ViT, la atención del último bloque sí recorre los campos pulmonares, mientras que el rollout se concentra en las esquinas, un artefacto conocido. Son ejemplos cualitativos, no una medida de localización.</a:t>
+              <a:t>Por último, quise ver dónde miran los modelos. Para eso usé Grad-CAM, que pinta de rojo las zonas que más influyeron en la decisión.
+[Señala el caso de derrame] Cuando hay derrame, los modelos miran justo donde está el problema.
+[Señala el caso de infiltración] Pero en otros casos miran las orillas de la imagen, o una etiqueta de texto que dice "PORTABLE".
+Eso es una alerta: un modelo puede acertar por las razones equivocadas. Que tenga buen puntaje no garantiza que esté viendo lo mismo que vería un médico.</a:t>
             </a:r>
             <a:endParaRPr lang="en-US" dirty="0"/>
           </a:p>

</xml_diff>

<commit_message>
Speech: add F1 and training time, precise pointing cues; row labels on slide 9
- Slide 9: Spanish row labels (Infiltración, Derrame pleural, Atelectasia)
  aligned with the three patients shared by the Grad-CAM and ViT figures,
  plus a caption explaining that column 1 is the original radiograph.
- Speech: F1 sentence (near zero at 0.5, ~0.2 with per-disease thresholds),
  training time (3-5 min per model with 12k, 8-40 with 112k), and specific
  cues for what to point at on each chart (rows, columns, line colors).
  ~885 spoken words (~5.7 min) with an ordered list of what to cut if long.
- Speaker notes regenerated from the guide.

Co-Authored-By: Claude Opus 5.5 <noreply@anthropic.com>
</commit_message>
<xml_diff>
--- a/slides/presentacion_final.pptx
+++ b/slides/presentacion_final.pptx
@@ -116,18 +116,18 @@
   <p:extLst>
     <p:ext uri="{521415D9-36F7-43E2-AB2F-B90AF26B5E84}">
       <p14:sectionLst xmlns:p14="http://schemas.microsoft.com/office/powerpoint/2010/main">
-        <p14:section name="Introducción" id="{2ae58300-2300-6538-5e59-d9a3a104d36f}">
+        <p14:section name="Introducción" id="{327e3bd9-8028-702b-0b42-3e42e3ec5d21}">
           <p14:sldIdLst>
             <p14:sldId id="256"/>
             <p14:sldId id="257"/>
           </p14:sldIdLst>
         </p14:section>
-        <p14:section name="Método" id="{42327332-0fee-d09e-39c0-987d0dd98b7d}">
+        <p14:section name="Método" id="{85c11354-30fb-ff37-c91c-95fcbb1c4c04}">
           <p14:sldIdLst>
             <p14:sldId id="258"/>
           </p14:sldIdLst>
         </p14:section>
-        <p14:section name="Resultados" id="{368152f7-6879-327a-1597-3265ff19e7e1}">
+        <p14:section name="Resultados" id="{4717db54-9007-d8e1-73e9-39768c69d760}">
           <p14:sldIdLst>
             <p14:sldId id="259"/>
             <p14:sldId id="260"/>
@@ -137,7 +137,7 @@
             <p14:sldId id="264"/>
           </p14:sldIdLst>
         </p14:section>
-        <p14:section name="Cierre" id="{15027108-20b5-e88a-17c9-f2e9842ce6a1}">
+        <p14:section name="Cierre" id="{2bc01c35-d537-151b-631d-ff732b816d1f}">
           <p14:sldIdLst>
             <p14:sldId id="265"/>
           </p14:sldIdLst>
@@ -1562,7 +1562,7 @@
               <a:t>Para cerrar, me quedo con tres ideas:
 Uno. Con las mismas reglas, convolucional, Transformer e híbrido rinden casi igual. Con más datos todos mejoran, y ResNet gana por poco.
 Dos. Lo que sí marca la diferencia es combinarlos, y en la práctica, el costo, donde ResNet es el más eficiente.
-Y tres. Medir bien importa tanto como el modelo. Separar por paciente, usar intervalos de confianza y repetir el experimento me evitó sacar conclusiones equivocadas.
+Y tres. Medir bien importa tanto como el modelo. Separar por paciente, usar intervalos de confianza y repetir el experimento evitó conclusiones equivocadas.
 Como siguientes pasos: reentrenar la red completa, aprovechar radiografías sin etiquetas y sumar datos clínicos del paciente.
 [Pausa] Muchas gracias. Quedo atento a sus preguntas.</a:t>
             </a:r>
@@ -1653,7 +1653,7 @@
             <a:r>
               <a:rPr lang="en-US" dirty="0"/>
               <a:t>Trabajé con ChestX-ray14: ciento doce mil radiografías de unos treinta mil pacientes, con catorce posibles hallazgos.
-Y no es un problema fácil, por tres razones:
+Y es difícil por tres razones:
 • Una misma radiografía puede tener varios hallazgos a la vez.
 • Las etiquetas tienen errores, porque salieron automáticamente de los reportes médicos.
 • Hay hallazgos rarísimos. La hernia aparece en apenas dos de cada mil imágenes.
@@ -1745,7 +1745,7 @@
           <a:p>
             <a:r>
               <a:rPr lang="en-US" dirty="0"/>
-              <a:t>Para que la comparación sea justa, los cuatro modelos siguen exactamente las mismas reglas.
+              <a:t>Para que sea justo, los cuatro modelos siguen las mismas reglas.
 Primero, separé las imágenes por paciente: nadie aparece al mismo tiempo en entrenamiento y en prueba. Si no, sería como dejar que el alumno vea el examen antes de presentarlo.
 Los modelos son cuatro:
 • Dos redes convolucionales, DenseNet y ResNet. Miran la imagen con filtros pequeños, como una lupa que recorre la placa.
@@ -1840,10 +1840,11 @@
           <a:p>
             <a:r>
               <a:rPr lang="en-US" dirty="0"/>
-              <a:t>[Señala la tabla] Este es el resultado principal.
+              <a:t>[Señala la tabla completa; las cuatro primeras filas son los modelos y la última, sombreada, el ensemble] Este es el resultado principal.
 Los cuatro modelos quedan muy parejos, entre 0.73 y 0.75 de AUROC, y sus diferencias están dentro del margen de error. De hecho, cuando repetí el experimento, el orden cambió.
-En cambio, el ensemble sí destaca: llega a 0.77 y le gana a todos, con diferencia significativa.
-Y un detalle curioso. [Señala la columna de exactitud] La exactitud es de 95% para todos. Pero un modelo que siempre dice "está sano" también saca 95%. Por eso esa métrica, aquí, no sirve para comparar.</a:t>
+En cambio, el ensemble [señala la última fila] sí destaca: llega a 0.77 y le gana a todos, con diferencia significativa.
+También reporto el F1, que mide si el modelo encuentra los casos sin dar falsas alarmas. Con el umbral típico de 0.5 sale casi en cero, porque el modelo casi nunca se anima a decir "sí"; al ajustar el umbral de cada enfermedad con validación, sube a cerca de 0.2.
+Y un detalle curioso. [Señala la columna "Exactitud", la penúltima: todos los valores son 0.950] La exactitud es de 95% para todos. Pero un modelo que siempre dice "está sano" también saca 95%, así que aquí no sirve para comparar.</a:t>
             </a:r>
             <a:endParaRPr lang="en-US" dirty="0"/>
           </a:p>
@@ -1932,8 +1933,8 @@
             <a:r>
               <a:rPr lang="en-US" dirty="0"/>
               <a:t>¿Por qué funciona el ensemble? Por lo mismo que una segunda opinión médica: cada modelo se equivoca en cosas distintas, y al juntarlos, los errores se compensan.
-¿Y el híbrido? Quedó en último lugar. Pero miren su curva. [Señala la línea amarilla] Todavía estaba aprendiendo cuando se terminó el entrenamiento. Simplemente le faltó tiempo.
-ResNet, en cambio, aprende tan rápido que pronto empieza a memorizar. Por eso siempre uso su mejor momento, no el último.</a:t>
+¿Y el híbrido? Quedó en último lugar. Pero miren su curva. [Señala en la gráfica de la derecha la línea amarilla, "maxvit_t", que sigue bajando hasta la época 5] Todavía estaba aprendiendo cuando se terminó el entrenamiento. Simplemente le faltó tiempo.
+ResNet, en cambio, [señala la línea naranja, "resnet18", que se dispara hacia arriba al final] aprende tan rápido que pronto empieza a memorizar. Por eso siempre uso su mejor momento, no el último.</a:t>
             </a:r>
             <a:endParaRPr lang="en-US" dirty="0"/>
           </a:p>
@@ -2021,9 +2022,9 @@
           <a:p>
             <a:r>
               <a:rPr lang="en-US" dirty="0"/>
-              <a:t>Después quise saber qué pasa con todos los datos. Así que repetí todo con las ciento doce mil imágenes, con las mismas reglas; lo único que cambia es la cantidad de datos.
+              <a:t>Después repetí todo con las ciento doce mil imágenes y las mismas reglas: solo cambia la cantidad de datos.
 Mi computadora se apagaba con tanta carga, así que puse la tarjeta gráfica a medio ritmo. Tardó casi cuatro horas, pero sin un solo apagado.
-¿El resultado? Todos mejoran unos cinco puntos. El híbrido es el que más gana, y ahora sí termina de aprender. El ensemble sube a 0.81, muy cerca de los mejores trabajos publicados. Y con tantos datos, ResNet ya se separa como el mejor modelo individual, aunque por muy poquito.</a:t>
+¿El resultado? [Señala la columna "Cambio": todos alrededor de +0.05] Todos mejoran unos cinco puntos. El híbrido es el que más gana, y ahora sí termina de aprender. El ensemble sube a 0.81, muy cerca de los mejores trabajos publicados. Y ResNet ya se separa como el mejor individual, aunque por muy poquito.</a:t>
             </a:r>
             <a:endParaRPr lang="en-US" dirty="0"/>
           </a:p>
@@ -2111,7 +2112,7 @@
           <a:p>
             <a:r>
               <a:rPr lang="en-US" dirty="0"/>
-              <a:t>Algo que me pareció muy interesante: la dificultad depende más de la enfermedad que del modelo. Las que son grandes y evidentes, como el edema o el derrame, se detectan bien. Las pequeñas, como los nódulos, les cuestan a todos.</a:t>
+              <a:t>Además, la dificultad depende más de la enfermedad que del modelo. Las que son grandes y evidentes, como el edema o el derrame [señala las filas de arriba de la gráfica, "Edema" y "Effusion", con puntos a la derecha], se detectan bien. Las pequeñas, como los nódulos [señala las filas de abajo, "Nodule" e "Infiltration", con puntos más a la izquierda], les cuestan a todos.</a:t>
             </a:r>
             <a:endParaRPr lang="en-US" dirty="0"/>
           </a:p>
@@ -2200,7 +2201,8 @@
             <a:r>
               <a:rPr lang="en-US" dirty="0"/>
               <a:t>Y donde sí hay diferencias grandes es en el costo.
-El ViT tiene doce veces más parámetros que DenseNet. Y el ViT y el híbrido son unas trece veces más lentos que ResNet para clasificar, sin dar mejores resultados.
+El ViT tiene doce veces más parámetros que DenseNet. [Señala la gráfica de la derecha, "Inferencia": la barra naranja de ResNet es la más alta] Y el ViT y el híbrido son unas trece veces más lentos que ResNet para clasificar, sin dar mejores resultados.
+Entrenar cada modelo tomó de tres a cinco minutos con 12 mil imágenes, y de ocho a cuarenta con las 112 mil.
 Si tuviera que elegir uno para la práctica, sería ResNet: rinde igual o mejor, y es el más rápido y ligero.</a:t>
             </a:r>
             <a:endParaRPr lang="en-US" dirty="0"/>
@@ -2290,9 +2292,10 @@
             <a:r>
               <a:rPr lang="en-US" dirty="0"/>
               <a:t>Por último, quise ver dónde miran los modelos. Para eso usé Grad-CAM, que pinta de rojo las zonas que más influyeron en la decisión.
-[Señala el caso de derrame] Cuando hay derrame, los modelos miran justo donde está el problema.
-[Señala el caso de infiltración] Pero en otros casos miran las orillas de la imagen, o una etiqueta de texto que dice "PORTABLE".
-Eso es una alerta: un modelo puede acertar por las razones equivocadas. Que tenga buen puntaje no garantiza que esté viendo lo mismo que vería un médico.</a:t>
+Cada fila es un paciente: [recorre con el dedo la primera fila de izquierda a derecha] primero la radiografía original y luego dónde miró cada modelo.
+[Señala la fila de en medio, la marcada "Derrame pleural" a la izquierda, y en ella las columnas 2 y 3 (DenseNet y ResNet): la mancha roja grande en el centro del tórax] Cuando hay derrame, las redes convolucionales ponen la mancha roja justo donde está el problema.
+[Señala la fila de arriba, "Infiltración": las manchas rojas quedan en los bordes, fuera de los pulmones] Pero aquí miran las orillas de la imagen o la etiqueta de texto "PORTABLE".
+Eso es una alerta: un modelo puede acertar por las razones equivocadas, y un buen puntaje no garantiza que vea lo que vería un médico.</a:t>
             </a:r>
             <a:endParaRPr lang="en-US" dirty="0"/>
           </a:p>
@@ -11568,8 +11571,8 @@
         </p:blipFill>
         <p:spPr>
           <a:xfrm>
-            <a:off x="670560" y="1188720"/>
-            <a:ext cx="6339840" cy="4754880"/>
+            <a:off x="1600200" y="1234440"/>
+            <a:ext cx="5669280" cy="4251960"/>
           </a:xfrm>
           <a:prstGeom prst="rect">
             <a:avLst/>
@@ -11592,8 +11595,8 @@
         </p:blipFill>
         <p:spPr>
           <a:xfrm>
-            <a:off x="7406640" y="1325880"/>
-            <a:ext cx="4480560" cy="4480560"/>
+            <a:off x="7452360" y="1234440"/>
+            <a:ext cx="4251960" cy="4251960"/>
           </a:xfrm>
           <a:prstGeom prst="rect">
             <a:avLst/>
@@ -11602,14 +11605,164 @@
       </p:pic>
       <p:sp>
         <p:nvSpPr>
-          <p:cNvPr id="5" name="Text 1"/>
+          <p:cNvPr id="5" name="fila-1"/>
           <p:cNvSpPr txBox="1"/>
           <p:nvPr/>
         </p:nvSpPr>
         <p:spPr>
           <a:xfrm>
-            <a:off x="365760" y="5989320"/>
-            <a:ext cx="6949440" cy="365760"/>
+            <a:off x="320040" y="1234440"/>
+            <a:ext cx="1234440" cy="1417320"/>
+          </a:xfrm>
+          <a:prstGeom prst="rect">
+            <a:avLst/>
+          </a:prstGeom>
+          <a:noFill/>
+          <a:ln/>
+        </p:spPr>
+        <p:txBody>
+          <a:bodyPr wrap="square" lIns="0" tIns="0" rIns="0" bIns="0" rtlCol="0" anchor="ctr"/>
+          <a:lstStyle/>
+          <a:p>
+            <a:pPr indent="0" marL="0">
+              <a:buNone/>
+            </a:pPr>
+            <a:r>
+              <a:rPr lang="en-US" sz="1500" b="1" dirty="0">
+                <a:solidFill>
+                  <a:schemeClr val="tx1"/>
+                </a:solidFill>
+              </a:rPr>
+              <a:t>Infiltración</a:t>
+            </a:r>
+            <a:endParaRPr lang="en-US" sz="1500" dirty="0"/>
+          </a:p>
+          <a:p>
+            <a:pPr indent="0" marL="0">
+              <a:buNone/>
+            </a:pPr>
+            <a:r>
+              <a:rPr lang="en-US" sz="1100" dirty="0">
+                <a:solidFill>
+                  <a:schemeClr val="accent5"/>
+                </a:solidFill>
+              </a:rPr>
+              <a:t>(Infiltration)</a:t>
+            </a:r>
+            <a:endParaRPr lang="en-US" sz="1500" dirty="0"/>
+          </a:p>
+        </p:txBody>
+      </p:sp>
+      <p:sp>
+        <p:nvSpPr>
+          <p:cNvPr id="6" name="fila-2"/>
+          <p:cNvSpPr txBox="1"/>
+          <p:nvPr/>
+        </p:nvSpPr>
+        <p:spPr>
+          <a:xfrm>
+            <a:off x="320040" y="2651760"/>
+            <a:ext cx="1234440" cy="1417320"/>
+          </a:xfrm>
+          <a:prstGeom prst="rect">
+            <a:avLst/>
+          </a:prstGeom>
+          <a:noFill/>
+          <a:ln/>
+        </p:spPr>
+        <p:txBody>
+          <a:bodyPr wrap="square" lIns="0" tIns="0" rIns="0" bIns="0" rtlCol="0" anchor="ctr"/>
+          <a:lstStyle/>
+          <a:p>
+            <a:pPr indent="0" marL="0">
+              <a:buNone/>
+            </a:pPr>
+            <a:r>
+              <a:rPr lang="en-US" sz="1500" b="1" dirty="0">
+                <a:solidFill>
+                  <a:schemeClr val="tx1"/>
+                </a:solidFill>
+              </a:rPr>
+              <a:t>Derrame pleural</a:t>
+            </a:r>
+            <a:endParaRPr lang="en-US" sz="1500" dirty="0"/>
+          </a:p>
+          <a:p>
+            <a:pPr indent="0" marL="0">
+              <a:buNone/>
+            </a:pPr>
+            <a:r>
+              <a:rPr lang="en-US" sz="1100" dirty="0">
+                <a:solidFill>
+                  <a:schemeClr val="accent5"/>
+                </a:solidFill>
+              </a:rPr>
+              <a:t>(Effusion)</a:t>
+            </a:r>
+            <a:endParaRPr lang="en-US" sz="1500" dirty="0"/>
+          </a:p>
+        </p:txBody>
+      </p:sp>
+      <p:sp>
+        <p:nvSpPr>
+          <p:cNvPr id="7" name="fila-3"/>
+          <p:cNvSpPr txBox="1"/>
+          <p:nvPr/>
+        </p:nvSpPr>
+        <p:spPr>
+          <a:xfrm>
+            <a:off x="320040" y="4069080"/>
+            <a:ext cx="1234440" cy="1417320"/>
+          </a:xfrm>
+          <a:prstGeom prst="rect">
+            <a:avLst/>
+          </a:prstGeom>
+          <a:noFill/>
+          <a:ln/>
+        </p:spPr>
+        <p:txBody>
+          <a:bodyPr wrap="square" lIns="0" tIns="0" rIns="0" bIns="0" rtlCol="0" anchor="ctr"/>
+          <a:lstStyle/>
+          <a:p>
+            <a:pPr indent="0" marL="0">
+              <a:buNone/>
+            </a:pPr>
+            <a:r>
+              <a:rPr lang="en-US" sz="1500" b="1" dirty="0">
+                <a:solidFill>
+                  <a:schemeClr val="tx1"/>
+                </a:solidFill>
+              </a:rPr>
+              <a:t>Atelectasia</a:t>
+            </a:r>
+            <a:endParaRPr lang="en-US" sz="1500" dirty="0"/>
+          </a:p>
+          <a:p>
+            <a:pPr indent="0" marL="0">
+              <a:buNone/>
+            </a:pPr>
+            <a:r>
+              <a:rPr lang="en-US" sz="1100" dirty="0">
+                <a:solidFill>
+                  <a:schemeClr val="accent5"/>
+                </a:solidFill>
+              </a:rPr>
+              <a:t>(Atelectasis)</a:t>
+            </a:r>
+            <a:endParaRPr lang="en-US" sz="1500" dirty="0"/>
+          </a:p>
+        </p:txBody>
+      </p:sp>
+      <p:sp>
+        <p:nvSpPr>
+          <p:cNvPr id="8" name="Text 4"/>
+          <p:cNvSpPr txBox="1"/>
+          <p:nvPr/>
+        </p:nvSpPr>
+        <p:spPr>
+          <a:xfrm>
+            <a:off x="1600200" y="5577840"/>
+            <a:ext cx="5669280" cy="365760"/>
           </a:xfrm>
           <a:prstGeom prst="rect">
             <a:avLst/>
@@ -11625,27 +11778,27 @@
               <a:buNone/>
             </a:pPr>
             <a:r>
-              <a:rPr lang="en-US" sz="1300" dirty="0">
+              <a:rPr lang="en-US" sz="1200" dirty="0">
                 <a:solidFill>
                   <a:schemeClr val="accent5"/>
                 </a:solidFill>
               </a:rPr>
-              <a:t>Grad-CAM: DenseNet121, ResNet18 y MaxViT-T (híbrido), para la clase real</a:t>
+              <a:t>Grad-CAM de DenseNet, ResNet y el híbrido (columna 1: radiografía original)</a:t>
             </a:r>
-            <a:endParaRPr lang="en-US" sz="1300" dirty="0"/>
+            <a:endParaRPr lang="en-US" sz="1200" dirty="0"/>
           </a:p>
         </p:txBody>
       </p:sp>
       <p:sp>
         <p:nvSpPr>
-          <p:cNvPr id="6" name="Text 2"/>
+          <p:cNvPr id="9" name="Text 5"/>
           <p:cNvSpPr txBox="1"/>
           <p:nvPr/>
         </p:nvSpPr>
         <p:spPr>
           <a:xfrm>
-            <a:off x="7406640" y="5989320"/>
-            <a:ext cx="4480560" cy="365760"/>
+            <a:off x="7452360" y="5577840"/>
+            <a:ext cx="4251960" cy="365760"/>
           </a:xfrm>
           <a:prstGeom prst="rect">
             <a:avLst/>
@@ -11661,14 +11814,14 @@
               <a:buNone/>
             </a:pPr>
             <a:r>
-              <a:rPr lang="en-US" sz="1300" dirty="0">
+              <a:rPr lang="en-US" sz="1200" dirty="0">
                 <a:solidFill>
                   <a:schemeClr val="accent5"/>
                 </a:solidFill>
               </a:rPr>
-              <a:t>ViT-B/16: atención del último bloque y rollout</a:t>
+              <a:t>ViT: atención del último bloque y rollout</a:t>
             </a:r>
-            <a:endParaRPr lang="en-US" sz="1300" dirty="0"/>
+            <a:endParaRPr lang="en-US" sz="1200" dirty="0"/>
           </a:p>
         </p:txBody>
       </p:sp>

</xml_diff>

<commit_message>
Speech: final 7-minute version with optional paragraphs
~1042 spoken words (~7 min). Adds motivation, a plain explanation of
confidence intervals, why pneumonia is hard, memory cost, the ViT attention
map, and a brief limitations line; paragraphs marked "(Opcional)" can be
skipped live to get back to ~6 min (920 words). Speaker notes regenerated.

Co-Authored-By: Claude Opus 5.5 <noreply@anthropic.com>
</commit_message>
<xml_diff>
--- a/slides/presentacion_final.pptx
+++ b/slides/presentacion_final.pptx
@@ -116,18 +116,18 @@
   <p:extLst>
     <p:ext uri="{521415D9-36F7-43E2-AB2F-B90AF26B5E84}">
       <p14:sectionLst xmlns:p14="http://schemas.microsoft.com/office/powerpoint/2010/main">
-        <p14:section name="Introducción" id="{327e3bd9-8028-702b-0b42-3e42e3ec5d21}">
+        <p14:section name="Introducción" id="{e92d3aec-c598-4672-61ba-0d6c72eb4f33}">
           <p14:sldIdLst>
             <p14:sldId id="256"/>
             <p14:sldId id="257"/>
           </p14:sldIdLst>
         </p14:section>
-        <p14:section name="Método" id="{85c11354-30fb-ff37-c91c-95fcbb1c4c04}">
+        <p14:section name="Método" id="{dfef0bd7-24b9-c1fe-5221-793aef01a508}">
           <p14:sldIdLst>
             <p14:sldId id="258"/>
           </p14:sldIdLst>
         </p14:section>
-        <p14:section name="Resultados" id="{4717db54-9007-d8e1-73e9-39768c69d760}">
+        <p14:section name="Resultados" id="{5b22fe61-2743-6f92-bc32-a35a72499801}">
           <p14:sldIdLst>
             <p14:sldId id="259"/>
             <p14:sldId id="260"/>
@@ -137,7 +137,7 @@
             <p14:sldId id="264"/>
           </p14:sldIdLst>
         </p14:section>
-        <p14:section name="Cierre" id="{2bc01c35-d537-151b-631d-ff732b816d1f}">
+        <p14:section name="Cierre" id="{c3b5c11c-22ae-ff83-e0af-d9e45cee98fc}">
           <p14:sldIdLst>
             <p14:sldId id="265"/>
           </p14:sldIdLst>
@@ -1563,7 +1563,8 @@
 Uno. Con las mismas reglas, convolucional, Transformer e híbrido rinden casi igual. Con más datos todos mejoran, y ResNet gana por poco.
 Dos. Lo que sí marca la diferencia es combinarlos, y en la práctica, el costo, donde ResNet es el más eficiente.
 Y tres. Medir bien importa tanto como el modelo. Separar por paciente, usar intervalos de confianza y repetir el experimento evitó conclusiones equivocadas.
-Como siguientes pasos: reentrenar la red completa, aprovechar radiografías sin etiquetas y sumar datos clínicos del paciente.
+(Opcional) Claro, el trabajo tiene limitaciones: las etiquetas tienen ruido, usé una sola semilla por corrida y reentrené solo la última parte de cada red.
+Como siguientes pasos: reentrenar la red completa, aprovechar radiografías sin etiquetas y sumar datos clínicos del paciente, como su edad o el texto del reporte.
 [Pausa] Muchas gracias. Quedo atento a sus preguntas.</a:t>
             </a:r>
             <a:endParaRPr lang="en-US" dirty="0"/>
@@ -1652,7 +1653,8 @@
           <a:p>
             <a:r>
               <a:rPr lang="en-US" dirty="0"/>
-              <a:t>Trabajé con ChestX-ray14: ciento doce mil radiografías de unos treinta mil pacientes, con catorce posibles hallazgos.
+              <a:t>¿Por qué importa? Hay muchas más radiografías que radiólogos para leerlas, y un modelo así podría ayudar a atender primero los casos urgentes.
+Trabajé con ChestX-ray14: ciento doce mil radiografías de unos treinta mil pacientes, con catorce posibles hallazgos.
 Y es difícil por tres razones:
 • Una misma radiografía puede tener varios hallazgos a la vez.
 • Las etiquetas tienen errores, porque salieron automáticamente de los reportes médicos.
@@ -1752,7 +1754,8 @@
 • Un Transformer, el ViT. Corta la imagen en cuadritos y los compara todos entre sí.
 • Un híbrido, MaxViT, que combina las dos ideas.
 Ninguno empieza de cero. Todos vienen entrenados con millones de fotos normales, y yo solo reentreno su última parte. Es como contratar a alguien que ya sabe mirar imágenes y enseñarle solamente a leer radiografías. A esto se le llama fine-tuning parcial.
-Y además pruebo un ensemble: juntar a los cuatro modelos y promediar su opinión.</a:t>
+Y además pruebo un ensemble: juntar a los cuatro modelos y promediar su opinión.
+(Opcional) Y para saber si una diferencia es real o es suerte, uso intervalos de confianza: repito la evaluación mil veces con muestras distintas y veo cuánto se mueve el resultado.</a:t>
             </a:r>
             <a:endParaRPr lang="en-US" dirty="0"/>
           </a:p>
@@ -1844,7 +1847,7 @@
 Los cuatro modelos quedan muy parejos, entre 0.73 y 0.75 de AUROC, y sus diferencias están dentro del margen de error. De hecho, cuando repetí el experimento, el orden cambió.
 En cambio, el ensemble [señala la última fila] sí destaca: llega a 0.77 y le gana a todos, con diferencia significativa.
 También reporto el F1, que mide si el modelo encuentra los casos sin dar falsas alarmas. Con el umbral típico de 0.5 sale casi en cero, porque el modelo casi nunca se anima a decir "sí"; al ajustar el umbral de cada enfermedad con validación, sube a cerca de 0.2.
-Y un detalle curioso. [Señala la columna "Exactitud", la penúltima: todos los valores son 0.950] La exactitud es de 95% para todos. Pero un modelo que siempre dice "está sano" también saca 95%, así que aquí no sirve para comparar.</a:t>
+Y un detalle curioso. [Señala la columna "Exactitud", la penúltima: todos los valores son 0.950] La exactitud es de 95% para todos. Suena muy bien, ¿verdad? Pero un modelo que siempre dice "está sano" también saca 95%. Así que aquí no sirve para comparar.</a:t>
             </a:r>
             <a:endParaRPr lang="en-US" dirty="0"/>
           </a:p>
@@ -2024,7 +2027,7 @@
               <a:rPr lang="en-US" dirty="0"/>
               <a:t>Después repetí todo con las ciento doce mil imágenes y las mismas reglas: solo cambia la cantidad de datos.
 Mi computadora se apagaba con tanta carga, así que puse la tarjeta gráfica a medio ritmo. Tardó casi cuatro horas, pero sin un solo apagado.
-¿El resultado? [Señala la columna "Cambio": todos alrededor de +0.05] Todos mejoran unos cinco puntos. El híbrido es el que más gana, y ahora sí termina de aprender. El ensemble sube a 0.81, muy cerca de los mejores trabajos publicados. Y ResNet ya se separa como el mejor individual, aunque por muy poquito.</a:t>
+¿El resultado? [Señala la columna "Cambio": todos alrededor de +0.05] Todos mejoran unos cinco puntos. El híbrido es el que más gana, y ahora sí termina de aprender: confirma que le faltaban datos. El ensemble sube a 0.81, muy cerca de los mejores trabajos publicados. Y ResNet ya se separa como el mejor individual, aunque por muy poquito.</a:t>
             </a:r>
             <a:endParaRPr lang="en-US" dirty="0"/>
           </a:p>
@@ -2112,7 +2115,8 @@
           <a:p>
             <a:r>
               <a:rPr lang="en-US" dirty="0"/>
-              <a:t>Además, la dificultad depende más de la enfermedad que del modelo. Las que son grandes y evidentes, como el edema o el derrame [señala las filas de arriba de la gráfica, "Edema" y "Effusion", con puntos a la derecha], se detectan bien. Las pequeñas, como los nódulos [señala las filas de abajo, "Nodule" e "Infiltration", con puntos más a la izquierda], les cuestan a todos.</a:t>
+              <a:t>Además, la dificultad depende más de la enfermedad que del modelo. Las que son grandes y evidentes, como el edema o el derrame [señala las filas de arriba de la gráfica, "Edema" y "Effusion", con puntos a la derecha], se detectan bien. Las pequeñas, como los nódulos [señala las filas de abajo, "Nodule" e "Infiltration", con puntos más a la izquierda], les cuestan a todos.
+(Opcional) Y la neumonía también cuesta, porque en la radiografía se parece mucho a la infiltración, y hasta las etiquetas las confunden.</a:t>
             </a:r>
             <a:endParaRPr lang="en-US" dirty="0"/>
           </a:p>
@@ -2201,8 +2205,8 @@
             <a:r>
               <a:rPr lang="en-US" dirty="0"/>
               <a:t>Y donde sí hay diferencias grandes es en el costo.
-El ViT tiene doce veces más parámetros que DenseNet. [Señala la gráfica de la derecha, "Inferencia": la barra naranja de ResNet es la más alta] Y el ViT y el híbrido son unas trece veces más lentos que ResNet para clasificar, sin dar mejores resultados.
-Entrenar cada modelo tomó de tres a cinco minutos con 12 mil imágenes, y de ocho a cuarenta con las 112 mil.
+El ViT tiene doce veces más parámetros que DenseNet. [Señala la gráfica de la derecha, "Inferencia": la barra naranja de ResNet es la más alta] Y el ViT y el híbrido son unas trece veces más lentos que ResNet para clasificar, sin dar mejores resultados. En memoria pasa lo mismo: usan entre dos y tres veces más.
+(Opcional) Entrenar cada modelo tomó de tres a cinco minutos con 12 mil imágenes, y de ocho a cuarenta con las 112 mil.
 Si tuviera que elegir uno para la práctica, sería ResNet: rinde igual o mejor, y es el más rápido y ligero.</a:t>
             </a:r>
             <a:endParaRPr lang="en-US" dirty="0"/>
@@ -2294,7 +2298,8 @@
               <a:t>Por último, quise ver dónde miran los modelos. Para eso usé Grad-CAM, que pinta de rojo las zonas que más influyeron en la decisión.
 Cada fila es un paciente: [recorre con el dedo la primera fila de izquierda a derecha] primero la radiografía original y luego dónde miró cada modelo.
 [Señala la fila de en medio, la marcada "Derrame pleural" a la izquierda, y en ella las columnas 2 y 3 (DenseNet y ResNet): la mancha roja grande en el centro del tórax] Cuando hay derrame, las redes convolucionales ponen la mancha roja justo donde está el problema.
-[Señala la fila de arriba, "Infiltración": las manchas rojas quedan en los bordes, fuera de los pulmones] Pero aquí miran las orillas de la imagen o la etiqueta de texto "PORTABLE".
+[Señala la fila de arriba, "Infiltración": las manchas rojas quedan en los bordes, fuera de los pulmones] Pero aquí miran las orillas de la imagen, o la etiqueta de texto que dice "PORTABLE".
+(Opcional) [Señala la figura de la derecha, la del ViT, columna del medio] En el Transformer, el mapa que combina todas sus capas se va a las esquinas de la imagen: estos mapas hay que leerlos con cuidado.
 Eso es una alerta: un modelo puede acertar por las razones equivocadas, y un buen puntaje no garantiza que vea lo que vería un médico.</a:t>
             </a:r>
             <a:endParaRPr lang="en-US" dirty="0"/>

</xml_diff>